<commit_message>
Issue #7: update building card template fields
Map placeholders for address, quarter, gush/parcel, ownership, sivug, built area, damage percent, yeud, planning status, preservation, owner/municipality positions, permit, and enforcement rows.

Keep missing values as -; cap enforcement cell lengths; update action label to ייצוא כרטיס מבנה.

Missing / blocked:

- Building image export (blocked by Issue #8).

- Map preview for building location (blocked by Issue #5).
</commit_message>
<xml_diff>
--- a/project/web-server/backend/Data/BuildingCardTemplate.pptx
+++ b/project/web-server/backend/Data/BuildingCardTemplate.pptx
@@ -21282,7 +21282,7 @@
                 <a:ea typeface="Calibri" panose="020F0502020204030204" pitchFamily="34" charset="0"/>
                 <a:cs typeface="Calibri" panose="020F0502020204030204" pitchFamily="34" charset="0"/>
               </a:rPr>
-              <a:t>עמדת העירייה</a:t>
+              <a:t>עמדת העירייה: {MUNI_POSITION}</a:t>
             </a:r>
           </a:p>
         </p:txBody>
@@ -21330,7 +21330,7 @@
                 <a:ea typeface="Calibri" panose="020F0502020204030204" pitchFamily="34" charset="0"/>
                 <a:cs typeface="Calibri" panose="020F0502020204030204" pitchFamily="34" charset="0"/>
               </a:rPr>
-              <a:t>עמדת הבעלים</a:t>
+              <a:t>עמדת הבעלים: {OWNER_POSITION}</a:t>
             </a:r>
           </a:p>
           <a:p>
@@ -21487,7 +21487,7 @@
                 <a:ea typeface="Calibri" panose="020F0502020204030204" pitchFamily="34" charset="0"/>
                 <a:cs typeface="Calibri" panose="020F0502020204030204" pitchFamily="34" charset="0"/>
               </a:rPr>
-              <a:t>..</a:t>
+              <a:t>{YEUD}</a:t>
             </a:r>
           </a:p>
           <a:p>
@@ -21501,7 +21501,7 @@
                 <a:ea typeface="Calibri" panose="020F0502020204030204" pitchFamily="34" charset="0"/>
                 <a:cs typeface="Calibri" panose="020F0502020204030204" pitchFamily="34" charset="0"/>
               </a:rPr>
-              <a:t>..</a:t>
+              <a:t/>
             </a:r>
           </a:p>
         </p:txBody>
@@ -21551,7 +21551,7 @@
                 <a:ea typeface="Calibri" panose="020F0502020204030204" pitchFamily="34" charset="0"/>
                 <a:cs typeface="Calibri" panose="020F0502020204030204" pitchFamily="34" charset="0"/>
               </a:rPr>
-              <a:t>גוש 10864 חלקה 173</a:t>
+              <a:t>גוש {GUSH_M} חלקה {PARCEL_M}</a:t>
             </a:r>
           </a:p>
         </p:txBody>
@@ -21599,7 +21599,7 @@
                 <a:ea typeface="Calibri" panose="020F0502020204030204" pitchFamily="34" charset="0"/>
                 <a:cs typeface="Calibri" panose="020F0502020204030204" pitchFamily="34" charset="0"/>
               </a:rPr>
-              <a:t>סטטוס</a:t>
+              <a:t>סיווג: {SIVUG}</a:t>
             </a:r>
           </a:p>
           <a:p>
@@ -21654,7 +21654,7 @@
                 <a:ea typeface="Calibri" panose="020F0502020204030204" pitchFamily="34" charset="0"/>
                 <a:cs typeface="Calibri" panose="020F0502020204030204" pitchFamily="34" charset="0"/>
               </a:rPr>
-              <a:t>בעלות: פרטית </a:t>
+              <a:t>בעלות: {OWNERSHIP_TYPE} - {OWNER_DETAILS}</a:t>
             </a:r>
             <a:r>
               <a:rPr lang="he-IL" sz="1400" dirty="0">
@@ -21665,7 +21665,7 @@
                 <a:ea typeface="Calibri" panose="020F0502020204030204" pitchFamily="34" charset="0"/>
                 <a:cs typeface="Calibri" panose="020F0502020204030204" pitchFamily="34" charset="0"/>
               </a:rPr>
-              <a:t>___שם הבעלים________</a:t>
+              <a:t/>
             </a:r>
           </a:p>
         </p:txBody>
@@ -21728,7 +21728,7 @@
                 <a:ea typeface="Calibri" panose="020F0502020204030204" pitchFamily="34" charset="0"/>
                 <a:cs typeface="Calibri" panose="020F0502020204030204" pitchFamily="34" charset="0"/>
               </a:rPr>
-              <a:t>6</a:t>
+              <a:t>{QUARTER}</a:t>
             </a:r>
           </a:p>
         </p:txBody>
@@ -22160,7 +22160,7 @@
                           <a:ea typeface="Calibri" panose="020F0502020204030204" pitchFamily="34" charset="0"/>
                           <a:cs typeface="Calibri" panose="020F0502020204030204" pitchFamily="34" charset="0"/>
                         </a:rPr>
-                        <a:t>X</a:t>
+                        <a:t>{PIKUACH_KLALI}</a:t>
                       </a:r>
                       <a:endParaRPr lang="he-IL" sz="2400" dirty="0">
                         <a:latin typeface="Calibri" panose="020F0502020204030204" pitchFamily="34" charset="0"/>
@@ -22226,7 +22226,7 @@
                           <a:ea typeface="Calibri" panose="020F0502020204030204" pitchFamily="34" charset="0"/>
                           <a:cs typeface="Calibri" panose="020F0502020204030204" pitchFamily="34" charset="0"/>
                         </a:rPr>
-                        <a:t>X</a:t>
+                        <a:t>{PIKUACH_AL_BNIYA}</a:t>
                       </a:r>
                       <a:endParaRPr lang="he-IL" sz="2400" kern="1200" dirty="0">
                         <a:solidFill>
@@ -22295,7 +22295,7 @@
                           <a:ea typeface="Calibri" panose="020F0502020204030204" pitchFamily="34" charset="0"/>
                           <a:cs typeface="Calibri" panose="020F0502020204030204" pitchFamily="34" charset="0"/>
                         </a:rPr>
-                        <a:t>X</a:t>
+                        <a:t>{TZAV_SHIPUTZ_FRONTS}</a:t>
                       </a:r>
                       <a:endParaRPr lang="he-IL" sz="2400" kern="1200" dirty="0">
                         <a:solidFill>
@@ -22506,7 +22506,7 @@
                 <a:ea typeface="Calibri" panose="020F0502020204030204" pitchFamily="34" charset="0"/>
                 <a:cs typeface="Calibri" panose="020F0502020204030204" pitchFamily="34" charset="0"/>
               </a:rPr>
-              <a:t>..</a:t>
+              <a:t>{KIDUM_TICHNUN}</a:t>
             </a:r>
           </a:p>
           <a:p>
@@ -22520,7 +22520,7 @@
                 <a:ea typeface="Calibri" panose="020F0502020204030204" pitchFamily="34" charset="0"/>
                 <a:cs typeface="Calibri" panose="020F0502020204030204" pitchFamily="34" charset="0"/>
               </a:rPr>
-              <a:t>..</a:t>
+              <a:t/>
             </a:r>
           </a:p>
         </p:txBody>
@@ -22585,7 +22585,7 @@
                 <a:ea typeface="Calibri" panose="020F0502020204030204" pitchFamily="34" charset="0"/>
                 <a:cs typeface="Calibri" panose="020F0502020204030204" pitchFamily="34" charset="0"/>
               </a:rPr>
-              <a:t>..</a:t>
+              <a:t>{SHIMUR_YEUD}</a:t>
             </a:r>
           </a:p>
           <a:p>
@@ -22599,7 +22599,7 @@
                 <a:ea typeface="Calibri" panose="020F0502020204030204" pitchFamily="34" charset="0"/>
                 <a:cs typeface="Calibri" panose="020F0502020204030204" pitchFamily="34" charset="0"/>
               </a:rPr>
-              <a:t>..</a:t>
+              <a:t/>
             </a:r>
           </a:p>
         </p:txBody>
@@ -22664,7 +22664,7 @@
                 <a:ea typeface="Calibri" panose="020F0502020204030204" pitchFamily="34" charset="0"/>
                 <a:cs typeface="Calibri" panose="020F0502020204030204" pitchFamily="34" charset="0"/>
               </a:rPr>
-              <a:t>..</a:t>
+              <a:t>{BUILDING_PERMIT}</a:t>
             </a:r>
           </a:p>
           <a:p>
@@ -22678,7 +22678,7 @@
                 <a:ea typeface="Calibri" panose="020F0502020204030204" pitchFamily="34" charset="0"/>
                 <a:cs typeface="Calibri" panose="020F0502020204030204" pitchFamily="34" charset="0"/>
               </a:rPr>
-              <a:t>..</a:t>
+              <a:t/>
             </a:r>
           </a:p>
         </p:txBody>
@@ -22777,7 +22777,7 @@
                 <a:ea typeface="Calibri" panose="020F0502020204030204" pitchFamily="34" charset="0"/>
                 <a:cs typeface="Calibri" panose="020F0502020204030204" pitchFamily="34" charset="0"/>
               </a:rPr>
-              <a:t>1,386 </a:t>
+              <a:t>{BUILT_AREA_SQM}</a:t>
             </a:r>
           </a:p>
           <a:p>
@@ -22888,7 +22888,7 @@
                 <a:ea typeface="Calibri" panose="020F0502020204030204" pitchFamily="34" charset="0"/>
                 <a:cs typeface="Calibri" panose="020F0502020204030204" pitchFamily="34" charset="0"/>
               </a:rPr>
-              <a:t>87% </a:t>
+              <a:t>{DAMAGE_PERCENT}</a:t>
             </a:r>
           </a:p>
           <a:p>

</xml_diff>

<commit_message>
Issue #7: fix card export image sizing and template cleanup; align add/edit image UI + prevent auto-save; add close button; set JPEG quality 100
</commit_message>
<xml_diff>
--- a/project/web-server/backend/Data/BuildingCardTemplate.pptx
+++ b/project/web-server/backend/Data/BuildingCardTemplate.pptx
@@ -130,6 +130,14 @@
 </p:cmAuthorLst>
 </file>
 
+<file path=ppt/revisionInfo.xml><?xml version="1.0" encoding="utf-8"?>
+<p1510:revInfo xmlns:a="http://schemas.openxmlformats.org/drawingml/2006/main" xmlns:r="http://schemas.openxmlformats.org/officeDocument/2006/relationships" xmlns:p1510="http://schemas.microsoft.com/office/powerpoint/2015/10/main">
+  <p1510:revLst>
+    <p1510:client id="{AF317526-C38C-4153-9F5B-986387788569}" v="1" dt="2026-01-22T13:55:06.673"/>
+  </p1510:revLst>
+</p1510:revInfo>
+</file>
+
 <file path=ppt/changesInfos/changesInfo1.xml><?xml version="1.0" encoding="utf-8"?>
 <pc:chgInfo xmlns:a="http://schemas.openxmlformats.org/drawingml/2006/main" xmlns:r="http://schemas.openxmlformats.org/officeDocument/2006/relationships" xmlns:ac="http://schemas.microsoft.com/office/drawing/2013/main/command" xmlns:pc="http://schemas.microsoft.com/office/powerpoint/2013/main/command">
   <pc:docChgLst>
@@ -153,6 +161,38 @@
             <ac:spMk id="28" creationId="{2576C175-3BF1-9365-5DE4-6A895245D818}"/>
           </ac:spMkLst>
         </pc:spChg>
+      </pc:sldChg>
+    </pc:docChg>
+  </pc:docChgLst>
+  <pc:docChgLst>
+    <pc:chgData name="Kareem Araide" userId="de348250dbb8bac6" providerId="LiveId" clId="{65F28107-F77A-404E-ADBF-4CBF28DF91CB}"/>
+    <pc:docChg chg="custSel modSld">
+      <pc:chgData name="Kareem Araide" userId="de348250dbb8bac6" providerId="LiveId" clId="{65F28107-F77A-404E-ADBF-4CBF28DF91CB}" dt="2026-01-22T13:55:44.701" v="13" actId="1076"/>
+      <pc:docMkLst>
+        <pc:docMk/>
+      </pc:docMkLst>
+      <pc:sldChg chg="addSp delSp modSp mod">
+        <pc:chgData name="Kareem Araide" userId="de348250dbb8bac6" providerId="LiveId" clId="{65F28107-F77A-404E-ADBF-4CBF28DF91CB}" dt="2026-01-22T13:55:44.701" v="13" actId="1076"/>
+        <pc:sldMkLst>
+          <pc:docMk/>
+          <pc:sldMk cId="2354692379" sldId="747"/>
+        </pc:sldMkLst>
+        <pc:picChg chg="add mod">
+          <ac:chgData name="Kareem Araide" userId="de348250dbb8bac6" providerId="LiveId" clId="{65F28107-F77A-404E-ADBF-4CBF28DF91CB}" dt="2026-01-22T13:55:44.701" v="13" actId="1076"/>
+          <ac:picMkLst>
+            <pc:docMk/>
+            <pc:sldMk cId="2354692379" sldId="747"/>
+            <ac:picMk id="5" creationId="{EA0E0737-9A13-3187-0B8F-64280260EE8B}"/>
+          </ac:picMkLst>
+        </pc:picChg>
+        <pc:picChg chg="del">
+          <ac:chgData name="Kareem Araide" userId="de348250dbb8bac6" providerId="LiveId" clId="{65F28107-F77A-404E-ADBF-4CBF28DF91CB}" dt="2026-01-22T13:55:32.753" v="4" actId="478"/>
+          <ac:picMkLst>
+            <pc:docMk/>
+            <pc:sldMk cId="2354692379" sldId="747"/>
+            <ac:picMk id="29" creationId="{00000000-0000-0000-0000-000000000000}"/>
+          </ac:picMkLst>
+        </pc:picChg>
       </pc:sldChg>
     </pc:docChg>
   </pc:docChgLst>
@@ -246,7 +286,7 @@
             <a:fld id="{2235085D-1097-4D16-8C89-046FBDEE899B}" type="datetimeFigureOut">
               <a:rPr lang="he-IL" smtClean="0"/>
               <a:pPr/>
-              <a:t>כ"ד/טבת/תשפ"ו</a:t>
+              <a:t>ד'/שבט/תשפ"ו</a:t>
             </a:fld>
             <a:endParaRPr lang="he-IL" dirty="0"/>
           </a:p>
@@ -9320,7 +9360,7 @@
             <a:fld id="{06D97635-68D3-4231-B6D3-E01CF285EE9C}" type="datetime8">
               <a:rPr lang="he-IL" smtClean="0"/>
               <a:pPr/>
-              <a:t>13 ינואר 26</a:t>
+              <a:t>22 ינואר 26</a:t>
             </a:fld>
             <a:endParaRPr lang="he-IL"/>
           </a:p>
@@ -9548,7 +9588,7 @@
           <a:p>
             <a:fld id="{BD92C3CD-2DD7-4739-91FD-190E7B42CACD}" type="datetime8">
               <a:rPr lang="he-IL" smtClean="0"/>
-              <a:t>13 ינואר 26</a:t>
+              <a:t>22 ינואר 26</a:t>
             </a:fld>
             <a:endParaRPr lang="he-IL"/>
           </a:p>
@@ -9734,7 +9774,7 @@
           <a:p>
             <a:fld id="{FD4BFC87-1F72-462A-BCEA-1A814EAC5254}" type="datetime8">
               <a:rPr lang="he-IL" smtClean="0"/>
-              <a:t>13 ינואר 26</a:t>
+              <a:t>22 ינואר 26</a:t>
             </a:fld>
             <a:endParaRPr lang="he-IL"/>
           </a:p>
@@ -9987,7 +10027,7 @@
             <a:fld id="{8D7207FB-0423-4EBC-BC71-093AC5750AD0}" type="datetime8">
               <a:rPr lang="he-IL" smtClean="0"/>
               <a:pPr/>
-              <a:t>13 ינואר 26</a:t>
+              <a:t>22 ינואר 26</a:t>
             </a:fld>
             <a:endParaRPr lang="he-IL"/>
           </a:p>
@@ -18772,7 +18812,7 @@
           <a:p>
             <a:fld id="{5BB1EDE2-E23E-4D45-97E7-8B22884C3954}" type="datetime8">
               <a:rPr lang="he-IL" smtClean="0"/>
-              <a:t>13 ינואר 26</a:t>
+              <a:t>22 ינואר 26</a:t>
             </a:fld>
             <a:endParaRPr lang="he-IL"/>
           </a:p>
@@ -19052,7 +19092,7 @@
           <a:p>
             <a:fld id="{A87D2518-068A-4B4E-9411-11F0D777D01C}" type="datetime8">
               <a:rPr lang="he-IL" smtClean="0"/>
-              <a:t>13 ינואר 26</a:t>
+              <a:t>22 ינואר 26</a:t>
             </a:fld>
             <a:endParaRPr lang="he-IL"/>
           </a:p>
@@ -19530,7 +19570,7 @@
             <a:fld id="{0F1C5475-1302-4305-92B3-B5D3D4D128BD}" type="datetime8">
               <a:rPr lang="he-IL" smtClean="0"/>
               <a:pPr/>
-              <a:t>13 ינואר 26</a:t>
+              <a:t>22 ינואר 26</a:t>
             </a:fld>
             <a:endParaRPr lang="he-IL"/>
           </a:p>
@@ -19680,7 +19720,7 @@
             <a:fld id="{98EE1D82-A631-49C7-A4BC-CF56C1A36EBF}" type="datetime8">
               <a:rPr lang="he-IL" smtClean="0"/>
               <a:pPr/>
-              <a:t>13 ינואר 26</a:t>
+              <a:t>22 ינואר 26</a:t>
             </a:fld>
             <a:endParaRPr lang="he-IL"/>
           </a:p>
@@ -19790,7 +19830,7 @@
           <a:p>
             <a:fld id="{0EB353D4-AB26-4510-80F0-851F863F6D73}" type="datetime8">
               <a:rPr lang="he-IL" smtClean="0"/>
-              <a:t>13 ינואר 26</a:t>
+              <a:t>22 ינואר 26</a:t>
             </a:fld>
             <a:endParaRPr lang="he-IL"/>
           </a:p>
@@ -20080,7 +20120,7 @@
           <a:p>
             <a:fld id="{813B2F0F-C3DA-4E52-B4E3-B2BD22748E6D}" type="datetime8">
               <a:rPr lang="he-IL" smtClean="0"/>
-              <a:t>13 ינואר 26</a:t>
+              <a:t>22 ינואר 26</a:t>
             </a:fld>
             <a:endParaRPr lang="he-IL"/>
           </a:p>
@@ -20360,7 +20400,7 @@
           <a:p>
             <a:fld id="{85CCD77F-7A8D-4C44-9CE3-16F0C0070A60}" type="datetime8">
               <a:rPr lang="he-IL" smtClean="0"/>
-              <a:t>13 ינואר 26</a:t>
+              <a:t>22 ינואר 26</a:t>
             </a:fld>
             <a:endParaRPr lang="he-IL"/>
           </a:p>
@@ -20617,7 +20657,7 @@
             <a:fld id="{864DF5F2-D2BF-431E-BFF9-A44526EEADB6}" type="datetime8">
               <a:rPr lang="he-IL" smtClean="0"/>
               <a:pPr/>
-              <a:t>13 ינואר 26</a:t>
+              <a:t>22 ינואר 26</a:t>
             </a:fld>
             <a:endParaRPr lang="he-IL"/>
           </a:p>
@@ -21108,7 +21148,7 @@
 </file>
 
 <file path=ppt/slides/slide1.xml><?xml version="1.0" encoding="utf-8"?>
-<p:sld xmlns:a="http://schemas.openxmlformats.org/drawingml/2006/main" xmlns:ns2="http://schemas.openxmlformats.org/officeDocument/2006/relationships" xmlns:ns3="http://schemas.microsoft.com/office/drawing/2014/main" xmlns:ns4="http://schemas.microsoft.com/office/powerpoint/2010/main" xmlns:ns5="http://schemas.microsoft.com/office/drawing/2010/main" xmlns:p="http://schemas.openxmlformats.org/presentationml/2006/main">
+<p:sld xmlns:a="http://schemas.openxmlformats.org/drawingml/2006/main" xmlns:r="http://schemas.openxmlformats.org/officeDocument/2006/relationships" xmlns:p="http://schemas.openxmlformats.org/presentationml/2006/main">
   <p:cSld>
     <p:spTree>
       <p:nvGrpSpPr>
@@ -21133,7 +21173,7 @@
           <p:nvPr/>
         </p:nvPicPr>
         <p:blipFill rotWithShape="1">
-          <a:blip ns2:embed="rId2"/>
+          <a:blip r:embed="rId2"/>
           <a:srcRect r="10124"/>
           <a:stretch/>
         </p:blipFill>
@@ -21244,7 +21284,7 @@
           <p:cNvPr id="17" name="תיבת טקסט 9">
             <a:extLst>
               <a:ext uri="{FF2B5EF4-FFF2-40B4-BE49-F238E27FC236}">
-                <ns3:creationId id="{2576C175-3BF1-9365-5DE4-6A895245D818}"/>
+                <a16:creationId xmlns:a16="http://schemas.microsoft.com/office/drawing/2014/main" id="{2576C175-3BF1-9365-5DE4-6A895245D818}"/>
               </a:ext>
             </a:extLst>
           </p:cNvPr>
@@ -21292,7 +21332,7 @@
           <p:cNvPr id="18" name="תיבת טקסט 9">
             <a:extLst>
               <a:ext uri="{FF2B5EF4-FFF2-40B4-BE49-F238E27FC236}">
-                <ns3:creationId id="{2576C175-3BF1-9365-5DE4-6A895245D818}"/>
+                <a16:creationId xmlns:a16="http://schemas.microsoft.com/office/drawing/2014/main" id="{2576C175-3BF1-9365-5DE4-6A895245D818}"/>
               </a:ext>
             </a:extLst>
           </p:cNvPr>
@@ -21384,7 +21424,7 @@
           <p:cNvPr id="19" name="תיבת טקסט 9">
             <a:extLst>
               <a:ext uri="{FF2B5EF4-FFF2-40B4-BE49-F238E27FC236}">
-                <ns3:creationId id="{2576C175-3BF1-9365-5DE4-6A895245D818}"/>
+                <a16:creationId xmlns:a16="http://schemas.microsoft.com/office/drawing/2014/main" id="{2576C175-3BF1-9365-5DE4-6A895245D818}"/>
               </a:ext>
             </a:extLst>
           </p:cNvPr>
@@ -21432,7 +21472,7 @@
           <p:cNvPr id="20" name="תיבת טקסט 9">
             <a:extLst>
               <a:ext uri="{FF2B5EF4-FFF2-40B4-BE49-F238E27FC236}">
-                <ns3:creationId id="{2576C175-3BF1-9365-5DE4-6A895245D818}"/>
+                <a16:creationId xmlns:a16="http://schemas.microsoft.com/office/drawing/2014/main" id="{2576C175-3BF1-9365-5DE4-6A895245D818}"/>
               </a:ext>
             </a:extLst>
           </p:cNvPr>
@@ -21492,17 +21532,14 @@
           </a:p>
           <a:p>
             <a:pPr algn="r" rtl="1"/>
-            <a:r>
-              <a:rPr lang="he-IL" sz="1400" dirty="0">
-                <a:solidFill>
-                  <a:srgbClr val="305250"/>
-                </a:solidFill>
-                <a:latin typeface="Calibri" panose="020F0502020204030204" pitchFamily="34" charset="0"/>
-                <a:ea typeface="Calibri" panose="020F0502020204030204" pitchFamily="34" charset="0"/>
-                <a:cs typeface="Calibri" panose="020F0502020204030204" pitchFamily="34" charset="0"/>
-              </a:rPr>
-              <a:t/>
-            </a:r>
+            <a:endParaRPr lang="he-IL" sz="1400" dirty="0">
+              <a:solidFill>
+                <a:srgbClr val="305250"/>
+              </a:solidFill>
+              <a:latin typeface="Calibri" panose="020F0502020204030204" pitchFamily="34" charset="0"/>
+              <a:ea typeface="Calibri" panose="020F0502020204030204" pitchFamily="34" charset="0"/>
+              <a:cs typeface="Calibri" panose="020F0502020204030204" pitchFamily="34" charset="0"/>
+            </a:endParaRPr>
           </a:p>
         </p:txBody>
       </p:sp>
@@ -21511,7 +21548,7 @@
           <p:cNvPr id="21" name="תיבת טקסט 9">
             <a:extLst>
               <a:ext uri="{FF2B5EF4-FFF2-40B4-BE49-F238E27FC236}">
-                <ns3:creationId id="{2576C175-3BF1-9365-5DE4-6A895245D818}"/>
+                <a16:creationId xmlns:a16="http://schemas.microsoft.com/office/drawing/2014/main" id="{2576C175-3BF1-9365-5DE4-6A895245D818}"/>
               </a:ext>
             </a:extLst>
           </p:cNvPr>
@@ -21561,7 +21598,7 @@
           <p:cNvPr id="23" name="תיבת טקסט 9">
             <a:extLst>
               <a:ext uri="{FF2B5EF4-FFF2-40B4-BE49-F238E27FC236}">
-                <ns3:creationId id="{2576C175-3BF1-9365-5DE4-6A895245D818}"/>
+                <a16:creationId xmlns:a16="http://schemas.microsoft.com/office/drawing/2014/main" id="{2576C175-3BF1-9365-5DE4-6A895245D818}"/>
               </a:ext>
             </a:extLst>
           </p:cNvPr>
@@ -21656,17 +21693,6 @@
               </a:rPr>
               <a:t>בעלות: {OWNERSHIP_TYPE} - {OWNER_DETAILS}</a:t>
             </a:r>
-            <a:r>
-              <a:rPr lang="he-IL" sz="1400" dirty="0">
-                <a:solidFill>
-                  <a:srgbClr val="305250"/>
-                </a:solidFill>
-                <a:latin typeface="Calibri" panose="020F0502020204030204" pitchFamily="34" charset="0"/>
-                <a:ea typeface="Calibri" panose="020F0502020204030204" pitchFamily="34" charset="0"/>
-                <a:cs typeface="Calibri" panose="020F0502020204030204" pitchFamily="34" charset="0"/>
-              </a:rPr>
-              <a:t/>
-            </a:r>
           </a:p>
         </p:txBody>
       </p:sp>
@@ -21742,14 +21768,14 @@
           <p:nvPr>
             <p:extLst>
               <p:ext uri="{D42A27DB-BD31-4B8C-83A1-F6EECF244321}">
-                <ns4:modId val="1855143216"/>
+                <p14:modId xmlns:p14="http://schemas.microsoft.com/office/powerpoint/2010/main" val="1855143216"/>
               </p:ext>
             </p:extLst>
           </p:nvPr>
         </p:nvGraphicFramePr>
         <p:xfrm>
           <a:off x="2732739" y="3307190"/>
-          <a:ext cx="9468046" cy="828040"/>
+          <a:ext cx="9468046" cy="1193800"/>
         </p:xfrm>
         <a:graphic>
           <a:graphicData uri="http://schemas.openxmlformats.org/drawingml/2006/table">
@@ -21761,35 +21787,35 @@
                 <a:gridCol w="2284730">
                   <a:extLst>
                     <a:ext uri="{9D8B030D-6E8A-4147-A177-3AD203B41FA5}">
-                      <ns3:colId val="720534580"/>
+                      <a16:colId xmlns:a16="http://schemas.microsoft.com/office/drawing/2014/main" val="720534580"/>
                     </a:ext>
                   </a:extLst>
                 </a:gridCol>
                 <a:gridCol w="1638944">
                   <a:extLst>
                     <a:ext uri="{9D8B030D-6E8A-4147-A177-3AD203B41FA5}">
-                      <ns3:colId val="3385606801"/>
+                      <a16:colId xmlns:a16="http://schemas.microsoft.com/office/drawing/2014/main" val="3385606801"/>
                     </a:ext>
                   </a:extLst>
                 </a:gridCol>
                 <a:gridCol w="1824722">
                   <a:extLst>
                     <a:ext uri="{9D8B030D-6E8A-4147-A177-3AD203B41FA5}">
-                      <ns3:colId val="1287329000"/>
+                      <a16:colId xmlns:a16="http://schemas.microsoft.com/office/drawing/2014/main" val="1287329000"/>
                     </a:ext>
                   </a:extLst>
                 </a:gridCol>
                 <a:gridCol w="1824722">
                   <a:extLst>
                     <a:ext uri="{9D8B030D-6E8A-4147-A177-3AD203B41FA5}">
-                      <ns3:colId val="3932464124"/>
+                      <a16:colId xmlns:a16="http://schemas.microsoft.com/office/drawing/2014/main" val="3932464124"/>
                     </a:ext>
                   </a:extLst>
                 </a:gridCol>
                 <a:gridCol w="1894928">
                   <a:extLst>
                     <a:ext uri="{9D8B030D-6E8A-4147-A177-3AD203B41FA5}">
-                      <ns3:colId val="483288508"/>
+                      <a16:colId xmlns:a16="http://schemas.microsoft.com/office/drawing/2014/main" val="483288508"/>
                     </a:ext>
                   </a:extLst>
                 </a:gridCol>
@@ -22087,7 +22113,7 @@
                 </a:tc>
                 <a:extLst>
                   <a:ext uri="{0D108BD9-81ED-4DB2-BD59-A6C34878D82A}">
-                    <ns3:rowId val="1032947799"/>
+                    <a16:rowId xmlns:a16="http://schemas.microsoft.com/office/drawing/2014/main" val="1032947799"/>
                   </a:ext>
                 </a:extLst>
               </a:tr>
@@ -22409,7 +22435,7 @@
                 </a:tc>
                 <a:extLst>
                   <a:ext uri="{0D108BD9-81ED-4DB2-BD59-A6C34878D82A}">
-                    <ns3:rowId val="4286580349"/>
+                    <a16:rowId xmlns:a16="http://schemas.microsoft.com/office/drawing/2014/main" val="4286580349"/>
                   </a:ext>
                 </a:extLst>
               </a:tr>
@@ -22417,41 +22443,12 @@
           </a:graphicData>
         </a:graphic>
       </p:graphicFrame>
-      <p:pic>
-        <p:nvPicPr>
-          <p:cNvPr id="29" name="תמונה 28"/>
-          <p:cNvPicPr>
-            <a:picLocks noChangeAspect="1"/>
-          </p:cNvPicPr>
-          <p:nvPr/>
-        </p:nvPicPr>
-        <p:blipFill rotWithShape="1">
-          <a:blip ns2:embed="rId3" cstate="print">
-            <a:extLst>
-              <a:ext uri="{28A0092B-C50C-407E-A947-70E740481C1C}">
-                <ns5:useLocalDpi val="0"/>
-              </a:ext>
-            </a:extLst>
-          </a:blip>
-          <a:srcRect l="30712" r="13481"/>
-          <a:stretch/>
-        </p:blipFill>
-        <p:spPr>
-          <a:xfrm>
-            <a:off x="-8965" y="-1"/>
-            <a:ext cx="3065930" cy="4120370"/>
-          </a:xfrm>
-          <a:prstGeom prst="rect">
-            <a:avLst/>
-          </a:prstGeom>
-        </p:spPr>
-      </p:pic>
       <p:sp>
         <p:nvSpPr>
           <p:cNvPr id="33" name="תיבת טקסט 9">
             <a:extLst>
               <a:ext uri="{FF2B5EF4-FFF2-40B4-BE49-F238E27FC236}">
-                <ns3:creationId id="{2576C175-3BF1-9365-5DE4-6A895245D818}"/>
+                <a16:creationId xmlns:a16="http://schemas.microsoft.com/office/drawing/2014/main" id="{2576C175-3BF1-9365-5DE4-6A895245D818}"/>
               </a:ext>
             </a:extLst>
           </p:cNvPr>
@@ -22511,17 +22508,14 @@
           </a:p>
           <a:p>
             <a:pPr algn="r" rtl="1"/>
-            <a:r>
-              <a:rPr lang="he-IL" sz="1400" dirty="0">
-                <a:solidFill>
-                  <a:srgbClr val="305250"/>
-                </a:solidFill>
-                <a:latin typeface="Calibri" panose="020F0502020204030204" pitchFamily="34" charset="0"/>
-                <a:ea typeface="Calibri" panose="020F0502020204030204" pitchFamily="34" charset="0"/>
-                <a:cs typeface="Calibri" panose="020F0502020204030204" pitchFamily="34" charset="0"/>
-              </a:rPr>
-              <a:t/>
-            </a:r>
+            <a:endParaRPr lang="he-IL" sz="1400" dirty="0">
+              <a:solidFill>
+                <a:srgbClr val="305250"/>
+              </a:solidFill>
+              <a:latin typeface="Calibri" panose="020F0502020204030204" pitchFamily="34" charset="0"/>
+              <a:ea typeface="Calibri" panose="020F0502020204030204" pitchFamily="34" charset="0"/>
+              <a:cs typeface="Calibri" panose="020F0502020204030204" pitchFamily="34" charset="0"/>
+            </a:endParaRPr>
           </a:p>
         </p:txBody>
       </p:sp>
@@ -22530,7 +22524,7 @@
           <p:cNvPr id="22" name="תיבת טקסט 9">
             <a:extLst>
               <a:ext uri="{FF2B5EF4-FFF2-40B4-BE49-F238E27FC236}">
-                <ns3:creationId id="{2576C175-3BF1-9365-5DE4-6A895245D818}"/>
+                <a16:creationId xmlns:a16="http://schemas.microsoft.com/office/drawing/2014/main" id="{2576C175-3BF1-9365-5DE4-6A895245D818}"/>
               </a:ext>
             </a:extLst>
           </p:cNvPr>
@@ -22590,17 +22584,14 @@
           </a:p>
           <a:p>
             <a:pPr algn="r" rtl="1"/>
-            <a:r>
-              <a:rPr lang="he-IL" sz="1400" dirty="0">
-                <a:solidFill>
-                  <a:srgbClr val="305250"/>
-                </a:solidFill>
-                <a:latin typeface="Calibri" panose="020F0502020204030204" pitchFamily="34" charset="0"/>
-                <a:ea typeface="Calibri" panose="020F0502020204030204" pitchFamily="34" charset="0"/>
-                <a:cs typeface="Calibri" panose="020F0502020204030204" pitchFamily="34" charset="0"/>
-              </a:rPr>
-              <a:t/>
-            </a:r>
+            <a:endParaRPr lang="he-IL" sz="1400" dirty="0">
+              <a:solidFill>
+                <a:srgbClr val="305250"/>
+              </a:solidFill>
+              <a:latin typeface="Calibri" panose="020F0502020204030204" pitchFamily="34" charset="0"/>
+              <a:ea typeface="Calibri" panose="020F0502020204030204" pitchFamily="34" charset="0"/>
+              <a:cs typeface="Calibri" panose="020F0502020204030204" pitchFamily="34" charset="0"/>
+            </a:endParaRPr>
           </a:p>
         </p:txBody>
       </p:sp>
@@ -22609,7 +22600,7 @@
           <p:cNvPr id="28" name="תיבת טקסט 9">
             <a:extLst>
               <a:ext uri="{FF2B5EF4-FFF2-40B4-BE49-F238E27FC236}">
-                <ns3:creationId id="{2576C175-3BF1-9365-5DE4-6A895245D818}"/>
+                <a16:creationId xmlns:a16="http://schemas.microsoft.com/office/drawing/2014/main" id="{2576C175-3BF1-9365-5DE4-6A895245D818}"/>
               </a:ext>
             </a:extLst>
           </p:cNvPr>
@@ -22669,17 +22660,14 @@
           </a:p>
           <a:p>
             <a:pPr algn="r" rtl="1"/>
-            <a:r>
-              <a:rPr lang="he-IL" sz="1400" dirty="0">
-                <a:solidFill>
-                  <a:srgbClr val="305250"/>
-                </a:solidFill>
-                <a:latin typeface="Calibri" panose="020F0502020204030204" pitchFamily="34" charset="0"/>
-                <a:ea typeface="Calibri" panose="020F0502020204030204" pitchFamily="34" charset="0"/>
-                <a:cs typeface="Calibri" panose="020F0502020204030204" pitchFamily="34" charset="0"/>
-              </a:rPr>
-              <a:t/>
-            </a:r>
+            <a:endParaRPr lang="he-IL" sz="1400" dirty="0">
+              <a:solidFill>
+                <a:srgbClr val="305250"/>
+              </a:solidFill>
+              <a:latin typeface="Calibri" panose="020F0502020204030204" pitchFamily="34" charset="0"/>
+              <a:ea typeface="Calibri" panose="020F0502020204030204" pitchFamily="34" charset="0"/>
+              <a:cs typeface="Calibri" panose="020F0502020204030204" pitchFamily="34" charset="0"/>
+            </a:endParaRPr>
           </a:p>
         </p:txBody>
       </p:sp>
@@ -22907,10 +22895,46 @@
           </a:p>
         </p:txBody>
       </p:sp>
+      <p:pic>
+        <p:nvPicPr>
+          <p:cNvPr id="5" name="Picture 4">
+            <a:extLst>
+              <a:ext uri="{FF2B5EF4-FFF2-40B4-BE49-F238E27FC236}">
+                <a16:creationId xmlns:a16="http://schemas.microsoft.com/office/drawing/2014/main" id="{EA0E0737-9A13-3187-0B8F-64280260EE8B}"/>
+              </a:ext>
+            </a:extLst>
+          </p:cNvPr>
+          <p:cNvPicPr>
+            <a:picLocks noChangeAspect="1"/>
+          </p:cNvPicPr>
+          <p:nvPr/>
+        </p:nvPicPr>
+        <p:blipFill>
+          <a:blip r:embed="rId3">
+            <a:extLst>
+              <a:ext uri="{28A0092B-C50C-407E-A947-70E740481C1C}">
+                <a14:useLocalDpi xmlns:a14="http://schemas.microsoft.com/office/drawing/2010/main" val="0"/>
+              </a:ext>
+            </a:extLst>
+          </a:blip>
+          <a:stretch>
+            <a:fillRect/>
+          </a:stretch>
+        </p:blipFill>
+        <p:spPr>
+          <a:xfrm>
+            <a:off x="-14514" y="0"/>
+            <a:ext cx="3061664" cy="4120370"/>
+          </a:xfrm>
+          <a:prstGeom prst="rect">
+            <a:avLst/>
+          </a:prstGeom>
+        </p:spPr>
+      </p:pic>
     </p:spTree>
     <p:extLst>
       <p:ext uri="{BB962C8B-B14F-4D97-AF65-F5344CB8AC3E}">
-        <ns4:creationId val="2354692379"/>
+        <p14:creationId xmlns:p14="http://schemas.microsoft.com/office/powerpoint/2010/main" val="2354692379"/>
       </p:ext>
     </p:extLst>
   </p:cSld>

</xml_diff>

<commit_message>
Issue #82: polish building card template
</commit_message>
<xml_diff>
--- a/project/web-server/backend/Data/BuildingCardTemplate.pptx
+++ b/project/web-server/backend/Data/BuildingCardTemplate.pptx
@@ -130,75 +130,6 @@
 </p:cmAuthorLst>
 </file>
 
-<file path=ppt/revisionInfo.xml><?xml version="1.0" encoding="utf-8"?>
-<p1510:revInfo xmlns:a="http://schemas.openxmlformats.org/drawingml/2006/main" xmlns:r="http://schemas.openxmlformats.org/officeDocument/2006/relationships" xmlns:p1510="http://schemas.microsoft.com/office/powerpoint/2015/10/main">
-  <p1510:revLst>
-    <p1510:client id="{AF317526-C38C-4153-9F5B-986387788569}" v="1" dt="2026-01-22T13:55:06.673"/>
-  </p1510:revLst>
-</p1510:revInfo>
-</file>
-
-<file path=ppt/changesInfos/changesInfo1.xml><?xml version="1.0" encoding="utf-8"?>
-<pc:chgInfo xmlns:a="http://schemas.openxmlformats.org/drawingml/2006/main" xmlns:r="http://schemas.openxmlformats.org/officeDocument/2006/relationships" xmlns:ac="http://schemas.microsoft.com/office/drawing/2013/main/command" xmlns:pc="http://schemas.microsoft.com/office/powerpoint/2013/main/command">
-  <pc:docChgLst>
-    <pc:chgData name="דובוב-דותן ויטלי" userId="b5f7de7b-54e1-4a3f-9416-31a449fb3524" providerId="ADAL" clId="{03BCFFEB-95F6-40A2-BF91-EC84C7D80E89}"/>
-    <pc:docChg chg="modSld">
-      <pc:chgData name="דובוב-דותן ויטלי" userId="b5f7de7b-54e1-4a3f-9416-31a449fb3524" providerId="ADAL" clId="{03BCFFEB-95F6-40A2-BF91-EC84C7D80E89}" dt="2026-01-13T18:37:14.791" v="0" actId="1076"/>
-      <pc:docMkLst>
-        <pc:docMk/>
-      </pc:docMkLst>
-      <pc:sldChg chg="modSp mod">
-        <pc:chgData name="דובוב-דותן ויטלי" userId="b5f7de7b-54e1-4a3f-9416-31a449fb3524" providerId="ADAL" clId="{03BCFFEB-95F6-40A2-BF91-EC84C7D80E89}" dt="2026-01-13T18:37:14.791" v="0" actId="1076"/>
-        <pc:sldMkLst>
-          <pc:docMk/>
-          <pc:sldMk cId="2354692379" sldId="747"/>
-        </pc:sldMkLst>
-        <pc:spChg chg="mod">
-          <ac:chgData name="דובוב-דותן ויטלי" userId="b5f7de7b-54e1-4a3f-9416-31a449fb3524" providerId="ADAL" clId="{03BCFFEB-95F6-40A2-BF91-EC84C7D80E89}" dt="2026-01-13T18:37:14.791" v="0" actId="1076"/>
-          <ac:spMkLst>
-            <pc:docMk/>
-            <pc:sldMk cId="2354692379" sldId="747"/>
-            <ac:spMk id="28" creationId="{2576C175-3BF1-9365-5DE4-6A895245D818}"/>
-          </ac:spMkLst>
-        </pc:spChg>
-      </pc:sldChg>
-    </pc:docChg>
-  </pc:docChgLst>
-  <pc:docChgLst>
-    <pc:chgData name="Kareem Araide" userId="de348250dbb8bac6" providerId="LiveId" clId="{65F28107-F77A-404E-ADBF-4CBF28DF91CB}"/>
-    <pc:docChg chg="custSel modSld">
-      <pc:chgData name="Kareem Araide" userId="de348250dbb8bac6" providerId="LiveId" clId="{65F28107-F77A-404E-ADBF-4CBF28DF91CB}" dt="2026-01-22T13:55:44.701" v="13" actId="1076"/>
-      <pc:docMkLst>
-        <pc:docMk/>
-      </pc:docMkLst>
-      <pc:sldChg chg="addSp delSp modSp mod">
-        <pc:chgData name="Kareem Araide" userId="de348250dbb8bac6" providerId="LiveId" clId="{65F28107-F77A-404E-ADBF-4CBF28DF91CB}" dt="2026-01-22T13:55:44.701" v="13" actId="1076"/>
-        <pc:sldMkLst>
-          <pc:docMk/>
-          <pc:sldMk cId="2354692379" sldId="747"/>
-        </pc:sldMkLst>
-        <pc:picChg chg="add mod">
-          <ac:chgData name="Kareem Araide" userId="de348250dbb8bac6" providerId="LiveId" clId="{65F28107-F77A-404E-ADBF-4CBF28DF91CB}" dt="2026-01-22T13:55:44.701" v="13" actId="1076"/>
-          <ac:picMkLst>
-            <pc:docMk/>
-            <pc:sldMk cId="2354692379" sldId="747"/>
-            <ac:picMk id="5" creationId="{EA0E0737-9A13-3187-0B8F-64280260EE8B}"/>
-          </ac:picMkLst>
-        </pc:picChg>
-        <pc:picChg chg="del">
-          <ac:chgData name="Kareem Araide" userId="de348250dbb8bac6" providerId="LiveId" clId="{65F28107-F77A-404E-ADBF-4CBF28DF91CB}" dt="2026-01-22T13:55:32.753" v="4" actId="478"/>
-          <ac:picMkLst>
-            <pc:docMk/>
-            <pc:sldMk cId="2354692379" sldId="747"/>
-            <ac:picMk id="29" creationId="{00000000-0000-0000-0000-000000000000}"/>
-          </ac:picMkLst>
-        </pc:picChg>
-      </pc:sldChg>
-    </pc:docChg>
-  </pc:docChgLst>
-</pc:chgInfo>
-</file>
-
 <file path=ppt/notesMasters/notesMaster1.xml><?xml version="1.0" encoding="utf-8"?>
 <p:notesMaster xmlns:a="http://schemas.openxmlformats.org/drawingml/2006/main" xmlns:r="http://schemas.openxmlformats.org/officeDocument/2006/relationships" xmlns:p="http://schemas.openxmlformats.org/presentationml/2006/main">
   <p:cSld>
@@ -286,7 +217,7 @@
             <a:fld id="{2235085D-1097-4D16-8C89-046FBDEE899B}" type="datetimeFigureOut">
               <a:rPr lang="he-IL" smtClean="0"/>
               <a:pPr/>
-              <a:t>ד'/שבט/תשפ"ו</a:t>
+              <a:t>י"ג/תמוז/תשפ"ו</a:t>
             </a:fld>
             <a:endParaRPr lang="he-IL" dirty="0"/>
           </a:p>
@@ -9360,7 +9291,7 @@
             <a:fld id="{06D97635-68D3-4231-B6D3-E01CF285EE9C}" type="datetime8">
               <a:rPr lang="he-IL" smtClean="0"/>
               <a:pPr/>
-              <a:t>22 ינואר 26</a:t>
+              <a:t>28 יוני 26</a:t>
             </a:fld>
             <a:endParaRPr lang="he-IL"/>
           </a:p>
@@ -9588,7 +9519,7 @@
           <a:p>
             <a:fld id="{BD92C3CD-2DD7-4739-91FD-190E7B42CACD}" type="datetime8">
               <a:rPr lang="he-IL" smtClean="0"/>
-              <a:t>22 ינואר 26</a:t>
+              <a:t>28 יוני 26</a:t>
             </a:fld>
             <a:endParaRPr lang="he-IL"/>
           </a:p>
@@ -9774,7 +9705,7 @@
           <a:p>
             <a:fld id="{FD4BFC87-1F72-462A-BCEA-1A814EAC5254}" type="datetime8">
               <a:rPr lang="he-IL" smtClean="0"/>
-              <a:t>22 ינואר 26</a:t>
+              <a:t>28 יוני 26</a:t>
             </a:fld>
             <a:endParaRPr lang="he-IL"/>
           </a:p>
@@ -10027,7 +9958,7 @@
             <a:fld id="{8D7207FB-0423-4EBC-BC71-093AC5750AD0}" type="datetime8">
               <a:rPr lang="he-IL" smtClean="0"/>
               <a:pPr/>
-              <a:t>22 ינואר 26</a:t>
+              <a:t>28 יוני 26</a:t>
             </a:fld>
             <a:endParaRPr lang="he-IL"/>
           </a:p>
@@ -18812,7 +18743,7 @@
           <a:p>
             <a:fld id="{5BB1EDE2-E23E-4D45-97E7-8B22884C3954}" type="datetime8">
               <a:rPr lang="he-IL" smtClean="0"/>
-              <a:t>22 ינואר 26</a:t>
+              <a:t>28 יוני 26</a:t>
             </a:fld>
             <a:endParaRPr lang="he-IL"/>
           </a:p>
@@ -19092,7 +19023,7 @@
           <a:p>
             <a:fld id="{A87D2518-068A-4B4E-9411-11F0D777D01C}" type="datetime8">
               <a:rPr lang="he-IL" smtClean="0"/>
-              <a:t>22 ינואר 26</a:t>
+              <a:t>28 יוני 26</a:t>
             </a:fld>
             <a:endParaRPr lang="he-IL"/>
           </a:p>
@@ -19570,7 +19501,7 @@
             <a:fld id="{0F1C5475-1302-4305-92B3-B5D3D4D128BD}" type="datetime8">
               <a:rPr lang="he-IL" smtClean="0"/>
               <a:pPr/>
-              <a:t>22 ינואר 26</a:t>
+              <a:t>28 יוני 26</a:t>
             </a:fld>
             <a:endParaRPr lang="he-IL"/>
           </a:p>
@@ -19720,7 +19651,7 @@
             <a:fld id="{98EE1D82-A631-49C7-A4BC-CF56C1A36EBF}" type="datetime8">
               <a:rPr lang="he-IL" smtClean="0"/>
               <a:pPr/>
-              <a:t>22 ינואר 26</a:t>
+              <a:t>28 יוני 26</a:t>
             </a:fld>
             <a:endParaRPr lang="he-IL"/>
           </a:p>
@@ -19830,7 +19761,7 @@
           <a:p>
             <a:fld id="{0EB353D4-AB26-4510-80F0-851F863F6D73}" type="datetime8">
               <a:rPr lang="he-IL" smtClean="0"/>
-              <a:t>22 ינואר 26</a:t>
+              <a:t>28 יוני 26</a:t>
             </a:fld>
             <a:endParaRPr lang="he-IL"/>
           </a:p>
@@ -20120,7 +20051,7 @@
           <a:p>
             <a:fld id="{813B2F0F-C3DA-4E52-B4E3-B2BD22748E6D}" type="datetime8">
               <a:rPr lang="he-IL" smtClean="0"/>
-              <a:t>22 ינואר 26</a:t>
+              <a:t>28 יוני 26</a:t>
             </a:fld>
             <a:endParaRPr lang="he-IL"/>
           </a:p>
@@ -20400,7 +20331,7 @@
           <a:p>
             <a:fld id="{85CCD77F-7A8D-4C44-9CE3-16F0C0070A60}" type="datetime8">
               <a:rPr lang="he-IL" smtClean="0"/>
-              <a:t>22 ינואר 26</a:t>
+              <a:t>28 יוני 26</a:t>
             </a:fld>
             <a:endParaRPr lang="he-IL"/>
           </a:p>
@@ -20657,7 +20588,7 @@
             <a:fld id="{864DF5F2-D2BF-431E-BFF9-A44526EEADB6}" type="datetime8">
               <a:rPr lang="he-IL" smtClean="0"/>
               <a:pPr/>
-              <a:t>22 ינואר 26</a:t>
+              <a:t>28 יוני 26</a:t>
             </a:fld>
             <a:endParaRPr lang="he-IL"/>
           </a:p>
@@ -21148,7 +21079,7 @@
 </file>
 
 <file path=ppt/slides/slide1.xml><?xml version="1.0" encoding="utf-8"?>
-<p:sld xmlns:a="http://schemas.openxmlformats.org/drawingml/2006/main" xmlns:r="http://schemas.openxmlformats.org/officeDocument/2006/relationships" xmlns:p="http://schemas.openxmlformats.org/presentationml/2006/main">
+<p:sld xmlns:a="http://schemas.openxmlformats.org/drawingml/2006/main" xmlns:ns2="http://schemas.openxmlformats.org/officeDocument/2006/relationships" xmlns:ns3="http://schemas.microsoft.com/office/drawing/2014/main" xmlns:ns4="http://schemas.microsoft.com/office/powerpoint/2010/main" xmlns:ns5="http://schemas.microsoft.com/office/drawing/2010/main" xmlns:p="http://schemas.openxmlformats.org/presentationml/2006/main">
   <p:cSld>
     <p:spTree>
       <p:nvGrpSpPr>
@@ -21173,14 +21104,14 @@
           <p:nvPr/>
         </p:nvPicPr>
         <p:blipFill rotWithShape="1">
-          <a:blip r:embed="rId2"/>
+          <a:blip ns2:embed="rId2"/>
           <a:srcRect r="10124"/>
           <a:stretch/>
         </p:blipFill>
         <p:spPr>
           <a:xfrm>
-            <a:off x="-10895" y="4120369"/>
-            <a:ext cx="3084295" cy="2737631"/>
+            <a:off x="0" y="4114800"/>
+            <a:ext cx="3035808" cy="2743200"/>
           </a:xfrm>
           <a:prstGeom prst="rect">
             <a:avLst/>
@@ -21195,8 +21126,8 @@
         </p:nvSpPr>
         <p:spPr>
           <a:xfrm>
-            <a:off x="1193067" y="5885973"/>
-            <a:ext cx="468000" cy="466725"/>
+            <a:off x="1188720" y="5888736"/>
+            <a:ext cx="466344" cy="466344"/>
           </a:xfrm>
           <a:prstGeom prst="ellipse">
             <a:avLst/>
@@ -21241,8 +21172,8 @@
         </p:nvSpPr>
         <p:spPr>
           <a:xfrm>
-            <a:off x="3077019" y="-1"/>
-            <a:ext cx="9124052" cy="6858001"/>
+            <a:off x="3072384" y="0"/>
+            <a:ext cx="9125712" cy="6858000"/>
           </a:xfrm>
           <a:prstGeom prst="rect">
             <a:avLst/>
@@ -21284,7 +21215,7 @@
           <p:cNvPr id="17" name="תיבת טקסט 9">
             <a:extLst>
               <a:ext uri="{FF2B5EF4-FFF2-40B4-BE49-F238E27FC236}">
-                <a16:creationId xmlns:a16="http://schemas.microsoft.com/office/drawing/2014/main" id="{2576C175-3BF1-9365-5DE4-6A895245D818}"/>
+                <ns3:creationId id="{2576C175-3BF1-9365-5DE4-6A895245D818}"/>
               </a:ext>
             </a:extLst>
           </p:cNvPr>
@@ -21293,8 +21224,8 @@
         </p:nvSpPr>
         <p:spPr>
           <a:xfrm>
-            <a:off x="3072925" y="4059749"/>
-            <a:ext cx="4504881" cy="584775"/>
+            <a:off x="3072384" y="5230368"/>
+            <a:ext cx="4398264" cy="1280160"/>
           </a:xfrm>
           <a:prstGeom prst="rect">
             <a:avLst/>
@@ -21307,7 +21238,7 @@
           </a:ln>
         </p:spPr>
         <p:txBody>
-          <a:bodyPr wrap="square">
+          <a:bodyPr wrap="square" anchor="t" tIns="80000" bIns="60000" lIns="90000" rIns="90000">
             <a:spAutoFit/>
           </a:bodyPr>
           <a:lstStyle/>
@@ -21332,7 +21263,7 @@
           <p:cNvPr id="18" name="תיבת טקסט 9">
             <a:extLst>
               <a:ext uri="{FF2B5EF4-FFF2-40B4-BE49-F238E27FC236}">
-                <a16:creationId xmlns:a16="http://schemas.microsoft.com/office/drawing/2014/main" id="{2576C175-3BF1-9365-5DE4-6A895245D818}"/>
+                <ns3:creationId id="{2576C175-3BF1-9365-5DE4-6A895245D818}"/>
               </a:ext>
             </a:extLst>
           </p:cNvPr>
@@ -21341,8 +21272,8 @@
         </p:nvSpPr>
         <p:spPr>
           <a:xfrm>
-            <a:off x="7577806" y="4053469"/>
-            <a:ext cx="4605550" cy="2246769"/>
+            <a:off x="7653528" y="5230368"/>
+            <a:ext cx="4398264" cy="1280160"/>
           </a:xfrm>
           <a:prstGeom prst="rect">
             <a:avLst/>
@@ -21355,7 +21286,7 @@
           </a:ln>
         </p:spPr>
         <p:txBody>
-          <a:bodyPr wrap="square">
+          <a:bodyPr wrap="square" anchor="t" tIns="80000" bIns="60000" lIns="90000" rIns="90000">
             <a:spAutoFit/>
           </a:bodyPr>
           <a:lstStyle/>
@@ -21424,7 +21355,7 @@
           <p:cNvPr id="19" name="תיבת טקסט 9">
             <a:extLst>
               <a:ext uri="{FF2B5EF4-FFF2-40B4-BE49-F238E27FC236}">
-                <a16:creationId xmlns:a16="http://schemas.microsoft.com/office/drawing/2014/main" id="{2576C175-3BF1-9365-5DE4-6A895245D818}"/>
+                <ns3:creationId id="{2576C175-3BF1-9365-5DE4-6A895245D818}"/>
               </a:ext>
             </a:extLst>
           </p:cNvPr>
@@ -21433,8 +21364,8 @@
         </p:nvSpPr>
         <p:spPr>
           <a:xfrm>
-            <a:off x="6858000" y="-1"/>
-            <a:ext cx="5333994" cy="923330"/>
+            <a:off x="6858000" y="36576"/>
+            <a:ext cx="5193792" cy="694944"/>
           </a:xfrm>
           <a:prstGeom prst="rect">
             <a:avLst/>
@@ -21447,7 +21378,7 @@
           </a:ln>
         </p:spPr>
         <p:txBody>
-          <a:bodyPr wrap="square">
+          <a:bodyPr wrap="square" anchor="ctr" tIns="0" bIns="0" lIns="0" rIns="0">
             <a:spAutoFit/>
           </a:bodyPr>
           <a:lstStyle/>
@@ -21472,7 +21403,7 @@
           <p:cNvPr id="20" name="תיבת טקסט 9">
             <a:extLst>
               <a:ext uri="{FF2B5EF4-FFF2-40B4-BE49-F238E27FC236}">
-                <a16:creationId xmlns:a16="http://schemas.microsoft.com/office/drawing/2014/main" id="{2576C175-3BF1-9365-5DE4-6A895245D818}"/>
+                <ns3:creationId id="{2576C175-3BF1-9365-5DE4-6A895245D818}"/>
               </a:ext>
             </a:extLst>
           </p:cNvPr>
@@ -21481,8 +21412,8 @@
         </p:nvSpPr>
         <p:spPr>
           <a:xfrm>
-            <a:off x="10042070" y="2293206"/>
-            <a:ext cx="2158779" cy="1015663"/>
+            <a:off x="9889236" y="3090672"/>
+            <a:ext cx="2162556" cy="841248"/>
           </a:xfrm>
           <a:prstGeom prst="rect">
             <a:avLst/>
@@ -21498,7 +21429,7 @@
           </a:ln>
         </p:spPr>
         <p:txBody>
-          <a:bodyPr wrap="square">
+          <a:bodyPr wrap="square" anchor="ctr" tIns="0" bIns="0" lIns="0" rIns="0">
             <a:spAutoFit/>
           </a:bodyPr>
           <a:lstStyle/>
@@ -21548,7 +21479,7 @@
           <p:cNvPr id="21" name="תיבת טקסט 9">
             <a:extLst>
               <a:ext uri="{FF2B5EF4-FFF2-40B4-BE49-F238E27FC236}">
-                <a16:creationId xmlns:a16="http://schemas.microsoft.com/office/drawing/2014/main" id="{2576C175-3BF1-9365-5DE4-6A895245D818}"/>
+                <ns3:creationId id="{2576C175-3BF1-9365-5DE4-6A895245D818}"/>
               </a:ext>
             </a:extLst>
           </p:cNvPr>
@@ -21557,8 +21488,8 @@
         </p:nvSpPr>
         <p:spPr>
           <a:xfrm>
-            <a:off x="3507003" y="409144"/>
-            <a:ext cx="3127822" cy="400110"/>
+            <a:off x="4526280" y="420624"/>
+            <a:ext cx="2697480" cy="384048"/>
           </a:xfrm>
           <a:prstGeom prst="rect">
             <a:avLst/>
@@ -21571,7 +21502,7 @@
           </a:ln>
         </p:spPr>
         <p:txBody>
-          <a:bodyPr wrap="square">
+          <a:bodyPr wrap="square" anchor="ctr" tIns="0" bIns="0" lIns="0" rIns="0">
             <a:spAutoFit/>
           </a:bodyPr>
           <a:lstStyle/>
@@ -21598,7 +21529,7 @@
           <p:cNvPr id="23" name="תיבת טקסט 9">
             <a:extLst>
               <a:ext uri="{FF2B5EF4-FFF2-40B4-BE49-F238E27FC236}">
-                <a16:creationId xmlns:a16="http://schemas.microsoft.com/office/drawing/2014/main" id="{2576C175-3BF1-9365-5DE4-6A895245D818}"/>
+                <ns3:creationId id="{2576C175-3BF1-9365-5DE4-6A895245D818}"/>
               </a:ext>
             </a:extLst>
           </p:cNvPr>
@@ -21607,8 +21538,8 @@
         </p:nvSpPr>
         <p:spPr>
           <a:xfrm>
-            <a:off x="2998178" y="1504365"/>
-            <a:ext cx="9202672" cy="800219"/>
+            <a:off x="3072384" y="2450592"/>
+            <a:ext cx="8979408" cy="512064"/>
           </a:xfrm>
           <a:prstGeom prst="rect">
             <a:avLst/>
@@ -21621,7 +21552,7 @@
           </a:ln>
         </p:spPr>
         <p:txBody>
-          <a:bodyPr wrap="square">
+          <a:bodyPr wrap="square" anchor="ctr" tIns="0" bIns="0" lIns="0" rIns="0">
             <a:spAutoFit/>
           </a:bodyPr>
           <a:lstStyle/>
@@ -21660,8 +21591,8 @@
         </p:nvSpPr>
         <p:spPr>
           <a:xfrm>
-            <a:off x="2993891" y="919589"/>
-            <a:ext cx="9215817" cy="584775"/>
+            <a:off x="3072384" y="1938528"/>
+            <a:ext cx="8979408" cy="420624"/>
           </a:xfrm>
           <a:prstGeom prst="rect">
             <a:avLst/>
@@ -21676,7 +21607,7 @@
           </a:ln>
         </p:spPr>
         <p:txBody>
-          <a:bodyPr wrap="square">
+          <a:bodyPr wrap="square" anchor="ctr" tIns="0" bIns="0" lIns="0" rIns="0">
             <a:spAutoFit/>
           </a:bodyPr>
           <a:lstStyle/>
@@ -21704,8 +21635,8 @@
         </p:nvSpPr>
         <p:spPr>
           <a:xfrm>
-            <a:off x="3171159" y="52319"/>
-            <a:ext cx="1260000" cy="1260000"/>
+            <a:off x="3474720" y="877824"/>
+            <a:ext cx="960120" cy="960120"/>
           </a:xfrm>
           <a:prstGeom prst="ellipse">
             <a:avLst/>
@@ -21741,7 +21672,7 @@
           </a:fontRef>
         </p:style>
         <p:txBody>
-          <a:bodyPr rtlCol="1" anchor="ctr"/>
+          <a:bodyPr rtlCol="1" anchor="ctr" tIns="0" bIns="0" lIns="0" rIns="0"/>
           <a:lstStyle/>
           <a:p>
             <a:pPr algn="ctr" rtl="1"/>
@@ -21768,14 +21699,14 @@
           <p:nvPr>
             <p:extLst>
               <p:ext uri="{D42A27DB-BD31-4B8C-83A1-F6EECF244321}">
-                <p14:modId xmlns:p14="http://schemas.microsoft.com/office/powerpoint/2010/main" val="1855143216"/>
+                <ns4:modId val="1855143216"/>
               </p:ext>
             </p:extLst>
           </p:nvPr>
         </p:nvGraphicFramePr>
         <p:xfrm>
-          <a:off x="2732739" y="3307190"/>
-          <a:ext cx="9468046" cy="1193800"/>
+          <a:off x="3072384" y="4078224"/>
+          <a:ext cx="8979408" cy="950976"/>
         </p:xfrm>
         <a:graphic>
           <a:graphicData uri="http://schemas.openxmlformats.org/drawingml/2006/table">
@@ -21784,46 +21715,39 @@
                 <a:tableStyleId>{2D5ABB26-0587-4C30-8999-92F81FD0307C}</a:tableStyleId>
               </a:tblPr>
               <a:tblGrid>
-                <a:gridCol w="2284730">
+                <a:gridCol w="2231136">
                   <a:extLst>
                     <a:ext uri="{9D8B030D-6E8A-4147-A177-3AD203B41FA5}">
-                      <a16:colId xmlns:a16="http://schemas.microsoft.com/office/drawing/2014/main" val="720534580"/>
+                      <ns3:colId val="720534580"/>
                     </a:ext>
                   </a:extLst>
                 </a:gridCol>
-                <a:gridCol w="1638944">
+                <a:gridCol w="2249424">
                   <a:extLst>
                     <a:ext uri="{9D8B030D-6E8A-4147-A177-3AD203B41FA5}">
-                      <a16:colId xmlns:a16="http://schemas.microsoft.com/office/drawing/2014/main" val="3385606801"/>
+                      <ns3:colId val="3385606801"/>
                     </a:ext>
                   </a:extLst>
                 </a:gridCol>
-                <a:gridCol w="1824722">
+                <a:gridCol w="2249424">
                   <a:extLst>
                     <a:ext uri="{9D8B030D-6E8A-4147-A177-3AD203B41FA5}">
-                      <a16:colId xmlns:a16="http://schemas.microsoft.com/office/drawing/2014/main" val="1287329000"/>
+                      <ns3:colId val="1287329000"/>
                     </a:ext>
                   </a:extLst>
                 </a:gridCol>
-                <a:gridCol w="1824722">
+                <a:gridCol w="2249424">
                   <a:extLst>
                     <a:ext uri="{9D8B030D-6E8A-4147-A177-3AD203B41FA5}">
-                      <a16:colId xmlns:a16="http://schemas.microsoft.com/office/drawing/2014/main" val="3932464124"/>
-                    </a:ext>
-                  </a:extLst>
-                </a:gridCol>
-                <a:gridCol w="1894928">
-                  <a:extLst>
-                    <a:ext uri="{9D8B030D-6E8A-4147-A177-3AD203B41FA5}">
-                      <a16:colId xmlns:a16="http://schemas.microsoft.com/office/drawing/2014/main" val="483288508"/>
+                      <ns3:colId val="3932464124"/>
                     </a:ext>
                   </a:extLst>
                 </a:gridCol>
               </a:tblGrid>
-              <a:tr h="370840">
+              <a:tr h="475488">
                 <a:tc rowSpan="2">
                   <a:txBody>
-                    <a:bodyPr/>
+                    <a:bodyPr anchor="ctr" tIns="0" bIns="0" lIns="0" rIns="0"/>
                     <a:lstStyle/>
                     <a:p>
                       <a:pPr algn="r" rtl="1"/>
@@ -21884,7 +21808,7 @@
                 </a:tc>
                 <a:tc>
                   <a:txBody>
-                    <a:bodyPr/>
+                    <a:bodyPr anchor="ctr" tIns="0" bIns="0" lIns="0" rIns="0"/>
                     <a:lstStyle/>
                     <a:p>
                       <a:pPr rtl="1"/>
@@ -21942,7 +21866,7 @@
                 </a:tc>
                 <a:tc>
                   <a:txBody>
-                    <a:bodyPr/>
+                    <a:bodyPr anchor="ctr" tIns="0" bIns="0" lIns="0" rIns="0"/>
                     <a:lstStyle/>
                     <a:p>
                       <a:pPr rtl="1"/>
@@ -22000,7 +21924,7 @@
                 </a:tc>
                 <a:tc>
                   <a:txBody>
-                    <a:bodyPr/>
+                    <a:bodyPr anchor="ctr" tIns="0" bIns="0" lIns="0" rIns="0"/>
                     <a:lstStyle/>
                     <a:p>
                       <a:pPr rtl="1"/>
@@ -22056,71 +21980,16 @@
                     </a:solidFill>
                   </a:tcPr>
                 </a:tc>
-                <a:tc>
-                  <a:txBody>
-                    <a:bodyPr/>
-                    <a:lstStyle/>
-                    <a:p>
-                      <a:pPr rtl="1"/>
-                      <a:endParaRPr lang="he-IL">
-                        <a:latin typeface="Calibri" panose="020F0502020204030204" pitchFamily="34" charset="0"/>
-                        <a:ea typeface="Calibri" panose="020F0502020204030204" pitchFamily="34" charset="0"/>
-                        <a:cs typeface="Calibri" panose="020F0502020204030204" pitchFamily="34" charset="0"/>
-                      </a:endParaRPr>
-                    </a:p>
-                  </a:txBody>
-                  <a:tcPr>
-                    <a:lnL w="12700" cap="flat" cmpd="sng" algn="ctr">
-                      <a:noFill/>
-                      <a:prstDash val="solid"/>
-                      <a:round/>
-                      <a:headEnd type="none" w="med" len="med"/>
-                      <a:tailEnd type="none" w="med" len="med"/>
-                    </a:lnL>
-                    <a:lnR w="12700" cap="flat" cmpd="sng" algn="ctr">
-                      <a:noFill/>
-                      <a:prstDash val="solid"/>
-                      <a:round/>
-                      <a:headEnd type="none" w="med" len="med"/>
-                      <a:tailEnd type="none" w="med" len="med"/>
-                    </a:lnR>
-                    <a:lnT w="12700" cap="flat" cmpd="sng" algn="ctr">
-                      <a:noFill/>
-                      <a:prstDash val="solid"/>
-                      <a:round/>
-                      <a:headEnd type="none" w="med" len="med"/>
-                      <a:tailEnd type="none" w="med" len="med"/>
-                    </a:lnT>
-                    <a:lnB w="12700" cap="flat" cmpd="sng" algn="ctr">
-                      <a:noFill/>
-                      <a:prstDash val="solid"/>
-                      <a:round/>
-                      <a:headEnd type="none" w="med" len="med"/>
-                      <a:tailEnd type="none" w="med" len="med"/>
-                    </a:lnB>
-                    <a:lnTlToBr w="12700" cmpd="sng">
-                      <a:noFill/>
-                      <a:prstDash val="solid"/>
-                    </a:lnTlToBr>
-                    <a:lnBlToTr w="12700" cmpd="sng">
-                      <a:noFill/>
-                      <a:prstDash val="solid"/>
-                    </a:lnBlToTr>
-                    <a:solidFill>
-                      <a:srgbClr val="D4EBDB"/>
-                    </a:solidFill>
-                  </a:tcPr>
-                </a:tc>
                 <a:extLst>
                   <a:ext uri="{0D108BD9-81ED-4DB2-BD59-A6C34878D82A}">
-                    <a16:rowId xmlns:a16="http://schemas.microsoft.com/office/drawing/2014/main" val="1032947799"/>
+                    <ns3:rowId val="1032947799"/>
                   </a:ext>
                 </a:extLst>
               </a:tr>
-              <a:tr h="370840">
+              <a:tr h="475488">
                 <a:tc vMerge="1">
                   <a:txBody>
-                    <a:bodyPr/>
+                    <a:bodyPr anchor="ctr" tIns="0" bIns="0" lIns="0" rIns="0"/>
                     <a:lstStyle/>
                     <a:p>
                       <a:pPr rtl="1"/>
@@ -22176,7 +22045,7 @@
                 </a:tc>
                 <a:tc>
                   <a:txBody>
-                    <a:bodyPr/>
+                    <a:bodyPr anchor="ctr" tIns="0" bIns="0" lIns="0" rIns="0"/>
                     <a:lstStyle/>
                     <a:p>
                       <a:pPr rtl="1"/>
@@ -22239,7 +22108,7 @@
                 </a:tc>
                 <a:tc>
                   <a:txBody>
-                    <a:bodyPr/>
+                    <a:bodyPr anchor="ctr" tIns="0" bIns="0" lIns="0" rIns="0"/>
                     <a:lstStyle/>
                     <a:p>
                       <a:pPr rtl="1"/>
@@ -22308,7 +22177,7 @@
                 </a:tc>
                 <a:tc>
                   <a:txBody>
-                    <a:bodyPr/>
+                    <a:bodyPr anchor="ctr" tIns="0" bIns="0" lIns="0" rIns="0"/>
                     <a:lstStyle/>
                     <a:p>
                       <a:pPr rtl="1"/>
@@ -22375,67 +22244,9 @@
                     </a:solidFill>
                   </a:tcPr>
                 </a:tc>
-                <a:tc>
-                  <a:txBody>
-                    <a:bodyPr/>
-                    <a:lstStyle/>
-                    <a:p>
-                      <a:pPr rtl="1"/>
-                      <a:endParaRPr lang="he-IL" sz="2400" kern="1200" dirty="0">
-                        <a:solidFill>
-                          <a:schemeClr val="tx1"/>
-                        </a:solidFill>
-                        <a:latin typeface="Calibri" panose="020F0502020204030204" pitchFamily="34" charset="0"/>
-                        <a:ea typeface="Calibri" panose="020F0502020204030204" pitchFamily="34" charset="0"/>
-                        <a:cs typeface="Calibri" panose="020F0502020204030204" pitchFamily="34" charset="0"/>
-                      </a:endParaRPr>
-                    </a:p>
-                  </a:txBody>
-                  <a:tcPr>
-                    <a:lnL w="12700" cap="flat" cmpd="sng" algn="ctr">
-                      <a:noFill/>
-                      <a:prstDash val="solid"/>
-                      <a:round/>
-                      <a:headEnd type="none" w="med" len="med"/>
-                      <a:tailEnd type="none" w="med" len="med"/>
-                    </a:lnL>
-                    <a:lnR w="12700" cap="flat" cmpd="sng" algn="ctr">
-                      <a:noFill/>
-                      <a:prstDash val="solid"/>
-                      <a:round/>
-                      <a:headEnd type="none" w="med" len="med"/>
-                      <a:tailEnd type="none" w="med" len="med"/>
-                    </a:lnR>
-                    <a:lnT w="12700" cap="flat" cmpd="sng" algn="ctr">
-                      <a:noFill/>
-                      <a:prstDash val="solid"/>
-                      <a:round/>
-                      <a:headEnd type="none" w="med" len="med"/>
-                      <a:tailEnd type="none" w="med" len="med"/>
-                    </a:lnT>
-                    <a:lnB w="12700" cap="flat" cmpd="sng" algn="ctr">
-                      <a:noFill/>
-                      <a:prstDash val="solid"/>
-                      <a:round/>
-                      <a:headEnd type="none" w="med" len="med"/>
-                      <a:tailEnd type="none" w="med" len="med"/>
-                    </a:lnB>
-                    <a:lnTlToBr w="12700" cmpd="sng">
-                      <a:noFill/>
-                      <a:prstDash val="solid"/>
-                    </a:lnTlToBr>
-                    <a:lnBlToTr w="12700" cmpd="sng">
-                      <a:noFill/>
-                      <a:prstDash val="solid"/>
-                    </a:lnBlToTr>
-                    <a:solidFill>
-                      <a:srgbClr val="D4EBDB"/>
-                    </a:solidFill>
-                  </a:tcPr>
-                </a:tc>
                 <a:extLst>
                   <a:ext uri="{0D108BD9-81ED-4DB2-BD59-A6C34878D82A}">
-                    <a16:rowId xmlns:a16="http://schemas.microsoft.com/office/drawing/2014/main" val="4286580349"/>
+                    <ns3:rowId val="4286580349"/>
                   </a:ext>
                 </a:extLst>
               </a:tr>
@@ -22448,7 +22259,7 @@
           <p:cNvPr id="33" name="תיבת טקסט 9">
             <a:extLst>
               <a:ext uri="{FF2B5EF4-FFF2-40B4-BE49-F238E27FC236}">
-                <a16:creationId xmlns:a16="http://schemas.microsoft.com/office/drawing/2014/main" id="{2576C175-3BF1-9365-5DE4-6A895245D818}"/>
+                <ns3:creationId id="{2576C175-3BF1-9365-5DE4-6A895245D818}"/>
               </a:ext>
             </a:extLst>
           </p:cNvPr>
@@ -22457,8 +22268,8 @@
         </p:nvSpPr>
         <p:spPr>
           <a:xfrm>
-            <a:off x="3068161" y="2297239"/>
-            <a:ext cx="2549734" cy="1015663"/>
+            <a:off x="3072384" y="3090672"/>
+            <a:ext cx="2162556" cy="841248"/>
           </a:xfrm>
           <a:prstGeom prst="rect">
             <a:avLst/>
@@ -22474,7 +22285,7 @@
           </a:ln>
         </p:spPr>
         <p:txBody>
-          <a:bodyPr wrap="square">
+          <a:bodyPr wrap="square" anchor="ctr" tIns="0" bIns="0" lIns="0" rIns="0">
             <a:spAutoFit/>
           </a:bodyPr>
           <a:lstStyle/>
@@ -22524,7 +22335,7 @@
           <p:cNvPr id="22" name="תיבת טקסט 9">
             <a:extLst>
               <a:ext uri="{FF2B5EF4-FFF2-40B4-BE49-F238E27FC236}">
-                <a16:creationId xmlns:a16="http://schemas.microsoft.com/office/drawing/2014/main" id="{2576C175-3BF1-9365-5DE4-6A895245D818}"/>
+                <ns3:creationId id="{2576C175-3BF1-9365-5DE4-6A895245D818}"/>
               </a:ext>
             </a:extLst>
           </p:cNvPr>
@@ -22533,8 +22344,8 @@
         </p:nvSpPr>
         <p:spPr>
           <a:xfrm>
-            <a:off x="7863237" y="2309577"/>
-            <a:ext cx="2158779" cy="1015663"/>
+            <a:off x="7616952" y="3090672"/>
+            <a:ext cx="2162556" cy="841248"/>
           </a:xfrm>
           <a:prstGeom prst="rect">
             <a:avLst/>
@@ -22550,7 +22361,7 @@
           </a:ln>
         </p:spPr>
         <p:txBody>
-          <a:bodyPr wrap="square">
+          <a:bodyPr wrap="square" anchor="ctr" tIns="0" bIns="0" lIns="0" rIns="0">
             <a:spAutoFit/>
           </a:bodyPr>
           <a:lstStyle/>
@@ -22600,7 +22411,7 @@
           <p:cNvPr id="28" name="תיבת טקסט 9">
             <a:extLst>
               <a:ext uri="{FF2B5EF4-FFF2-40B4-BE49-F238E27FC236}">
-                <a16:creationId xmlns:a16="http://schemas.microsoft.com/office/drawing/2014/main" id="{2576C175-3BF1-9365-5DE4-6A895245D818}"/>
+                <ns3:creationId id="{2576C175-3BF1-9365-5DE4-6A895245D818}"/>
               </a:ext>
             </a:extLst>
           </p:cNvPr>
@@ -22609,8 +22420,8 @@
         </p:nvSpPr>
         <p:spPr>
           <a:xfrm>
-            <a:off x="5637727" y="2300552"/>
-            <a:ext cx="2158779" cy="1015663"/>
+            <a:off x="5344668" y="3090672"/>
+            <a:ext cx="2162556" cy="841248"/>
           </a:xfrm>
           <a:prstGeom prst="rect">
             <a:avLst/>
@@ -22626,7 +22437,7 @@
           </a:ln>
         </p:spPr>
         <p:txBody>
-          <a:bodyPr wrap="square">
+          <a:bodyPr wrap="square" anchor="ctr" tIns="0" bIns="0" lIns="0" rIns="0">
             <a:spAutoFit/>
           </a:bodyPr>
           <a:lstStyle/>
@@ -22679,8 +22490,8 @@
         </p:nvSpPr>
         <p:spPr>
           <a:xfrm>
-            <a:off x="3166394" y="1410041"/>
-            <a:ext cx="1260000" cy="1260000"/>
+            <a:off x="5989320" y="877824"/>
+            <a:ext cx="960120" cy="960120"/>
           </a:xfrm>
           <a:prstGeom prst="ellipse">
             <a:avLst/>
@@ -22741,8 +22552,8 @@
         </p:nvSpPr>
         <p:spPr>
           <a:xfrm>
-            <a:off x="3076797" y="1591192"/>
-            <a:ext cx="1461708" cy="892552"/>
+            <a:off x="5989320" y="877824"/>
+            <a:ext cx="960120" cy="960120"/>
           </a:xfrm>
           <a:prstGeom prst="rect">
             <a:avLst/>
@@ -22750,7 +22561,7 @@
           <a:noFill/>
         </p:spPr>
         <p:txBody>
-          <a:bodyPr wrap="square" rtlCol="1">
+          <a:bodyPr wrap="square" rtlCol="1" anchor="ctr" tIns="0" bIns="0" lIns="0" rIns="0">
             <a:spAutoFit/>
           </a:bodyPr>
           <a:lstStyle/>
@@ -22792,8 +22603,8 @@
         </p:nvSpPr>
         <p:spPr>
           <a:xfrm>
-            <a:off x="3171159" y="2763547"/>
-            <a:ext cx="1260000" cy="1260000"/>
+            <a:off x="8503920" y="877824"/>
+            <a:ext cx="960120" cy="960120"/>
           </a:xfrm>
           <a:prstGeom prst="ellipse">
             <a:avLst/>
@@ -22852,8 +22663,8 @@
         </p:nvSpPr>
         <p:spPr>
           <a:xfrm>
-            <a:off x="3085878" y="2925779"/>
-            <a:ext cx="1461708" cy="892552"/>
+            <a:off x="8503920" y="877824"/>
+            <a:ext cx="960120" cy="960120"/>
           </a:xfrm>
           <a:prstGeom prst="rect">
             <a:avLst/>
@@ -22861,14 +22672,14 @@
           <a:noFill/>
         </p:spPr>
         <p:txBody>
-          <a:bodyPr wrap="square" rtlCol="1">
+          <a:bodyPr wrap="square" rtlCol="1" anchor="ctr" tIns="0" bIns="0" lIns="0" rIns="0">
             <a:spAutoFit/>
           </a:bodyPr>
           <a:lstStyle/>
           <a:p>
             <a:pPr algn="ctr" rtl="1"/>
             <a:r>
-              <a:rPr lang="he-IL" sz="3600" b="1" dirty="0">
+              <a:rPr lang="he-IL" sz="2800" b="1" dirty="0">
                 <a:solidFill>
                   <a:schemeClr val="bg1"/>
                 </a:solidFill>
@@ -22882,7 +22693,7 @@
           <a:p>
             <a:pPr algn="ctr" rtl="1"/>
             <a:r>
-              <a:rPr lang="he-IL" sz="1600" dirty="0">
+              <a:rPr lang="he-IL" sz="1200" dirty="0">
                 <a:solidFill>
                   <a:schemeClr val="bg1"/>
                 </a:solidFill>
@@ -22900,7 +22711,7 @@
           <p:cNvPr id="5" name="Picture 4">
             <a:extLst>
               <a:ext uri="{FF2B5EF4-FFF2-40B4-BE49-F238E27FC236}">
-                <a16:creationId xmlns:a16="http://schemas.microsoft.com/office/drawing/2014/main" id="{EA0E0737-9A13-3187-0B8F-64280260EE8B}"/>
+                <ns3:creationId id="{EA0E0737-9A13-3187-0B8F-64280260EE8B}"/>
               </a:ext>
             </a:extLst>
           </p:cNvPr>
@@ -22910,10 +22721,10 @@
           <p:nvPr/>
         </p:nvPicPr>
         <p:blipFill>
-          <a:blip r:embed="rId3">
+          <a:blip ns2:embed="rId3">
             <a:extLst>
               <a:ext uri="{28A0092B-C50C-407E-A947-70E740481C1C}">
-                <a14:useLocalDpi xmlns:a14="http://schemas.microsoft.com/office/drawing/2010/main" val="0"/>
+                <ns5:useLocalDpi val="0"/>
               </a:ext>
             </a:extLst>
           </a:blip>
@@ -22923,8 +22734,8 @@
         </p:blipFill>
         <p:spPr>
           <a:xfrm>
-            <a:off x="-14514" y="0"/>
-            <a:ext cx="3061664" cy="4120370"/>
+            <a:off x="0" y="0"/>
+            <a:ext cx="3035808" cy="4114800"/>
           </a:xfrm>
           <a:prstGeom prst="rect">
             <a:avLst/>
@@ -22934,7 +22745,7 @@
     </p:spTree>
     <p:extLst>
       <p:ext uri="{BB962C8B-B14F-4D97-AF65-F5344CB8AC3E}">
-        <p14:creationId xmlns:p14="http://schemas.microsoft.com/office/powerpoint/2010/main" val="2354692379"/>
+        <ns4:creationId val="2354692379"/>
       </p:ext>
     </p:extLst>
   </p:cSld>

</xml_diff>

<commit_message>
Polish building card export template
</commit_message>
<xml_diff>
--- a/project/web-server/backend/Data/BuildingCardTemplate.pptx
+++ b/project/web-server/backend/Data/BuildingCardTemplate.pptx
@@ -21212,146 +21212,6 @@
       </p:sp>
       <p:sp>
         <p:nvSpPr>
-          <p:cNvPr id="17" name="תיבת טקסט 9">
-            <a:extLst>
-              <a:ext uri="{FF2B5EF4-FFF2-40B4-BE49-F238E27FC236}">
-                <ns3:creationId id="{2576C175-3BF1-9365-5DE4-6A895245D818}"/>
-              </a:ext>
-            </a:extLst>
-          </p:cNvPr>
-          <p:cNvSpPr txBox="1"/>
-          <p:nvPr/>
-        </p:nvSpPr>
-        <p:spPr>
-          <a:xfrm>
-            <a:off x="3072384" y="5230368"/>
-            <a:ext cx="4398264" cy="1280160"/>
-          </a:xfrm>
-          <a:prstGeom prst="rect">
-            <a:avLst/>
-          </a:prstGeom>
-          <a:solidFill>
-            <a:schemeClr val="bg1"/>
-          </a:solidFill>
-          <a:ln>
-            <a:noFill/>
-          </a:ln>
-        </p:spPr>
-        <p:txBody>
-          <a:bodyPr wrap="square" anchor="t" tIns="80000" bIns="60000" lIns="90000" rIns="90000">
-            <a:spAutoFit/>
-          </a:bodyPr>
-          <a:lstStyle/>
-          <a:p>
-            <a:pPr algn="r" rtl="1"/>
-            <a:r>
-              <a:rPr lang="he-IL" sz="3200" b="1" dirty="0">
-                <a:solidFill>
-                  <a:srgbClr val="305250"/>
-                </a:solidFill>
-                <a:latin typeface="Calibri" panose="020F0502020204030204" pitchFamily="34" charset="0"/>
-                <a:ea typeface="Calibri" panose="020F0502020204030204" pitchFamily="34" charset="0"/>
-                <a:cs typeface="Calibri" panose="020F0502020204030204" pitchFamily="34" charset="0"/>
-              </a:rPr>
-              <a:t>עמדת העירייה: {MUNI_POSITION}</a:t>
-            </a:r>
-          </a:p>
-        </p:txBody>
-      </p:sp>
-      <p:sp>
-        <p:nvSpPr>
-          <p:cNvPr id="18" name="תיבת טקסט 9">
-            <a:extLst>
-              <a:ext uri="{FF2B5EF4-FFF2-40B4-BE49-F238E27FC236}">
-                <ns3:creationId id="{2576C175-3BF1-9365-5DE4-6A895245D818}"/>
-              </a:ext>
-            </a:extLst>
-          </p:cNvPr>
-          <p:cNvSpPr txBox="1"/>
-          <p:nvPr/>
-        </p:nvSpPr>
-        <p:spPr>
-          <a:xfrm>
-            <a:off x="7653528" y="5230368"/>
-            <a:ext cx="4398264" cy="1280160"/>
-          </a:xfrm>
-          <a:prstGeom prst="rect">
-            <a:avLst/>
-          </a:prstGeom>
-          <a:solidFill>
-            <a:schemeClr val="bg1"/>
-          </a:solidFill>
-          <a:ln>
-            <a:noFill/>
-          </a:ln>
-        </p:spPr>
-        <p:txBody>
-          <a:bodyPr wrap="square" anchor="t" tIns="80000" bIns="60000" lIns="90000" rIns="90000">
-            <a:spAutoFit/>
-          </a:bodyPr>
-          <a:lstStyle/>
-          <a:p>
-            <a:pPr algn="r" rtl="1"/>
-            <a:r>
-              <a:rPr lang="he-IL" sz="3200" b="1" dirty="0">
-                <a:solidFill>
-                  <a:srgbClr val="305250"/>
-                </a:solidFill>
-                <a:latin typeface="Calibri" panose="020F0502020204030204" pitchFamily="34" charset="0"/>
-                <a:ea typeface="Calibri" panose="020F0502020204030204" pitchFamily="34" charset="0"/>
-                <a:cs typeface="Calibri" panose="020F0502020204030204" pitchFamily="34" charset="0"/>
-              </a:rPr>
-              <a:t>עמדת הבעלים: {OWNER_POSITION}</a:t>
-            </a:r>
-          </a:p>
-          <a:p>
-            <a:pPr algn="r" rtl="1"/>
-            <a:endParaRPr lang="he-IL" sz="1600" dirty="0">
-              <a:solidFill>
-                <a:srgbClr val="305250"/>
-              </a:solidFill>
-              <a:latin typeface="Calibri" panose="020F0502020204030204" pitchFamily="34" charset="0"/>
-              <a:ea typeface="Calibri" panose="020F0502020204030204" pitchFamily="34" charset="0"/>
-              <a:cs typeface="Calibri" panose="020F0502020204030204" pitchFamily="34" charset="0"/>
-            </a:endParaRPr>
-          </a:p>
-          <a:p>
-            <a:pPr algn="r" rtl="1"/>
-            <a:endParaRPr lang="he-IL" sz="2800" dirty="0">
-              <a:solidFill>
-                <a:srgbClr val="305250"/>
-              </a:solidFill>
-              <a:latin typeface="Calibri" panose="020F0502020204030204" pitchFamily="34" charset="0"/>
-              <a:ea typeface="Calibri" panose="020F0502020204030204" pitchFamily="34" charset="0"/>
-              <a:cs typeface="Calibri" panose="020F0502020204030204" pitchFamily="34" charset="0"/>
-            </a:endParaRPr>
-          </a:p>
-          <a:p>
-            <a:pPr algn="r" rtl="1"/>
-            <a:endParaRPr lang="he-IL" sz="3200" dirty="0">
-              <a:solidFill>
-                <a:srgbClr val="305250"/>
-              </a:solidFill>
-              <a:latin typeface="Calibri" panose="020F0502020204030204" pitchFamily="34" charset="0"/>
-              <a:ea typeface="Calibri" panose="020F0502020204030204" pitchFamily="34" charset="0"/>
-              <a:cs typeface="Calibri" panose="020F0502020204030204" pitchFamily="34" charset="0"/>
-            </a:endParaRPr>
-          </a:p>
-          <a:p>
-            <a:pPr algn="r" rtl="1"/>
-            <a:endParaRPr lang="he-IL" sz="3200" dirty="0">
-              <a:solidFill>
-                <a:srgbClr val="305250"/>
-              </a:solidFill>
-              <a:latin typeface="Calibri" panose="020F0502020204030204" pitchFamily="34" charset="0"/>
-              <a:ea typeface="Calibri" panose="020F0502020204030204" pitchFamily="34" charset="0"/>
-              <a:cs typeface="Calibri" panose="020F0502020204030204" pitchFamily="34" charset="0"/>
-            </a:endParaRPr>
-          </a:p>
-        </p:txBody>
-      </p:sp>
-      <p:sp>
-        <p:nvSpPr>
           <p:cNvPr id="19" name="תיבת טקסט 9">
             <a:extLst>
               <a:ext uri="{FF2B5EF4-FFF2-40B4-BE49-F238E27FC236}">
@@ -21364,8 +21224,8 @@
         </p:nvSpPr>
         <p:spPr>
           <a:xfrm>
-            <a:off x="6858000" y="36576"/>
-            <a:ext cx="5193792" cy="694944"/>
+            <a:off x="3072384" y="0"/>
+            <a:ext cx="8979408" cy="694944"/>
           </a:xfrm>
           <a:prstGeom prst="rect">
             <a:avLst/>
@@ -21383,13 +21243,13 @@
           </a:bodyPr>
           <a:lstStyle/>
           <a:p>
-            <a:pPr algn="r" rtl="1"/>
+            <a:pPr algn="ctr" rtl="1"/>
             <a:r>
               <a:rPr lang="he-IL" sz="5400" b="1" dirty="0">
                 <a:solidFill>
                   <a:srgbClr val="305250"/>
                 </a:solidFill>
-                <a:latin typeface="Calibri" panose="020F0502020204030204" pitchFamily="34" charset="0"/>
+                <a:latin typeface="Aptos" panose="020F0502020204030204" pitchFamily="34" charset="0"/>
                 <a:ea typeface="Calibri" panose="020F0502020204030204" pitchFamily="34" charset="0"/>
                 <a:cs typeface="Calibri" panose="020F0502020204030204" pitchFamily="34" charset="0"/>
               </a:rPr>
@@ -21412,17 +21272,14 @@
         </p:nvSpPr>
         <p:spPr>
           <a:xfrm>
-            <a:off x="9889236" y="3090672"/>
+            <a:off x="9889236" y="3392424"/>
             <a:ext cx="2162556" cy="841248"/>
           </a:xfrm>
           <a:prstGeom prst="rect">
             <a:avLst/>
           </a:prstGeom>
           <a:solidFill>
-            <a:schemeClr val="tx2">
-              <a:lumMod val="20000"/>
-              <a:lumOff val="80000"/>
-            </a:schemeClr>
+            <a:srgbClr val="D4E6EE"/>
           </a:solidFill>
           <a:ln>
             <a:noFill/>
@@ -21434,43 +21291,28 @@
           </a:bodyPr>
           <a:lstStyle/>
           <a:p>
-            <a:pPr algn="r" rtl="1"/>
+            <a:pPr algn="ctr" rtl="1"/>
             <a:r>
-              <a:rPr lang="he-IL" sz="3200" b="1" dirty="0">
+              <a:rPr sz="3200" b="1">
                 <a:solidFill>
-                  <a:srgbClr val="305250"/>
+                  <a:srgbClr val="2F5552"/>
                 </a:solidFill>
-                <a:latin typeface="Calibri" panose="020F0502020204030204" pitchFamily="34" charset="0"/>
-                <a:ea typeface="Calibri" panose="020F0502020204030204" pitchFamily="34" charset="0"/>
-                <a:cs typeface="Calibri" panose="020F0502020204030204" pitchFamily="34" charset="0"/>
+                <a:latin typeface="Aptos"/>
               </a:rPr>
               <a:t>יעוד</a:t>
             </a:r>
           </a:p>
           <a:p>
-            <a:pPr algn="r" rtl="1"/>
+            <a:pPr algn="ctr"/>
             <a:r>
-              <a:rPr lang="he-IL" sz="1400" dirty="0">
+              <a:rPr sz="1400" b="0">
                 <a:solidFill>
-                  <a:srgbClr val="305250"/>
+                  <a:srgbClr val="2F5552"/>
                 </a:solidFill>
-                <a:latin typeface="Calibri" panose="020F0502020204030204" pitchFamily="34" charset="0"/>
-                <a:ea typeface="Calibri" panose="020F0502020204030204" pitchFamily="34" charset="0"/>
-                <a:cs typeface="Calibri" panose="020F0502020204030204" pitchFamily="34" charset="0"/>
+                <a:latin typeface="Aptos"/>
               </a:rPr>
               <a:t>{YEUD}</a:t>
             </a:r>
-          </a:p>
-          <a:p>
-            <a:pPr algn="r" rtl="1"/>
-            <a:endParaRPr lang="he-IL" sz="1400" dirty="0">
-              <a:solidFill>
-                <a:srgbClr val="305250"/>
-              </a:solidFill>
-              <a:latin typeface="Calibri" panose="020F0502020204030204" pitchFamily="34" charset="0"/>
-              <a:ea typeface="Calibri" panose="020F0502020204030204" pitchFamily="34" charset="0"/>
-              <a:cs typeface="Calibri" panose="020F0502020204030204" pitchFamily="34" charset="0"/>
-            </a:endParaRPr>
           </a:p>
         </p:txBody>
       </p:sp>
@@ -21488,8 +21330,8 @@
         </p:nvSpPr>
         <p:spPr>
           <a:xfrm>
-            <a:off x="4526280" y="420624"/>
-            <a:ext cx="2697480" cy="384048"/>
+            <a:off x="3072384" y="676656"/>
+            <a:ext cx="8979408" cy="310896"/>
           </a:xfrm>
           <a:prstGeom prst="rect">
             <a:avLst/>
@@ -21507,15 +21349,13 @@
           </a:bodyPr>
           <a:lstStyle/>
           <a:p>
-            <a:pPr algn="r" rtl="1"/>
+            <a:pPr algn="ctr" rtl="1"/>
             <a:r>
               <a:rPr lang="he-IL" sz="2000" dirty="0">
                 <a:solidFill>
-                  <a:schemeClr val="bg1">
-                    <a:lumMod val="65000"/>
-                  </a:schemeClr>
+                  <a:srgbClr val="A6A6A6"/>
                 </a:solidFill>
-                <a:latin typeface="Calibri" panose="020F0502020204030204" pitchFamily="34" charset="0"/>
+                <a:latin typeface="Aptos" panose="020F0502020204030204" pitchFamily="34" charset="0"/>
                 <a:ea typeface="Calibri" panose="020F0502020204030204" pitchFamily="34" charset="0"/>
                 <a:cs typeface="Calibri" panose="020F0502020204030204" pitchFamily="34" charset="0"/>
               </a:rPr>
@@ -21538,14 +21378,14 @@
         </p:nvSpPr>
         <p:spPr>
           <a:xfrm>
-            <a:off x="3072384" y="2450592"/>
+            <a:off x="3072384" y="2752344"/>
             <a:ext cx="8979408" cy="512064"/>
           </a:xfrm>
           <a:prstGeom prst="rect">
             <a:avLst/>
           </a:prstGeom>
           <a:solidFill>
-            <a:srgbClr val="92D050"/>
+            <a:srgbClr val="8ED052"/>
           </a:solidFill>
           <a:ln>
             <a:noFill/>
@@ -21557,29 +21397,16 @@
           </a:bodyPr>
           <a:lstStyle/>
           <a:p>
-            <a:pPr algn="r" rtl="1"/>
+            <a:pPr algn="ctr" rtl="1"/>
             <a:r>
-              <a:rPr lang="he-IL" sz="3200" b="1" dirty="0">
+              <a:rPr sz="3200" b="1">
                 <a:solidFill>
-                  <a:srgbClr val="305250"/>
+                  <a:srgbClr val="2F5552"/>
                 </a:solidFill>
-                <a:latin typeface="Calibri" panose="020F0502020204030204" pitchFamily="34" charset="0"/>
-                <a:ea typeface="Calibri" panose="020F0502020204030204" pitchFamily="34" charset="0"/>
-                <a:cs typeface="Calibri" panose="020F0502020204030204" pitchFamily="34" charset="0"/>
+                <a:latin typeface="Aptos"/>
               </a:rPr>
               <a:t>סיווג: {SIVUG}</a:t>
             </a:r>
-          </a:p>
-          <a:p>
-            <a:pPr algn="r" rtl="1"/>
-            <a:endParaRPr lang="he-IL" sz="1400" dirty="0">
-              <a:solidFill>
-                <a:srgbClr val="305250"/>
-              </a:solidFill>
-              <a:latin typeface="Calibri" panose="020F0502020204030204" pitchFamily="34" charset="0"/>
-              <a:ea typeface="Calibri" panose="020F0502020204030204" pitchFamily="34" charset="0"/>
-              <a:cs typeface="Calibri" panose="020F0502020204030204" pitchFamily="34" charset="0"/>
-            </a:endParaRPr>
           </a:p>
         </p:txBody>
       </p:sp>
@@ -21591,16 +21418,14 @@
         </p:nvSpPr>
         <p:spPr>
           <a:xfrm>
-            <a:off x="3072384" y="1938528"/>
+            <a:off x="3072384" y="2240280"/>
             <a:ext cx="8979408" cy="420624"/>
           </a:xfrm>
           <a:prstGeom prst="rect">
             <a:avLst/>
           </a:prstGeom>
           <a:solidFill>
-            <a:schemeClr val="bg2">
-              <a:lumMod val="75000"/>
-            </a:schemeClr>
+            <a:srgbClr val="AEBBC0"/>
           </a:solidFill>
           <a:ln>
             <a:noFill/>
@@ -21612,13 +21437,13 @@
           </a:bodyPr>
           <a:lstStyle/>
           <a:p>
-            <a:pPr algn="r" rtl="1"/>
+            <a:pPr algn="ctr" rtl="1"/>
             <a:r>
               <a:rPr lang="he-IL" sz="3200" b="1" dirty="0">
                 <a:solidFill>
-                  <a:srgbClr val="305250"/>
+                  <a:srgbClr val="2F5552"/>
                 </a:solidFill>
-                <a:latin typeface="Calibri" panose="020F0502020204030204" pitchFamily="34" charset="0"/>
+                <a:latin typeface="Aptos" panose="020F0502020204030204" pitchFamily="34" charset="0"/>
                 <a:ea typeface="Calibri" panose="020F0502020204030204" pitchFamily="34" charset="0"/>
                 <a:cs typeface="Calibri" panose="020F0502020204030204" pitchFamily="34" charset="0"/>
               </a:rPr>
@@ -21635,14 +21460,14 @@
         </p:nvSpPr>
         <p:spPr>
           <a:xfrm>
-            <a:off x="3474720" y="877824"/>
+            <a:off x="4088891" y="1078992"/>
             <a:ext cx="960120" cy="960120"/>
           </a:xfrm>
           <a:prstGeom prst="ellipse">
             <a:avLst/>
           </a:prstGeom>
           <a:solidFill>
-            <a:srgbClr val="FF0000"/>
+            <a:srgbClr val="E84A3A"/>
           </a:solidFill>
           <a:ln>
             <a:noFill/>
@@ -21679,9 +21504,9 @@
             <a:r>
               <a:rPr lang="he-IL" sz="7200" b="1" dirty="0">
                 <a:solidFill>
-                  <a:schemeClr val="bg1"/>
+                  <a:srgbClr val="FFFFFF"/>
                 </a:solidFill>
-                <a:latin typeface="Calibri" panose="020F0502020204030204" pitchFamily="34" charset="0"/>
+                <a:latin typeface="Aptos" panose="020F0502020204030204" pitchFamily="34" charset="0"/>
                 <a:ea typeface="Calibri" panose="020F0502020204030204" pitchFamily="34" charset="0"/>
                 <a:cs typeface="Calibri" panose="020F0502020204030204" pitchFamily="34" charset="0"/>
               </a:rPr>
@@ -21705,7 +21530,7 @@
           </p:nvPr>
         </p:nvGraphicFramePr>
         <p:xfrm>
-          <a:off x="3072384" y="4078224"/>
+          <a:off x="3072384" y="4379976"/>
           <a:ext cx="8979408" cy="950976"/>
         </p:xfrm>
         <a:graphic>
@@ -21750,13 +21575,13 @@
                     <a:bodyPr anchor="ctr" tIns="0" bIns="0" lIns="0" rIns="0"/>
                     <a:lstStyle/>
                     <a:p>
-                      <a:pPr algn="r" rtl="1"/>
+                      <a:pPr algn="ctr" rtl="1"/>
                       <a:r>
                         <a:rPr lang="he-IL" sz="3200" b="1" kern="1200" dirty="0">
                           <a:solidFill>
-                            <a:srgbClr val="305250"/>
+                            <a:srgbClr val="2F5552"/>
                           </a:solidFill>
-                          <a:latin typeface="Calibri" panose="020F0502020204030204" pitchFamily="34" charset="0"/>
+                          <a:latin typeface="Aptos" panose="020F0502020204030204" pitchFamily="34" charset="0"/>
                           <a:ea typeface="Calibri" panose="020F0502020204030204" pitchFamily="34" charset="0"/>
                           <a:cs typeface="Calibri" panose="020F0502020204030204" pitchFamily="34" charset="0"/>
                         </a:rPr>
@@ -21764,7 +21589,7 @@
                       </a:r>
                     </a:p>
                   </a:txBody>
-                  <a:tcPr>
+                  <a:tcPr anchor="ctr" marL="0" marR="0" marT="0" marB="0">
                     <a:lnL w="12700" cap="flat" cmpd="sng" algn="ctr">
                       <a:noFill/>
                       <a:prstDash val="solid"/>
@@ -21802,7 +21627,7 @@
                       <a:prstDash val="solid"/>
                     </a:lnBlToTr>
                     <a:solidFill>
-                      <a:srgbClr val="D4EBDB"/>
+                      <a:srgbClr val="D9F0E2"/>
                     </a:solidFill>
                   </a:tcPr>
                 </a:tc>
@@ -21811,10 +21636,13 @@
                     <a:bodyPr anchor="ctr" tIns="0" bIns="0" lIns="0" rIns="0"/>
                     <a:lstStyle/>
                     <a:p>
-                      <a:pPr rtl="1"/>
+                      <a:pPr rtl="1" algn="ctr"/>
                       <a:r>
                         <a:rPr lang="he-IL" dirty="0">
-                          <a:latin typeface="Calibri" panose="020F0502020204030204" pitchFamily="34" charset="0"/>
+                          <a:solidFill>
+                            <a:srgbClr val="2F5552"/>
+                          </a:solidFill>
+                          <a:latin typeface="Aptos" panose="020F0502020204030204" pitchFamily="34" charset="0"/>
                           <a:ea typeface="Calibri" panose="020F0502020204030204" pitchFamily="34" charset="0"/>
                           <a:cs typeface="Calibri" panose="020F0502020204030204" pitchFamily="34" charset="0"/>
                         </a:rPr>
@@ -21822,7 +21650,7 @@
                       </a:r>
                     </a:p>
                   </a:txBody>
-                  <a:tcPr>
+                  <a:tcPr anchor="ctr" marL="0" marR="0" marT="0" marB="0">
                     <a:lnL w="12700" cap="flat" cmpd="sng" algn="ctr">
                       <a:noFill/>
                       <a:prstDash val="solid"/>
@@ -21860,7 +21688,7 @@
                       <a:prstDash val="solid"/>
                     </a:lnBlToTr>
                     <a:solidFill>
-                      <a:srgbClr val="D4EBDB"/>
+                      <a:srgbClr val="D9F0E2"/>
                     </a:solidFill>
                   </a:tcPr>
                 </a:tc>
@@ -21869,10 +21697,13 @@
                     <a:bodyPr anchor="ctr" tIns="0" bIns="0" lIns="0" rIns="0"/>
                     <a:lstStyle/>
                     <a:p>
-                      <a:pPr rtl="1"/>
+                      <a:pPr rtl="1" algn="ctr"/>
                       <a:r>
                         <a:rPr lang="he-IL" dirty="0">
-                          <a:latin typeface="Calibri" panose="020F0502020204030204" pitchFamily="34" charset="0"/>
+                          <a:solidFill>
+                            <a:srgbClr val="2F5552"/>
+                          </a:solidFill>
+                          <a:latin typeface="Aptos" panose="020F0502020204030204" pitchFamily="34" charset="0"/>
                           <a:ea typeface="Calibri" panose="020F0502020204030204" pitchFamily="34" charset="0"/>
                           <a:cs typeface="Calibri" panose="020F0502020204030204" pitchFamily="34" charset="0"/>
                         </a:rPr>
@@ -21880,7 +21711,7 @@
                       </a:r>
                     </a:p>
                   </a:txBody>
-                  <a:tcPr>
+                  <a:tcPr anchor="ctr" marL="0" marR="0" marT="0" marB="0">
                     <a:lnL w="12700" cap="flat" cmpd="sng" algn="ctr">
                       <a:noFill/>
                       <a:prstDash val="solid"/>
@@ -21918,7 +21749,7 @@
                       <a:prstDash val="solid"/>
                     </a:lnBlToTr>
                     <a:solidFill>
-                      <a:srgbClr val="D4EBDB"/>
+                      <a:srgbClr val="D9F0E2"/>
                     </a:solidFill>
                   </a:tcPr>
                 </a:tc>
@@ -21927,10 +21758,13 @@
                     <a:bodyPr anchor="ctr" tIns="0" bIns="0" lIns="0" rIns="0"/>
                     <a:lstStyle/>
                     <a:p>
-                      <a:pPr rtl="1"/>
+                      <a:pPr rtl="1" algn="ctr"/>
                       <a:r>
                         <a:rPr lang="he-IL" dirty="0">
-                          <a:latin typeface="Calibri" panose="020F0502020204030204" pitchFamily="34" charset="0"/>
+                          <a:solidFill>
+                            <a:srgbClr val="2F5552"/>
+                          </a:solidFill>
+                          <a:latin typeface="Aptos" panose="020F0502020204030204" pitchFamily="34" charset="0"/>
                           <a:ea typeface="Calibri" panose="020F0502020204030204" pitchFamily="34" charset="0"/>
                           <a:cs typeface="Calibri" panose="020F0502020204030204" pitchFamily="34" charset="0"/>
                         </a:rPr>
@@ -21938,7 +21772,7 @@
                       </a:r>
                     </a:p>
                   </a:txBody>
-                  <a:tcPr>
+                  <a:tcPr anchor="ctr" marL="0" marR="0" marT="0" marB="0">
                     <a:lnL w="12700" cap="flat" cmpd="sng" algn="ctr">
                       <a:noFill/>
                       <a:prstDash val="solid"/>
@@ -21976,7 +21810,7 @@
                       <a:prstDash val="solid"/>
                     </a:lnBlToTr>
                     <a:solidFill>
-                      <a:srgbClr val="D4EBDB"/>
+                      <a:srgbClr val="D9F0E2"/>
                     </a:solidFill>
                   </a:tcPr>
                 </a:tc>
@@ -21992,11 +21826,11 @@
                     <a:bodyPr anchor="ctr" tIns="0" bIns="0" lIns="0" rIns="0"/>
                     <a:lstStyle/>
                     <a:p>
-                      <a:pPr rtl="1"/>
+                      <a:pPr rtl="1" algn="ctr"/>
                       <a:endParaRPr lang="he-IL" dirty="0"/>
                     </a:p>
                   </a:txBody>
-                  <a:tcPr>
+                  <a:tcPr anchor="ctr" marL="0" marR="0" marT="0" marB="0">
                     <a:lnL w="12700" cap="flat" cmpd="sng" algn="ctr">
                       <a:solidFill>
                         <a:schemeClr val="tx1"/>
@@ -22041,6 +21875,9 @@
                       <a:noFill/>
                       <a:prstDash val="solid"/>
                     </a:lnBlToTr>
+                    <a:solidFill>
+                      <a:srgbClr val="D9F0E2"/>
+                    </a:solidFill>
                   </a:tcPr>
                 </a:tc>
                 <a:tc>
@@ -22048,10 +21885,13 @@
                     <a:bodyPr anchor="ctr" tIns="0" bIns="0" lIns="0" rIns="0"/>
                     <a:lstStyle/>
                     <a:p>
-                      <a:pPr rtl="1"/>
+                      <a:pPr rtl="1" algn="ctr"/>
                       <a:r>
                         <a:rPr lang="en-US" sz="2400" dirty="0">
-                          <a:latin typeface="Calibri" panose="020F0502020204030204" pitchFamily="34" charset="0"/>
+                          <a:solidFill>
+                            <a:srgbClr val="2F5552"/>
+                          </a:solidFill>
+                          <a:latin typeface="Aptos" panose="020F0502020204030204" pitchFamily="34" charset="0"/>
                           <a:ea typeface="Calibri" panose="020F0502020204030204" pitchFamily="34" charset="0"/>
                           <a:cs typeface="Calibri" panose="020F0502020204030204" pitchFamily="34" charset="0"/>
                         </a:rPr>
@@ -22064,7 +21904,7 @@
                       </a:endParaRPr>
                     </a:p>
                   </a:txBody>
-                  <a:tcPr>
+                  <a:tcPr anchor="ctr" marL="0" marR="0" marT="0" marB="0">
                     <a:lnL w="12700" cap="flat" cmpd="sng" algn="ctr">
                       <a:noFill/>
                       <a:prstDash val="solid"/>
@@ -22102,7 +21942,7 @@
                       <a:prstDash val="solid"/>
                     </a:lnBlToTr>
                     <a:solidFill>
-                      <a:srgbClr val="D4EBDB"/>
+                      <a:srgbClr val="D9F0E2"/>
                     </a:solidFill>
                   </a:tcPr>
                 </a:tc>
@@ -22111,13 +21951,13 @@
                     <a:bodyPr anchor="ctr" tIns="0" bIns="0" lIns="0" rIns="0"/>
                     <a:lstStyle/>
                     <a:p>
-                      <a:pPr rtl="1"/>
+                      <a:pPr rtl="1" algn="ctr"/>
                       <a:r>
                         <a:rPr lang="en-US" sz="2400" kern="1200" dirty="0">
                           <a:solidFill>
-                            <a:schemeClr val="tx1"/>
+                            <a:srgbClr val="2F5552"/>
                           </a:solidFill>
-                          <a:latin typeface="Calibri" panose="020F0502020204030204" pitchFamily="34" charset="0"/>
+                          <a:latin typeface="Aptos" panose="020F0502020204030204" pitchFamily="34" charset="0"/>
                           <a:ea typeface="Calibri" panose="020F0502020204030204" pitchFamily="34" charset="0"/>
                           <a:cs typeface="Calibri" panose="020F0502020204030204" pitchFamily="34" charset="0"/>
                         </a:rPr>
@@ -22133,7 +21973,7 @@
                       </a:endParaRPr>
                     </a:p>
                   </a:txBody>
-                  <a:tcPr>
+                  <a:tcPr anchor="ctr" marL="0" marR="0" marT="0" marB="0">
                     <a:lnL w="12700" cap="flat" cmpd="sng" algn="ctr">
                       <a:noFill/>
                       <a:prstDash val="solid"/>
@@ -22171,7 +22011,7 @@
                       <a:prstDash val="solid"/>
                     </a:lnBlToTr>
                     <a:solidFill>
-                      <a:srgbClr val="D4EBDB"/>
+                      <a:srgbClr val="D9F0E2"/>
                     </a:solidFill>
                   </a:tcPr>
                 </a:tc>
@@ -22180,13 +22020,13 @@
                     <a:bodyPr anchor="ctr" tIns="0" bIns="0" lIns="0" rIns="0"/>
                     <a:lstStyle/>
                     <a:p>
-                      <a:pPr rtl="1"/>
+                      <a:pPr rtl="1" algn="ctr"/>
                       <a:r>
                         <a:rPr lang="en-US" sz="2400" kern="1200" dirty="0">
                           <a:solidFill>
-                            <a:schemeClr val="tx1"/>
+                            <a:srgbClr val="2F5552"/>
                           </a:solidFill>
-                          <a:latin typeface="Calibri" panose="020F0502020204030204" pitchFamily="34" charset="0"/>
+                          <a:latin typeface="Aptos" panose="020F0502020204030204" pitchFamily="34" charset="0"/>
                           <a:ea typeface="Calibri" panose="020F0502020204030204" pitchFamily="34" charset="0"/>
                           <a:cs typeface="Calibri" panose="020F0502020204030204" pitchFamily="34" charset="0"/>
                         </a:rPr>
@@ -22202,7 +22042,7 @@
                       </a:endParaRPr>
                     </a:p>
                   </a:txBody>
-                  <a:tcPr>
+                  <a:tcPr anchor="ctr" marL="0" marR="0" marT="0" marB="0">
                     <a:lnL w="12700" cap="flat" cmpd="sng" algn="ctr">
                       <a:noFill/>
                       <a:prstDash val="solid"/>
@@ -22240,7 +22080,7 @@
                       <a:prstDash val="solid"/>
                     </a:lnBlToTr>
                     <a:solidFill>
-                      <a:srgbClr val="D4EBDB"/>
+                      <a:srgbClr val="D9F0E2"/>
                     </a:solidFill>
                   </a:tcPr>
                 </a:tc>
@@ -22268,17 +22108,14 @@
         </p:nvSpPr>
         <p:spPr>
           <a:xfrm>
-            <a:off x="3072384" y="3090672"/>
+            <a:off x="3072384" y="3392424"/>
             <a:ext cx="2162556" cy="841248"/>
           </a:xfrm>
           <a:prstGeom prst="rect">
             <a:avLst/>
           </a:prstGeom>
           <a:solidFill>
-            <a:schemeClr val="tx2">
-              <a:lumMod val="20000"/>
-              <a:lumOff val="80000"/>
-            </a:schemeClr>
+            <a:srgbClr val="D4E6EE"/>
           </a:solidFill>
           <a:ln>
             <a:noFill/>
@@ -22290,43 +22127,28 @@
           </a:bodyPr>
           <a:lstStyle/>
           <a:p>
-            <a:pPr algn="r" rtl="1"/>
+            <a:pPr algn="ctr" rtl="1"/>
             <a:r>
-              <a:rPr lang="he-IL" sz="3200" b="1" dirty="0">
+              <a:rPr sz="3200" b="1">
                 <a:solidFill>
-                  <a:srgbClr val="305250"/>
+                  <a:srgbClr val="2F5552"/>
                 </a:solidFill>
-                <a:latin typeface="Calibri" panose="020F0502020204030204" pitchFamily="34" charset="0"/>
-                <a:ea typeface="Calibri" panose="020F0502020204030204" pitchFamily="34" charset="0"/>
-                <a:cs typeface="Calibri" panose="020F0502020204030204" pitchFamily="34" charset="0"/>
+                <a:latin typeface="Aptos"/>
               </a:rPr>
               <a:t>תכנון</a:t>
             </a:r>
           </a:p>
           <a:p>
-            <a:pPr algn="r" rtl="1"/>
+            <a:pPr algn="ctr"/>
             <a:r>
-              <a:rPr lang="he-IL" sz="1400" dirty="0">
+              <a:rPr sz="1400" b="0">
                 <a:solidFill>
-                  <a:srgbClr val="305250"/>
+                  <a:srgbClr val="2F5552"/>
                 </a:solidFill>
-                <a:latin typeface="Calibri" panose="020F0502020204030204" pitchFamily="34" charset="0"/>
-                <a:ea typeface="Calibri" panose="020F0502020204030204" pitchFamily="34" charset="0"/>
-                <a:cs typeface="Calibri" panose="020F0502020204030204" pitchFamily="34" charset="0"/>
+                <a:latin typeface="Aptos"/>
               </a:rPr>
               <a:t>{KIDUM_TICHNUN}</a:t>
             </a:r>
-          </a:p>
-          <a:p>
-            <a:pPr algn="r" rtl="1"/>
-            <a:endParaRPr lang="he-IL" sz="1400" dirty="0">
-              <a:solidFill>
-                <a:srgbClr val="305250"/>
-              </a:solidFill>
-              <a:latin typeface="Calibri" panose="020F0502020204030204" pitchFamily="34" charset="0"/>
-              <a:ea typeface="Calibri" panose="020F0502020204030204" pitchFamily="34" charset="0"/>
-              <a:cs typeface="Calibri" panose="020F0502020204030204" pitchFamily="34" charset="0"/>
-            </a:endParaRPr>
           </a:p>
         </p:txBody>
       </p:sp>
@@ -22344,17 +22166,14 @@
         </p:nvSpPr>
         <p:spPr>
           <a:xfrm>
-            <a:off x="7616952" y="3090672"/>
+            <a:off x="7616952" y="3392424"/>
             <a:ext cx="2162556" cy="841248"/>
           </a:xfrm>
           <a:prstGeom prst="rect">
             <a:avLst/>
           </a:prstGeom>
           <a:solidFill>
-            <a:schemeClr val="tx2">
-              <a:lumMod val="20000"/>
-              <a:lumOff val="80000"/>
-            </a:schemeClr>
+            <a:srgbClr val="D4E6EE"/>
           </a:solidFill>
           <a:ln>
             <a:noFill/>
@@ -22366,43 +22185,28 @@
           </a:bodyPr>
           <a:lstStyle/>
           <a:p>
-            <a:pPr algn="r" rtl="1"/>
+            <a:pPr algn="ctr" rtl="1"/>
             <a:r>
-              <a:rPr lang="he-IL" sz="3200" b="1" dirty="0">
+              <a:rPr sz="3200" b="1">
                 <a:solidFill>
-                  <a:srgbClr val="305250"/>
+                  <a:srgbClr val="2F5552"/>
                 </a:solidFill>
-                <a:latin typeface="Calibri" panose="020F0502020204030204" pitchFamily="34" charset="0"/>
-                <a:ea typeface="Calibri" panose="020F0502020204030204" pitchFamily="34" charset="0"/>
-                <a:cs typeface="Calibri" panose="020F0502020204030204" pitchFamily="34" charset="0"/>
+                <a:latin typeface="Aptos"/>
               </a:rPr>
               <a:t>שימור</a:t>
             </a:r>
           </a:p>
           <a:p>
-            <a:pPr algn="r" rtl="1"/>
+            <a:pPr algn="ctr"/>
             <a:r>
-              <a:rPr lang="he-IL" sz="1400" dirty="0">
+              <a:rPr sz="1400" b="0">
                 <a:solidFill>
-                  <a:srgbClr val="305250"/>
+                  <a:srgbClr val="2F5552"/>
                 </a:solidFill>
-                <a:latin typeface="Calibri" panose="020F0502020204030204" pitchFamily="34" charset="0"/>
-                <a:ea typeface="Calibri" panose="020F0502020204030204" pitchFamily="34" charset="0"/>
-                <a:cs typeface="Calibri" panose="020F0502020204030204" pitchFamily="34" charset="0"/>
+                <a:latin typeface="Aptos"/>
               </a:rPr>
               <a:t>{SHIMUR_YEUD}</a:t>
             </a:r>
-          </a:p>
-          <a:p>
-            <a:pPr algn="r" rtl="1"/>
-            <a:endParaRPr lang="he-IL" sz="1400" dirty="0">
-              <a:solidFill>
-                <a:srgbClr val="305250"/>
-              </a:solidFill>
-              <a:latin typeface="Calibri" panose="020F0502020204030204" pitchFamily="34" charset="0"/>
-              <a:ea typeface="Calibri" panose="020F0502020204030204" pitchFamily="34" charset="0"/>
-              <a:cs typeface="Calibri" panose="020F0502020204030204" pitchFamily="34" charset="0"/>
-            </a:endParaRPr>
           </a:p>
         </p:txBody>
       </p:sp>
@@ -22420,17 +22224,14 @@
         </p:nvSpPr>
         <p:spPr>
           <a:xfrm>
-            <a:off x="5344668" y="3090672"/>
+            <a:off x="5344668" y="3392424"/>
             <a:ext cx="2162556" cy="841248"/>
           </a:xfrm>
           <a:prstGeom prst="rect">
             <a:avLst/>
           </a:prstGeom>
           <a:solidFill>
-            <a:schemeClr val="tx2">
-              <a:lumMod val="20000"/>
-              <a:lumOff val="80000"/>
-            </a:schemeClr>
+            <a:srgbClr val="D4E6EE"/>
           </a:solidFill>
           <a:ln>
             <a:noFill/>
@@ -22442,43 +22243,28 @@
           </a:bodyPr>
           <a:lstStyle/>
           <a:p>
-            <a:pPr algn="r" rtl="1"/>
+            <a:pPr algn="ctr" rtl="1"/>
             <a:r>
-              <a:rPr lang="he-IL" sz="3200" b="1" dirty="0">
+              <a:rPr sz="3200" b="1">
                 <a:solidFill>
-                  <a:srgbClr val="305250"/>
+                  <a:srgbClr val="2F5552"/>
                 </a:solidFill>
-                <a:latin typeface="Calibri" panose="020F0502020204030204" pitchFamily="34" charset="0"/>
-                <a:ea typeface="Calibri" panose="020F0502020204030204" pitchFamily="34" charset="0"/>
-                <a:cs typeface="Calibri" panose="020F0502020204030204" pitchFamily="34" charset="0"/>
+                <a:latin typeface="Aptos"/>
               </a:rPr>
               <a:t>רישוי</a:t>
             </a:r>
           </a:p>
           <a:p>
-            <a:pPr algn="r" rtl="1"/>
+            <a:pPr algn="ctr"/>
             <a:r>
-              <a:rPr lang="he-IL" sz="1400" dirty="0">
+              <a:rPr sz="1400" b="0">
                 <a:solidFill>
-                  <a:srgbClr val="305250"/>
+                  <a:srgbClr val="2F5552"/>
                 </a:solidFill>
-                <a:latin typeface="Calibri" panose="020F0502020204030204" pitchFamily="34" charset="0"/>
-                <a:ea typeface="Calibri" panose="020F0502020204030204" pitchFamily="34" charset="0"/>
-                <a:cs typeface="Calibri" panose="020F0502020204030204" pitchFamily="34" charset="0"/>
+                <a:latin typeface="Aptos"/>
               </a:rPr>
               <a:t>{BUILDING_PERMIT}</a:t>
             </a:r>
-          </a:p>
-          <a:p>
-            <a:pPr algn="r" rtl="1"/>
-            <a:endParaRPr lang="he-IL" sz="1400" dirty="0">
-              <a:solidFill>
-                <a:srgbClr val="305250"/>
-              </a:solidFill>
-              <a:latin typeface="Calibri" panose="020F0502020204030204" pitchFamily="34" charset="0"/>
-              <a:ea typeface="Calibri" panose="020F0502020204030204" pitchFamily="34" charset="0"/>
-              <a:cs typeface="Calibri" panose="020F0502020204030204" pitchFamily="34" charset="0"/>
-            </a:endParaRPr>
           </a:p>
         </p:txBody>
       </p:sp>
@@ -22490,16 +22276,14 @@
         </p:nvSpPr>
         <p:spPr>
           <a:xfrm>
-            <a:off x="5989320" y="877824"/>
+            <a:off x="7082027" y="1078992"/>
             <a:ext cx="960120" cy="960120"/>
           </a:xfrm>
           <a:prstGeom prst="ellipse">
             <a:avLst/>
           </a:prstGeom>
           <a:solidFill>
-            <a:schemeClr val="bg1">
-              <a:lumMod val="75000"/>
-            </a:schemeClr>
+            <a:srgbClr val="9FAEB2"/>
           </a:solidFill>
           <a:ln>
             <a:noFill/>
@@ -22552,7 +22336,7 @@
         </p:nvSpPr>
         <p:spPr>
           <a:xfrm>
-            <a:off x="5989320" y="877824"/>
+            <a:off x="7082027" y="1078992"/>
             <a:ext cx="960120" cy="960120"/>
           </a:xfrm>
           <a:prstGeom prst="rect">
@@ -22570,9 +22354,9 @@
             <a:r>
               <a:rPr lang="he-IL" sz="3600" b="1" dirty="0">
                 <a:solidFill>
-                  <a:schemeClr val="bg1"/>
+                  <a:srgbClr val="FFFFFF"/>
                 </a:solidFill>
-                <a:latin typeface="Calibri" panose="020F0502020204030204" pitchFamily="34" charset="0"/>
+                <a:latin typeface="Aptos" panose="020F0502020204030204" pitchFamily="34" charset="0"/>
                 <a:ea typeface="Calibri" panose="020F0502020204030204" pitchFamily="34" charset="0"/>
                 <a:cs typeface="Calibri" panose="020F0502020204030204" pitchFamily="34" charset="0"/>
               </a:rPr>
@@ -22584,9 +22368,9 @@
             <a:r>
               <a:rPr lang="he-IL" sz="1600" dirty="0">
                 <a:solidFill>
-                  <a:schemeClr val="bg1"/>
+                  <a:srgbClr val="FFFFFF"/>
                 </a:solidFill>
-                <a:latin typeface="Calibri" panose="020F0502020204030204" pitchFamily="34" charset="0"/>
+                <a:latin typeface="Aptos" panose="020F0502020204030204" pitchFamily="34" charset="0"/>
                 <a:ea typeface="Calibri" panose="020F0502020204030204" pitchFamily="34" charset="0"/>
                 <a:cs typeface="Calibri" panose="020F0502020204030204" pitchFamily="34" charset="0"/>
               </a:rPr>
@@ -22603,14 +22387,14 @@
         </p:nvSpPr>
         <p:spPr>
           <a:xfrm>
-            <a:off x="8503920" y="877824"/>
+            <a:off x="10075164" y="1078992"/>
             <a:ext cx="960120" cy="960120"/>
           </a:xfrm>
           <a:prstGeom prst="ellipse">
             <a:avLst/>
           </a:prstGeom>
           <a:solidFill>
-            <a:srgbClr val="EAB200"/>
+            <a:srgbClr val="E8AE22"/>
           </a:solidFill>
           <a:ln>
             <a:noFill/>
@@ -22663,7 +22447,7 @@
         </p:nvSpPr>
         <p:spPr>
           <a:xfrm>
-            <a:off x="8503920" y="877824"/>
+            <a:off x="10075164" y="1078992"/>
             <a:ext cx="960120" cy="960120"/>
           </a:xfrm>
           <a:prstGeom prst="rect">
@@ -22681,9 +22465,9 @@
             <a:r>
               <a:rPr lang="he-IL" sz="2800" b="1" dirty="0">
                 <a:solidFill>
-                  <a:schemeClr val="bg1"/>
+                  <a:srgbClr val="FFFFFF"/>
                 </a:solidFill>
-                <a:latin typeface="Calibri" panose="020F0502020204030204" pitchFamily="34" charset="0"/>
+                <a:latin typeface="Aptos" panose="020F0502020204030204" pitchFamily="34" charset="0"/>
                 <a:ea typeface="Calibri" panose="020F0502020204030204" pitchFamily="34" charset="0"/>
                 <a:cs typeface="Calibri" panose="020F0502020204030204" pitchFamily="34" charset="0"/>
               </a:rPr>
@@ -22695,9 +22479,9 @@
             <a:r>
               <a:rPr lang="he-IL" sz="1200" dirty="0">
                 <a:solidFill>
-                  <a:schemeClr val="bg1"/>
+                  <a:srgbClr val="FFFFFF"/>
                 </a:solidFill>
-                <a:latin typeface="Calibri" panose="020F0502020204030204" pitchFamily="34" charset="0"/>
+                <a:latin typeface="Aptos" panose="020F0502020204030204" pitchFamily="34" charset="0"/>
                 <a:ea typeface="Calibri" panose="020F0502020204030204" pitchFamily="34" charset="0"/>
                 <a:cs typeface="Calibri" panose="020F0502020204030204" pitchFamily="34" charset="0"/>
               </a:rPr>
@@ -22742,6 +22526,122 @@
           </a:prstGeom>
         </p:spPr>
       </p:pic>
+      <p:sp>
+        <p:nvSpPr>
+          <p:cNvPr id="17" name="תיבת טקסט 9">
+            <a:extLst>
+              <a:ext uri="{FF2B5EF4-FFF2-40B4-BE49-F238E27FC236}">
+                <ns3:creationId id="{2576C175-3BF1-9365-5DE4-6A895245D818}"/>
+              </a:ext>
+            </a:extLst>
+          </p:cNvPr>
+          <p:cNvSpPr txBox="1"/>
+          <p:nvPr/>
+        </p:nvSpPr>
+        <p:spPr>
+          <a:xfrm>
+            <a:off x="3072384" y="5504688"/>
+            <a:ext cx="4398264" cy="932688"/>
+          </a:xfrm>
+          <a:prstGeom prst="rect">
+            <a:avLst/>
+          </a:prstGeom>
+          <a:solidFill>
+            <a:srgbClr val="EDF6F2"/>
+          </a:solidFill>
+          <a:ln>
+            <a:noFill/>
+          </a:ln>
+        </p:spPr>
+        <p:txBody>
+          <a:bodyPr wrap="square" anchor="ctr" tIns="0" bIns="0" lIns="0" rIns="0">
+            <a:spAutoFit/>
+          </a:bodyPr>
+          <a:lstStyle/>
+          <a:p>
+            <a:pPr algn="ctr" rtl="1"/>
+            <a:r>
+              <a:rPr sz="2200" b="1">
+                <a:solidFill>
+                  <a:srgbClr val="2F5552"/>
+                </a:solidFill>
+                <a:latin typeface="Aptos"/>
+              </a:rPr>
+              <a:t>עמדת העירייה</a:t>
+            </a:r>
+          </a:p>
+          <a:p>
+            <a:pPr algn="ctr"/>
+            <a:r>
+              <a:rPr sz="2000" b="1">
+                <a:solidFill>
+                  <a:srgbClr val="2F5552"/>
+                </a:solidFill>
+                <a:latin typeface="Aptos"/>
+              </a:rPr>
+              <a:t>{MUNI_POSITION}</a:t>
+            </a:r>
+          </a:p>
+        </p:txBody>
+      </p:sp>
+      <p:sp>
+        <p:nvSpPr>
+          <p:cNvPr id="18" name="תיבת טקסט 9">
+            <a:extLst>
+              <a:ext uri="{FF2B5EF4-FFF2-40B4-BE49-F238E27FC236}">
+                <ns3:creationId id="{2576C175-3BF1-9365-5DE4-6A895245D818}"/>
+              </a:ext>
+            </a:extLst>
+          </p:cNvPr>
+          <p:cNvSpPr txBox="1"/>
+          <p:nvPr/>
+        </p:nvSpPr>
+        <p:spPr>
+          <a:xfrm>
+            <a:off x="7653528" y="5504688"/>
+            <a:ext cx="4398264" cy="932688"/>
+          </a:xfrm>
+          <a:prstGeom prst="rect">
+            <a:avLst/>
+          </a:prstGeom>
+          <a:solidFill>
+            <a:srgbClr val="EDF6F2"/>
+          </a:solidFill>
+          <a:ln>
+            <a:noFill/>
+          </a:ln>
+        </p:spPr>
+        <p:txBody>
+          <a:bodyPr wrap="square" anchor="ctr" tIns="0" bIns="0" lIns="0" rIns="0">
+            <a:spAutoFit/>
+          </a:bodyPr>
+          <a:lstStyle/>
+          <a:p>
+            <a:pPr algn="ctr" rtl="1"/>
+            <a:r>
+              <a:rPr sz="2200" b="1">
+                <a:solidFill>
+                  <a:srgbClr val="2F5552"/>
+                </a:solidFill>
+                <a:latin typeface="Aptos"/>
+              </a:rPr>
+              <a:t>עמדת הבעלים</a:t>
+            </a:r>
+          </a:p>
+          <a:p>
+            <a:pPr algn="ctr"/>
+            <a:r>
+              <a:rPr sz="2000" b="1">
+                <a:solidFill>
+                  <a:srgbClr val="2F5552"/>
+                </a:solidFill>
+                <a:latin typeface="Aptos"/>
+              </a:rPr>
+              <a:t>{OWNER_POSITION}</a:t>
+            </a:r>
+          </a:p>
+        </p:txBody>
+      </p:sp>
     </p:spTree>
     <p:extLst>
       <p:ext uri="{BB962C8B-B14F-4D97-AF65-F5344CB8AC3E}">

</xml_diff>

<commit_message>
Fix building card classification punctuation
</commit_message>
<xml_diff>
--- a/project/web-server/backend/Data/BuildingCardTemplate.pptx
+++ b/project/web-server/backend/Data/BuildingCardTemplate.pptx
@@ -21405,7 +21405,16 @@
                 </a:solidFill>
                 <a:latin typeface="Aptos"/>
               </a:rPr>
-              <a:t>סיווג: {SIVUG}</a:t>
+              <a:t>סיווג:</a:t>
+            </a:r>
+            <a:r>
+              <a:rPr sz="3200" b="1">
+                <a:solidFill>
+                  <a:srgbClr val="2F5552"/>
+                </a:solidFill>
+                <a:latin typeface="Aptos"/>
+              </a:rPr>
+              <a:t> {SIVUG}</a:t>
             </a:r>
           </a:p>
         </p:txBody>

</xml_diff>

<commit_message>
Fix building card classification RTL punctuation
</commit_message>
<xml_diff>
--- a/project/web-server/backend/Data/BuildingCardTemplate.pptx
+++ b/project/web-server/backend/Data/BuildingCardTemplate.pptx
@@ -130,6 +130,43 @@
 </p:cmAuthorLst>
 </file>
 
+<file path=ppt/revisionInfo.xml><?xml version="1.0" encoding="utf-8"?>
+<p1510:revInfo xmlns:a="http://schemas.openxmlformats.org/drawingml/2006/main" xmlns:r="http://schemas.openxmlformats.org/officeDocument/2006/relationships" xmlns:p1510="http://schemas.microsoft.com/office/powerpoint/2015/10/main">
+  <p1510:revLst>
+    <p1510:client id="{45FAB8A7-59B8-46A3-A0F1-187B5B1D61FE}" v="1" dt="2026-07-01T07:15:06.488"/>
+  </p1510:revLst>
+</p1510:revInfo>
+</file>
+
+<file path=ppt/changesInfos/changesInfo1.xml><?xml version="1.0" encoding="utf-8"?>
+<pc:chgInfo xmlns:a="http://schemas.openxmlformats.org/drawingml/2006/main" xmlns:r="http://schemas.openxmlformats.org/officeDocument/2006/relationships" xmlns:ac="http://schemas.microsoft.com/office/drawing/2013/main/command" xmlns:pc="http://schemas.microsoft.com/office/powerpoint/2013/main/command">
+  <pc:docChgLst>
+    <pc:chgData name="Kareem Araide" userId="de348250dbb8bac6" providerId="LiveId" clId="{65F28107-F77A-404E-ADBF-4CBF28DF91CB}"/>
+    <pc:docChg chg="undo custSel modSld">
+      <pc:chgData name="Kareem Araide" userId="de348250dbb8bac6" providerId="LiveId" clId="{65F28107-F77A-404E-ADBF-4CBF28DF91CB}" dt="2026-07-01T07:15:12.736" v="20" actId="2711"/>
+      <pc:docMkLst>
+        <pc:docMk/>
+      </pc:docMkLst>
+      <pc:sldChg chg="modSp mod">
+        <pc:chgData name="Kareem Araide" userId="de348250dbb8bac6" providerId="LiveId" clId="{65F28107-F77A-404E-ADBF-4CBF28DF91CB}" dt="2026-07-01T07:15:12.736" v="20" actId="2711"/>
+        <pc:sldMkLst>
+          <pc:docMk/>
+          <pc:sldMk cId="2354692379" sldId="747"/>
+        </pc:sldMkLst>
+        <pc:spChg chg="mod">
+          <ac:chgData name="Kareem Araide" userId="de348250dbb8bac6" providerId="LiveId" clId="{65F28107-F77A-404E-ADBF-4CBF28DF91CB}" dt="2026-07-01T07:15:12.736" v="20" actId="2711"/>
+          <ac:spMkLst>
+            <pc:docMk/>
+            <pc:sldMk cId="2354692379" sldId="747"/>
+            <ac:spMk id="23" creationId="{2576C175-3BF1-9365-5DE4-6A895245D818}"/>
+          </ac:spMkLst>
+        </pc:spChg>
+      </pc:sldChg>
+    </pc:docChg>
+  </pc:docChgLst>
+</pc:chgInfo>
+</file>
+
 <file path=ppt/notesMasters/notesMaster1.xml><?xml version="1.0" encoding="utf-8"?>
 <p:notesMaster xmlns:a="http://schemas.openxmlformats.org/drawingml/2006/main" xmlns:r="http://schemas.openxmlformats.org/officeDocument/2006/relationships" xmlns:p="http://schemas.openxmlformats.org/presentationml/2006/main">
   <p:cSld>
@@ -217,7 +254,7 @@
             <a:fld id="{2235085D-1097-4D16-8C89-046FBDEE899B}" type="datetimeFigureOut">
               <a:rPr lang="he-IL" smtClean="0"/>
               <a:pPr/>
-              <a:t>י"ג/תמוז/תשפ"ו</a:t>
+              <a:t>ט"ז/תמוז/תשפ"ו</a:t>
             </a:fld>
             <a:endParaRPr lang="he-IL" dirty="0"/>
           </a:p>
@@ -9291,7 +9328,7 @@
             <a:fld id="{06D97635-68D3-4231-B6D3-E01CF285EE9C}" type="datetime8">
               <a:rPr lang="he-IL" smtClean="0"/>
               <a:pPr/>
-              <a:t>28 יוני 26</a:t>
+              <a:t>01 יולי 26</a:t>
             </a:fld>
             <a:endParaRPr lang="he-IL"/>
           </a:p>
@@ -9519,7 +9556,7 @@
           <a:p>
             <a:fld id="{BD92C3CD-2DD7-4739-91FD-190E7B42CACD}" type="datetime8">
               <a:rPr lang="he-IL" smtClean="0"/>
-              <a:t>28 יוני 26</a:t>
+              <a:t>01 יולי 26</a:t>
             </a:fld>
             <a:endParaRPr lang="he-IL"/>
           </a:p>
@@ -9705,7 +9742,7 @@
           <a:p>
             <a:fld id="{FD4BFC87-1F72-462A-BCEA-1A814EAC5254}" type="datetime8">
               <a:rPr lang="he-IL" smtClean="0"/>
-              <a:t>28 יוני 26</a:t>
+              <a:t>01 יולי 26</a:t>
             </a:fld>
             <a:endParaRPr lang="he-IL"/>
           </a:p>
@@ -9958,7 +9995,7 @@
             <a:fld id="{8D7207FB-0423-4EBC-BC71-093AC5750AD0}" type="datetime8">
               <a:rPr lang="he-IL" smtClean="0"/>
               <a:pPr/>
-              <a:t>28 יוני 26</a:t>
+              <a:t>01 יולי 26</a:t>
             </a:fld>
             <a:endParaRPr lang="he-IL"/>
           </a:p>
@@ -18743,7 +18780,7 @@
           <a:p>
             <a:fld id="{5BB1EDE2-E23E-4D45-97E7-8B22884C3954}" type="datetime8">
               <a:rPr lang="he-IL" smtClean="0"/>
-              <a:t>28 יוני 26</a:t>
+              <a:t>01 יולי 26</a:t>
             </a:fld>
             <a:endParaRPr lang="he-IL"/>
           </a:p>
@@ -19023,7 +19060,7 @@
           <a:p>
             <a:fld id="{A87D2518-068A-4B4E-9411-11F0D777D01C}" type="datetime8">
               <a:rPr lang="he-IL" smtClean="0"/>
-              <a:t>28 יוני 26</a:t>
+              <a:t>01 יולי 26</a:t>
             </a:fld>
             <a:endParaRPr lang="he-IL"/>
           </a:p>
@@ -19501,7 +19538,7 @@
             <a:fld id="{0F1C5475-1302-4305-92B3-B5D3D4D128BD}" type="datetime8">
               <a:rPr lang="he-IL" smtClean="0"/>
               <a:pPr/>
-              <a:t>28 יוני 26</a:t>
+              <a:t>01 יולי 26</a:t>
             </a:fld>
             <a:endParaRPr lang="he-IL"/>
           </a:p>
@@ -19651,7 +19688,7 @@
             <a:fld id="{98EE1D82-A631-49C7-A4BC-CF56C1A36EBF}" type="datetime8">
               <a:rPr lang="he-IL" smtClean="0"/>
               <a:pPr/>
-              <a:t>28 יוני 26</a:t>
+              <a:t>01 יולי 26</a:t>
             </a:fld>
             <a:endParaRPr lang="he-IL"/>
           </a:p>
@@ -19761,7 +19798,7 @@
           <a:p>
             <a:fld id="{0EB353D4-AB26-4510-80F0-851F863F6D73}" type="datetime8">
               <a:rPr lang="he-IL" smtClean="0"/>
-              <a:t>28 יוני 26</a:t>
+              <a:t>01 יולי 26</a:t>
             </a:fld>
             <a:endParaRPr lang="he-IL"/>
           </a:p>
@@ -20051,7 +20088,7 @@
           <a:p>
             <a:fld id="{813B2F0F-C3DA-4E52-B4E3-B2BD22748E6D}" type="datetime8">
               <a:rPr lang="he-IL" smtClean="0"/>
-              <a:t>28 יוני 26</a:t>
+              <a:t>01 יולי 26</a:t>
             </a:fld>
             <a:endParaRPr lang="he-IL"/>
           </a:p>
@@ -20331,7 +20368,7 @@
           <a:p>
             <a:fld id="{85CCD77F-7A8D-4C44-9CE3-16F0C0070A60}" type="datetime8">
               <a:rPr lang="he-IL" smtClean="0"/>
-              <a:t>28 יוני 26</a:t>
+              <a:t>01 יולי 26</a:t>
             </a:fld>
             <a:endParaRPr lang="he-IL"/>
           </a:p>
@@ -20588,7 +20625,7 @@
             <a:fld id="{864DF5F2-D2BF-431E-BFF9-A44526EEADB6}" type="datetime8">
               <a:rPr lang="he-IL" smtClean="0"/>
               <a:pPr/>
-              <a:t>28 יוני 26</a:t>
+              <a:t>01 יולי 26</a:t>
             </a:fld>
             <a:endParaRPr lang="he-IL"/>
           </a:p>
@@ -21079,7 +21116,7 @@
 </file>
 
 <file path=ppt/slides/slide1.xml><?xml version="1.0" encoding="utf-8"?>
-<p:sld xmlns:a="http://schemas.openxmlformats.org/drawingml/2006/main" xmlns:ns2="http://schemas.openxmlformats.org/officeDocument/2006/relationships" xmlns:ns3="http://schemas.microsoft.com/office/drawing/2014/main" xmlns:ns4="http://schemas.microsoft.com/office/powerpoint/2010/main" xmlns:ns5="http://schemas.microsoft.com/office/drawing/2010/main" xmlns:p="http://schemas.openxmlformats.org/presentationml/2006/main">
+<p:sld xmlns:a="http://schemas.openxmlformats.org/drawingml/2006/main" xmlns:r="http://schemas.openxmlformats.org/officeDocument/2006/relationships" xmlns:p="http://schemas.openxmlformats.org/presentationml/2006/main">
   <p:cSld>
     <p:spTree>
       <p:nvGrpSpPr>
@@ -21104,7 +21141,7 @@
           <p:nvPr/>
         </p:nvPicPr>
         <p:blipFill rotWithShape="1">
-          <a:blip ns2:embed="rId2"/>
+          <a:blip r:embed="rId2"/>
           <a:srcRect r="10124"/>
           <a:stretch/>
         </p:blipFill>
@@ -21215,7 +21252,7 @@
           <p:cNvPr id="19" name="תיבת טקסט 9">
             <a:extLst>
               <a:ext uri="{FF2B5EF4-FFF2-40B4-BE49-F238E27FC236}">
-                <ns3:creationId id="{2576C175-3BF1-9365-5DE4-6A895245D818}"/>
+                <a16:creationId xmlns:a16="http://schemas.microsoft.com/office/drawing/2014/main" id="{2576C175-3BF1-9365-5DE4-6A895245D818}"/>
               </a:ext>
             </a:extLst>
           </p:cNvPr>
@@ -21238,7 +21275,7 @@
           </a:ln>
         </p:spPr>
         <p:txBody>
-          <a:bodyPr wrap="square" anchor="ctr" tIns="0" bIns="0" lIns="0" rIns="0">
+          <a:bodyPr wrap="square" lIns="0" tIns="0" rIns="0" bIns="0" anchor="ctr">
             <a:spAutoFit/>
           </a:bodyPr>
           <a:lstStyle/>
@@ -21263,7 +21300,7 @@
           <p:cNvPr id="20" name="תיבת טקסט 9">
             <a:extLst>
               <a:ext uri="{FF2B5EF4-FFF2-40B4-BE49-F238E27FC236}">
-                <ns3:creationId id="{2576C175-3BF1-9365-5DE4-6A895245D818}"/>
+                <a16:creationId xmlns:a16="http://schemas.microsoft.com/office/drawing/2014/main" id="{2576C175-3BF1-9365-5DE4-6A895245D818}"/>
               </a:ext>
             </a:extLst>
           </p:cNvPr>
@@ -21286,7 +21323,7 @@
           </a:ln>
         </p:spPr>
         <p:txBody>
-          <a:bodyPr wrap="square" anchor="ctr" tIns="0" bIns="0" lIns="0" rIns="0">
+          <a:bodyPr wrap="square" lIns="0" tIns="0" rIns="0" bIns="0" anchor="ctr">
             <a:spAutoFit/>
           </a:bodyPr>
           <a:lstStyle/>
@@ -21321,7 +21358,7 @@
           <p:cNvPr id="21" name="תיבת טקסט 9">
             <a:extLst>
               <a:ext uri="{FF2B5EF4-FFF2-40B4-BE49-F238E27FC236}">
-                <ns3:creationId id="{2576C175-3BF1-9365-5DE4-6A895245D818}"/>
+                <a16:creationId xmlns:a16="http://schemas.microsoft.com/office/drawing/2014/main" id="{2576C175-3BF1-9365-5DE4-6A895245D818}"/>
               </a:ext>
             </a:extLst>
           </p:cNvPr>
@@ -21344,7 +21381,7 @@
           </a:ln>
         </p:spPr>
         <p:txBody>
-          <a:bodyPr wrap="square" anchor="ctr" tIns="0" bIns="0" lIns="0" rIns="0">
+          <a:bodyPr wrap="square" lIns="0" tIns="0" rIns="0" bIns="0" anchor="ctr">
             <a:spAutoFit/>
           </a:bodyPr>
           <a:lstStyle/>
@@ -21369,7 +21406,7 @@
           <p:cNvPr id="23" name="תיבת טקסט 9">
             <a:extLst>
               <a:ext uri="{FF2B5EF4-FFF2-40B4-BE49-F238E27FC236}">
-                <ns3:creationId id="{2576C175-3BF1-9365-5DE4-6A895245D818}"/>
+                <a16:creationId xmlns:a16="http://schemas.microsoft.com/office/drawing/2014/main" id="{2576C175-3BF1-9365-5DE4-6A895245D818}"/>
               </a:ext>
             </a:extLst>
           </p:cNvPr>
@@ -21392,30 +21429,36 @@
           </a:ln>
         </p:spPr>
         <p:txBody>
-          <a:bodyPr wrap="square" anchor="ctr" tIns="0" bIns="0" lIns="0" rIns="0">
+          <a:bodyPr wrap="square" lIns="0" tIns="0" rIns="0" bIns="0" anchor="ctr">
             <a:spAutoFit/>
           </a:bodyPr>
           <a:lstStyle/>
           <a:p>
             <a:pPr algn="ctr" rtl="1"/>
             <a:r>
-              <a:rPr sz="3200" b="1">
+              <a:rPr lang="he-IL" sz="3200" b="1" dirty="0">
                 <a:solidFill>
                   <a:srgbClr val="2F5552"/>
                 </a:solidFill>
-                <a:latin typeface="Aptos"/>
+                <a:latin typeface="Aptos" panose="020B0004020202020204" pitchFamily="34" charset="0"/>
               </a:rPr>
-              <a:t>סיווג:</a:t>
+              <a:t>סיווג: </a:t>
             </a:r>
             <a:r>
-              <a:rPr sz="3200" b="1">
+              <a:rPr lang="en-US" sz="3200" b="1" dirty="0">
                 <a:solidFill>
                   <a:srgbClr val="2F5552"/>
                 </a:solidFill>
-                <a:latin typeface="Aptos"/>
+                <a:latin typeface="Aptos" panose="020B0004020202020204" pitchFamily="34" charset="0"/>
               </a:rPr>
-              <a:t> {SIVUG}</a:t>
+              <a:t>{SIVUG}</a:t>
             </a:r>
+            <a:endParaRPr sz="3200" b="1" dirty="0">
+              <a:solidFill>
+                <a:srgbClr val="2F5552"/>
+              </a:solidFill>
+              <a:latin typeface="Aptos" panose="020B0004020202020204" pitchFamily="34" charset="0"/>
+            </a:endParaRPr>
           </a:p>
         </p:txBody>
       </p:sp>
@@ -21441,7 +21484,7 @@
           </a:ln>
         </p:spPr>
         <p:txBody>
-          <a:bodyPr wrap="square" anchor="ctr" tIns="0" bIns="0" lIns="0" rIns="0">
+          <a:bodyPr wrap="square" lIns="0" tIns="0" rIns="0" bIns="0" anchor="ctr">
             <a:spAutoFit/>
           </a:bodyPr>
           <a:lstStyle/>
@@ -21506,7 +21549,7 @@
           </a:fontRef>
         </p:style>
         <p:txBody>
-          <a:bodyPr rtlCol="1" anchor="ctr" tIns="0" bIns="0" lIns="0" rIns="0"/>
+          <a:bodyPr lIns="0" tIns="0" rIns="0" bIns="0" rtlCol="1" anchor="ctr"/>
           <a:lstStyle/>
           <a:p>
             <a:pPr algn="ctr" rtl="1"/>
@@ -21533,14 +21576,14 @@
           <p:nvPr>
             <p:extLst>
               <p:ext uri="{D42A27DB-BD31-4B8C-83A1-F6EECF244321}">
-                <ns4:modId val="1855143216"/>
+                <p14:modId xmlns:p14="http://schemas.microsoft.com/office/powerpoint/2010/main" val="1855143216"/>
               </p:ext>
             </p:extLst>
           </p:nvPr>
         </p:nvGraphicFramePr>
         <p:xfrm>
           <a:off x="3072384" y="4379976"/>
-          <a:ext cx="8979408" cy="950976"/>
+          <a:ext cx="8979408" cy="1207008"/>
         </p:xfrm>
         <a:graphic>
           <a:graphicData uri="http://schemas.openxmlformats.org/drawingml/2006/table">
@@ -21552,28 +21595,28 @@
                 <a:gridCol w="2231136">
                   <a:extLst>
                     <a:ext uri="{9D8B030D-6E8A-4147-A177-3AD203B41FA5}">
-                      <ns3:colId val="720534580"/>
+                      <a16:colId xmlns:a16="http://schemas.microsoft.com/office/drawing/2014/main" val="720534580"/>
                     </a:ext>
                   </a:extLst>
                 </a:gridCol>
                 <a:gridCol w="2249424">
                   <a:extLst>
                     <a:ext uri="{9D8B030D-6E8A-4147-A177-3AD203B41FA5}">
-                      <ns3:colId val="3385606801"/>
+                      <a16:colId xmlns:a16="http://schemas.microsoft.com/office/drawing/2014/main" val="3385606801"/>
                     </a:ext>
                   </a:extLst>
                 </a:gridCol>
                 <a:gridCol w="2249424">
                   <a:extLst>
                     <a:ext uri="{9D8B030D-6E8A-4147-A177-3AD203B41FA5}">
-                      <ns3:colId val="1287329000"/>
+                      <a16:colId xmlns:a16="http://schemas.microsoft.com/office/drawing/2014/main" val="1287329000"/>
                     </a:ext>
                   </a:extLst>
                 </a:gridCol>
                 <a:gridCol w="2249424">
                   <a:extLst>
                     <a:ext uri="{9D8B030D-6E8A-4147-A177-3AD203B41FA5}">
-                      <ns3:colId val="3932464124"/>
+                      <a16:colId xmlns:a16="http://schemas.microsoft.com/office/drawing/2014/main" val="3932464124"/>
                     </a:ext>
                   </a:extLst>
                 </a:gridCol>
@@ -21581,7 +21624,7 @@
               <a:tr h="475488">
                 <a:tc rowSpan="2">
                   <a:txBody>
-                    <a:bodyPr anchor="ctr" tIns="0" bIns="0" lIns="0" rIns="0"/>
+                    <a:bodyPr/>
                     <a:lstStyle/>
                     <a:p>
                       <a:pPr algn="ctr" rtl="1"/>
@@ -21598,7 +21641,7 @@
                       </a:r>
                     </a:p>
                   </a:txBody>
-                  <a:tcPr anchor="ctr" marL="0" marR="0" marT="0" marB="0">
+                  <a:tcPr marL="0" marR="0" marT="0" marB="0" anchor="ctr">
                     <a:lnL w="12700" cap="flat" cmpd="sng" algn="ctr">
                       <a:noFill/>
                       <a:prstDash val="solid"/>
@@ -21642,10 +21685,10 @@
                 </a:tc>
                 <a:tc>
                   <a:txBody>
-                    <a:bodyPr anchor="ctr" tIns="0" bIns="0" lIns="0" rIns="0"/>
+                    <a:bodyPr/>
                     <a:lstStyle/>
                     <a:p>
-                      <a:pPr rtl="1" algn="ctr"/>
+                      <a:pPr algn="ctr" rtl="1"/>
                       <a:r>
                         <a:rPr lang="he-IL" dirty="0">
                           <a:solidFill>
@@ -21659,7 +21702,7 @@
                       </a:r>
                     </a:p>
                   </a:txBody>
-                  <a:tcPr anchor="ctr" marL="0" marR="0" marT="0" marB="0">
+                  <a:tcPr marL="0" marR="0" marT="0" marB="0" anchor="ctr">
                     <a:lnL w="12700" cap="flat" cmpd="sng" algn="ctr">
                       <a:noFill/>
                       <a:prstDash val="solid"/>
@@ -21703,10 +21746,10 @@
                 </a:tc>
                 <a:tc>
                   <a:txBody>
-                    <a:bodyPr anchor="ctr" tIns="0" bIns="0" lIns="0" rIns="0"/>
+                    <a:bodyPr/>
                     <a:lstStyle/>
                     <a:p>
-                      <a:pPr rtl="1" algn="ctr"/>
+                      <a:pPr algn="ctr" rtl="1"/>
                       <a:r>
                         <a:rPr lang="he-IL" dirty="0">
                           <a:solidFill>
@@ -21720,7 +21763,7 @@
                       </a:r>
                     </a:p>
                   </a:txBody>
-                  <a:tcPr anchor="ctr" marL="0" marR="0" marT="0" marB="0">
+                  <a:tcPr marL="0" marR="0" marT="0" marB="0" anchor="ctr">
                     <a:lnL w="12700" cap="flat" cmpd="sng" algn="ctr">
                       <a:noFill/>
                       <a:prstDash val="solid"/>
@@ -21764,10 +21807,10 @@
                 </a:tc>
                 <a:tc>
                   <a:txBody>
-                    <a:bodyPr anchor="ctr" tIns="0" bIns="0" lIns="0" rIns="0"/>
+                    <a:bodyPr/>
                     <a:lstStyle/>
                     <a:p>
-                      <a:pPr rtl="1" algn="ctr"/>
+                      <a:pPr algn="ctr" rtl="1"/>
                       <a:r>
                         <a:rPr lang="he-IL" dirty="0">
                           <a:solidFill>
@@ -21781,7 +21824,7 @@
                       </a:r>
                     </a:p>
                   </a:txBody>
-                  <a:tcPr anchor="ctr" marL="0" marR="0" marT="0" marB="0">
+                  <a:tcPr marL="0" marR="0" marT="0" marB="0" anchor="ctr">
                     <a:lnL w="12700" cap="flat" cmpd="sng" algn="ctr">
                       <a:noFill/>
                       <a:prstDash val="solid"/>
@@ -21825,21 +21868,21 @@
                 </a:tc>
                 <a:extLst>
                   <a:ext uri="{0D108BD9-81ED-4DB2-BD59-A6C34878D82A}">
-                    <ns3:rowId val="1032947799"/>
+                    <a16:rowId xmlns:a16="http://schemas.microsoft.com/office/drawing/2014/main" val="1032947799"/>
                   </a:ext>
                 </a:extLst>
               </a:tr>
               <a:tr h="475488">
                 <a:tc vMerge="1">
                   <a:txBody>
-                    <a:bodyPr anchor="ctr" tIns="0" bIns="0" lIns="0" rIns="0"/>
+                    <a:bodyPr/>
                     <a:lstStyle/>
                     <a:p>
-                      <a:pPr rtl="1" algn="ctr"/>
+                      <a:pPr algn="ctr" rtl="1"/>
                       <a:endParaRPr lang="he-IL" dirty="0"/>
                     </a:p>
                   </a:txBody>
-                  <a:tcPr anchor="ctr" marL="0" marR="0" marT="0" marB="0">
+                  <a:tcPr marL="0" marR="0" marT="0" marB="0" anchor="ctr">
                     <a:lnL w="12700" cap="flat" cmpd="sng" algn="ctr">
                       <a:solidFill>
                         <a:schemeClr val="tx1"/>
@@ -21891,10 +21934,10 @@
                 </a:tc>
                 <a:tc>
                   <a:txBody>
-                    <a:bodyPr anchor="ctr" tIns="0" bIns="0" lIns="0" rIns="0"/>
+                    <a:bodyPr/>
                     <a:lstStyle/>
                     <a:p>
-                      <a:pPr rtl="1" algn="ctr"/>
+                      <a:pPr algn="ctr" rtl="1"/>
                       <a:r>
                         <a:rPr lang="en-US" sz="2400" dirty="0">
                           <a:solidFill>
@@ -21913,7 +21956,7 @@
                       </a:endParaRPr>
                     </a:p>
                   </a:txBody>
-                  <a:tcPr anchor="ctr" marL="0" marR="0" marT="0" marB="0">
+                  <a:tcPr marL="0" marR="0" marT="0" marB="0" anchor="ctr">
                     <a:lnL w="12700" cap="flat" cmpd="sng" algn="ctr">
                       <a:noFill/>
                       <a:prstDash val="solid"/>
@@ -21957,10 +22000,10 @@
                 </a:tc>
                 <a:tc>
                   <a:txBody>
-                    <a:bodyPr anchor="ctr" tIns="0" bIns="0" lIns="0" rIns="0"/>
+                    <a:bodyPr/>
                     <a:lstStyle/>
                     <a:p>
-                      <a:pPr rtl="1" algn="ctr"/>
+                      <a:pPr algn="ctr" rtl="1"/>
                       <a:r>
                         <a:rPr lang="en-US" sz="2400" kern="1200" dirty="0">
                           <a:solidFill>
@@ -21982,7 +22025,7 @@
                       </a:endParaRPr>
                     </a:p>
                   </a:txBody>
-                  <a:tcPr anchor="ctr" marL="0" marR="0" marT="0" marB="0">
+                  <a:tcPr marL="0" marR="0" marT="0" marB="0" anchor="ctr">
                     <a:lnL w="12700" cap="flat" cmpd="sng" algn="ctr">
                       <a:noFill/>
                       <a:prstDash val="solid"/>
@@ -22026,10 +22069,10 @@
                 </a:tc>
                 <a:tc>
                   <a:txBody>
-                    <a:bodyPr anchor="ctr" tIns="0" bIns="0" lIns="0" rIns="0"/>
+                    <a:bodyPr/>
                     <a:lstStyle/>
                     <a:p>
-                      <a:pPr rtl="1" algn="ctr"/>
+                      <a:pPr algn="ctr" rtl="1"/>
                       <a:r>
                         <a:rPr lang="en-US" sz="2400" kern="1200" dirty="0">
                           <a:solidFill>
@@ -22051,7 +22094,7 @@
                       </a:endParaRPr>
                     </a:p>
                   </a:txBody>
-                  <a:tcPr anchor="ctr" marL="0" marR="0" marT="0" marB="0">
+                  <a:tcPr marL="0" marR="0" marT="0" marB="0" anchor="ctr">
                     <a:lnL w="12700" cap="flat" cmpd="sng" algn="ctr">
                       <a:noFill/>
                       <a:prstDash val="solid"/>
@@ -22095,7 +22138,7 @@
                 </a:tc>
                 <a:extLst>
                   <a:ext uri="{0D108BD9-81ED-4DB2-BD59-A6C34878D82A}">
-                    <ns3:rowId val="4286580349"/>
+                    <a16:rowId xmlns:a16="http://schemas.microsoft.com/office/drawing/2014/main" val="4286580349"/>
                   </a:ext>
                 </a:extLst>
               </a:tr>
@@ -22108,7 +22151,7 @@
           <p:cNvPr id="33" name="תיבת טקסט 9">
             <a:extLst>
               <a:ext uri="{FF2B5EF4-FFF2-40B4-BE49-F238E27FC236}">
-                <ns3:creationId id="{2576C175-3BF1-9365-5DE4-6A895245D818}"/>
+                <a16:creationId xmlns:a16="http://schemas.microsoft.com/office/drawing/2014/main" id="{2576C175-3BF1-9365-5DE4-6A895245D818}"/>
               </a:ext>
             </a:extLst>
           </p:cNvPr>
@@ -22131,7 +22174,7 @@
           </a:ln>
         </p:spPr>
         <p:txBody>
-          <a:bodyPr wrap="square" anchor="ctr" tIns="0" bIns="0" lIns="0" rIns="0">
+          <a:bodyPr wrap="square" lIns="0" tIns="0" rIns="0" bIns="0" anchor="ctr">
             <a:spAutoFit/>
           </a:bodyPr>
           <a:lstStyle/>
@@ -22166,7 +22209,7 @@
           <p:cNvPr id="22" name="תיבת טקסט 9">
             <a:extLst>
               <a:ext uri="{FF2B5EF4-FFF2-40B4-BE49-F238E27FC236}">
-                <ns3:creationId id="{2576C175-3BF1-9365-5DE4-6A895245D818}"/>
+                <a16:creationId xmlns:a16="http://schemas.microsoft.com/office/drawing/2014/main" id="{2576C175-3BF1-9365-5DE4-6A895245D818}"/>
               </a:ext>
             </a:extLst>
           </p:cNvPr>
@@ -22189,7 +22232,7 @@
           </a:ln>
         </p:spPr>
         <p:txBody>
-          <a:bodyPr wrap="square" anchor="ctr" tIns="0" bIns="0" lIns="0" rIns="0">
+          <a:bodyPr wrap="square" lIns="0" tIns="0" rIns="0" bIns="0" anchor="ctr">
             <a:spAutoFit/>
           </a:bodyPr>
           <a:lstStyle/>
@@ -22224,7 +22267,7 @@
           <p:cNvPr id="28" name="תיבת טקסט 9">
             <a:extLst>
               <a:ext uri="{FF2B5EF4-FFF2-40B4-BE49-F238E27FC236}">
-                <ns3:creationId id="{2576C175-3BF1-9365-5DE4-6A895245D818}"/>
+                <a16:creationId xmlns:a16="http://schemas.microsoft.com/office/drawing/2014/main" id="{2576C175-3BF1-9365-5DE4-6A895245D818}"/>
               </a:ext>
             </a:extLst>
           </p:cNvPr>
@@ -22247,7 +22290,7 @@
           </a:ln>
         </p:spPr>
         <p:txBody>
-          <a:bodyPr wrap="square" anchor="ctr" tIns="0" bIns="0" lIns="0" rIns="0">
+          <a:bodyPr wrap="square" lIns="0" tIns="0" rIns="0" bIns="0" anchor="ctr">
             <a:spAutoFit/>
           </a:bodyPr>
           <a:lstStyle/>
@@ -22354,7 +22397,7 @@
           <a:noFill/>
         </p:spPr>
         <p:txBody>
-          <a:bodyPr wrap="square" rtlCol="1" anchor="ctr" tIns="0" bIns="0" lIns="0" rIns="0">
+          <a:bodyPr wrap="square" lIns="0" tIns="0" rIns="0" bIns="0" rtlCol="1" anchor="ctr">
             <a:spAutoFit/>
           </a:bodyPr>
           <a:lstStyle/>
@@ -22465,7 +22508,7 @@
           <a:noFill/>
         </p:spPr>
         <p:txBody>
-          <a:bodyPr wrap="square" rtlCol="1" anchor="ctr" tIns="0" bIns="0" lIns="0" rIns="0">
+          <a:bodyPr wrap="square" lIns="0" tIns="0" rIns="0" bIns="0" rtlCol="1" anchor="ctr">
             <a:spAutoFit/>
           </a:bodyPr>
           <a:lstStyle/>
@@ -22504,7 +22547,7 @@
           <p:cNvPr id="5" name="Picture 4">
             <a:extLst>
               <a:ext uri="{FF2B5EF4-FFF2-40B4-BE49-F238E27FC236}">
-                <ns3:creationId id="{EA0E0737-9A13-3187-0B8F-64280260EE8B}"/>
+                <a16:creationId xmlns:a16="http://schemas.microsoft.com/office/drawing/2014/main" id="{EA0E0737-9A13-3187-0B8F-64280260EE8B}"/>
               </a:ext>
             </a:extLst>
           </p:cNvPr>
@@ -22514,10 +22557,10 @@
           <p:nvPr/>
         </p:nvPicPr>
         <p:blipFill>
-          <a:blip ns2:embed="rId3">
+          <a:blip r:embed="rId3">
             <a:extLst>
               <a:ext uri="{28A0092B-C50C-407E-A947-70E740481C1C}">
-                <ns5:useLocalDpi val="0"/>
+                <a14:useLocalDpi xmlns:a14="http://schemas.microsoft.com/office/drawing/2010/main" val="0"/>
               </a:ext>
             </a:extLst>
           </a:blip>
@@ -22540,7 +22583,7 @@
           <p:cNvPr id="17" name="תיבת טקסט 9">
             <a:extLst>
               <a:ext uri="{FF2B5EF4-FFF2-40B4-BE49-F238E27FC236}">
-                <ns3:creationId id="{2576C175-3BF1-9365-5DE4-6A895245D818}"/>
+                <a16:creationId xmlns:a16="http://schemas.microsoft.com/office/drawing/2014/main" id="{2576C175-3BF1-9365-5DE4-6A895245D818}"/>
               </a:ext>
             </a:extLst>
           </p:cNvPr>
@@ -22563,7 +22606,7 @@
           </a:ln>
         </p:spPr>
         <p:txBody>
-          <a:bodyPr wrap="square" anchor="ctr" tIns="0" bIns="0" lIns="0" rIns="0">
+          <a:bodyPr wrap="square" lIns="0" tIns="0" rIns="0" bIns="0" anchor="ctr">
             <a:spAutoFit/>
           </a:bodyPr>
           <a:lstStyle/>
@@ -22598,7 +22641,7 @@
           <p:cNvPr id="18" name="תיבת טקסט 9">
             <a:extLst>
               <a:ext uri="{FF2B5EF4-FFF2-40B4-BE49-F238E27FC236}">
-                <ns3:creationId id="{2576C175-3BF1-9365-5DE4-6A895245D818}"/>
+                <a16:creationId xmlns:a16="http://schemas.microsoft.com/office/drawing/2014/main" id="{2576C175-3BF1-9365-5DE4-6A895245D818}"/>
               </a:ext>
             </a:extLst>
           </p:cNvPr>
@@ -22621,7 +22664,7 @@
           </a:ln>
         </p:spPr>
         <p:txBody>
-          <a:bodyPr wrap="square" anchor="ctr" tIns="0" bIns="0" lIns="0" rIns="0">
+          <a:bodyPr wrap="square" lIns="0" tIns="0" rIns="0" bIns="0" anchor="ctr">
             <a:spAutoFit/>
           </a:bodyPr>
           <a:lstStyle/>
@@ -22654,7 +22697,7 @@
     </p:spTree>
     <p:extLst>
       <p:ext uri="{BB962C8B-B14F-4D97-AF65-F5344CB8AC3E}">
-        <ns4:creationId val="2354692379"/>
+        <p14:creationId xmlns:p14="http://schemas.microsoft.com/office/powerpoint/2010/main" val="2354692379"/>
       </p:ext>
     </p:extLst>
   </p:cSld>

</xml_diff>

<commit_message>
Fix building card Hebrew font slots
</commit_message>
<xml_diff>
--- a/project/web-server/backend/Data/BuildingCardTemplate.pptx
+++ b/project/web-server/backend/Data/BuildingCardTemplate.pptx
@@ -133,7 +133,7 @@
 <file path=ppt/revisionInfo.xml><?xml version="1.0" encoding="utf-8"?>
 <p1510:revInfo xmlns:a="http://schemas.openxmlformats.org/drawingml/2006/main" xmlns:r="http://schemas.openxmlformats.org/officeDocument/2006/relationships" xmlns:p1510="http://schemas.microsoft.com/office/powerpoint/2015/10/main">
   <p1510:revLst>
-    <p1510:client id="{45FAB8A7-59B8-46A3-A0F1-187B5B1D61FE}" v="1" dt="2026-07-01T07:15:06.488"/>
+    <p1510:client id="{45FAB8A7-59B8-46A3-A0F1-187B5B1D61FE}" v="4" dt="2026-07-01T07:21:53.788"/>
   </p1510:revLst>
 </p1510:revInfo>
 </file>
@@ -142,19 +142,19 @@
 <pc:chgInfo xmlns:a="http://schemas.openxmlformats.org/drawingml/2006/main" xmlns:r="http://schemas.openxmlformats.org/officeDocument/2006/relationships" xmlns:ac="http://schemas.microsoft.com/office/drawing/2013/main/command" xmlns:pc="http://schemas.microsoft.com/office/powerpoint/2013/main/command">
   <pc:docChgLst>
     <pc:chgData name="Kareem Araide" userId="de348250dbb8bac6" providerId="LiveId" clId="{65F28107-F77A-404E-ADBF-4CBF28DF91CB}"/>
-    <pc:docChg chg="undo custSel modSld">
-      <pc:chgData name="Kareem Araide" userId="de348250dbb8bac6" providerId="LiveId" clId="{65F28107-F77A-404E-ADBF-4CBF28DF91CB}" dt="2026-07-01T07:15:12.736" v="20" actId="2711"/>
+    <pc:docChg chg="undo redo custSel modSld">
+      <pc:chgData name="Kareem Araide" userId="de348250dbb8bac6" providerId="LiveId" clId="{65F28107-F77A-404E-ADBF-4CBF28DF91CB}" dt="2026-07-01T07:21:54.422" v="42" actId="20577"/>
       <pc:docMkLst>
         <pc:docMk/>
       </pc:docMkLst>
       <pc:sldChg chg="modSp mod">
-        <pc:chgData name="Kareem Araide" userId="de348250dbb8bac6" providerId="LiveId" clId="{65F28107-F77A-404E-ADBF-4CBF28DF91CB}" dt="2026-07-01T07:15:12.736" v="20" actId="2711"/>
+        <pc:chgData name="Kareem Araide" userId="de348250dbb8bac6" providerId="LiveId" clId="{65F28107-F77A-404E-ADBF-4CBF28DF91CB}" dt="2026-07-01T07:21:54.422" v="42" actId="20577"/>
         <pc:sldMkLst>
           <pc:docMk/>
           <pc:sldMk cId="2354692379" sldId="747"/>
         </pc:sldMkLst>
         <pc:spChg chg="mod">
-          <ac:chgData name="Kareem Araide" userId="de348250dbb8bac6" providerId="LiveId" clId="{65F28107-F77A-404E-ADBF-4CBF28DF91CB}" dt="2026-07-01T07:15:12.736" v="20" actId="2711"/>
+          <ac:chgData name="Kareem Araide" userId="de348250dbb8bac6" providerId="LiveId" clId="{65F28107-F77A-404E-ADBF-4CBF28DF91CB}" dt="2026-07-01T07:21:54.422" v="42" actId="20577"/>
           <ac:spMkLst>
             <pc:docMk/>
             <pc:sldMk cId="2354692379" sldId="747"/>
@@ -21197,7 +21197,11 @@
           <a:lstStyle/>
           <a:p>
             <a:pPr algn="ctr"/>
-            <a:endParaRPr lang="he-IL"/>
+            <a:endParaRPr lang="he-IL">
+              <a:latin typeface="Aptos" panose="020B0004020202020204" pitchFamily="34" charset="0"/>
+              <a:ea typeface="Aptos" panose="020B0004020202020204" pitchFamily="34" charset="0"/>
+              <a:cs typeface="Aptos" panose="020B0004020202020204" pitchFamily="34" charset="0"/>
+            </a:endParaRPr>
           </a:p>
         </p:txBody>
       </p:sp>
@@ -21243,7 +21247,11 @@
           <a:lstStyle/>
           <a:p>
             <a:pPr algn="ctr"/>
-            <a:endParaRPr lang="he-IL"/>
+            <a:endParaRPr lang="he-IL">
+              <a:latin typeface="Aptos" panose="020B0004020202020204" pitchFamily="34" charset="0"/>
+              <a:ea typeface="Aptos" panose="020B0004020202020204" pitchFamily="34" charset="0"/>
+              <a:cs typeface="Aptos" panose="020B0004020202020204" pitchFamily="34" charset="0"/>
+            </a:endParaRPr>
           </a:p>
         </p:txBody>
       </p:sp>
@@ -21286,9 +21294,9 @@
                 <a:solidFill>
                   <a:srgbClr val="305250"/>
                 </a:solidFill>
-                <a:latin typeface="Aptos" panose="020F0502020204030204" pitchFamily="34" charset="0"/>
-                <a:ea typeface="Calibri" panose="020F0502020204030204" pitchFamily="34" charset="0"/>
-                <a:cs typeface="Calibri" panose="020F0502020204030204" pitchFamily="34" charset="0"/>
+                <a:latin typeface="Aptos" panose="020B0004020202020204" pitchFamily="34" charset="0"/>
+                <a:ea typeface="Aptos" panose="020B0004020202020204" pitchFamily="34" charset="0"/>
+                <a:cs typeface="Aptos" panose="020B0004020202020204" pitchFamily="34" charset="0"/>
               </a:rPr>
               <a:t>{STREET_NAME} {HOUSE_NUMBER}</a:t>
             </a:r>
@@ -21330,11 +21338,13 @@
           <a:p>
             <a:pPr algn="ctr" rtl="1"/>
             <a:r>
-              <a:rPr sz="3200" b="1">
+              <a:rPr sz="3200" b="1" lang="he-IL">
                 <a:solidFill>
                   <a:srgbClr val="2F5552"/>
                 </a:solidFill>
-                <a:latin typeface="Aptos"/>
+                <a:latin typeface="Aptos" panose="020B0004020202020204" pitchFamily="34" charset="0"/>
+                <a:ea typeface="Aptos" panose="020B0004020202020204" pitchFamily="34" charset="0"/>
+                <a:cs typeface="Aptos" panose="020B0004020202020204" pitchFamily="34" charset="0"/>
               </a:rPr>
               <a:t>יעוד</a:t>
             </a:r>
@@ -21342,11 +21352,13 @@
           <a:p>
             <a:pPr algn="ctr"/>
             <a:r>
-              <a:rPr sz="1400" b="0">
+              <a:rPr sz="1400" b="0" lang="he-IL">
                 <a:solidFill>
                   <a:srgbClr val="2F5552"/>
                 </a:solidFill>
-                <a:latin typeface="Aptos"/>
+                <a:latin typeface="Aptos" panose="020B0004020202020204" pitchFamily="34" charset="0"/>
+                <a:ea typeface="Aptos" panose="020B0004020202020204" pitchFamily="34" charset="0"/>
+                <a:cs typeface="Aptos" panose="020B0004020202020204" pitchFamily="34" charset="0"/>
               </a:rPr>
               <a:t>{YEUD}</a:t>
             </a:r>
@@ -21392,9 +21404,9 @@
                 <a:solidFill>
                   <a:srgbClr val="A6A6A6"/>
                 </a:solidFill>
-                <a:latin typeface="Aptos" panose="020F0502020204030204" pitchFamily="34" charset="0"/>
-                <a:ea typeface="Calibri" panose="020F0502020204030204" pitchFamily="34" charset="0"/>
-                <a:cs typeface="Calibri" panose="020F0502020204030204" pitchFamily="34" charset="0"/>
+                <a:latin typeface="Aptos" panose="020B0004020202020204" pitchFamily="34" charset="0"/>
+                <a:ea typeface="Aptos" panose="020B0004020202020204" pitchFamily="34" charset="0"/>
+                <a:cs typeface="Aptos" panose="020B0004020202020204" pitchFamily="34" charset="0"/>
               </a:rPr>
               <a:t>גוש {GUSH_M} חלקה {PARCEL_M}</a:t>
             </a:r>
@@ -21441,23 +21453,40 @@
                   <a:srgbClr val="2F5552"/>
                 </a:solidFill>
                 <a:latin typeface="Aptos" panose="020B0004020202020204" pitchFamily="34" charset="0"/>
+                <a:ea typeface="Aptos" panose="020B0004020202020204" pitchFamily="34" charset="0"/>
+                <a:cs typeface="Aptos" panose="020B0004020202020204" pitchFamily="34" charset="0"/>
               </a:rPr>
-              <a:t>סיווג: </a:t>
+              <a:t>סיווג</a:t>
             </a:r>
             <a:r>
-              <a:rPr lang="en-US" sz="3200" b="1" dirty="0">
+              <a:rPr lang="he-IL" sz="3200" b="1" dirty="0">
                 <a:solidFill>
                   <a:srgbClr val="2F5552"/>
                 </a:solidFill>
                 <a:latin typeface="Aptos" panose="020B0004020202020204" pitchFamily="34" charset="0"/>
+                <a:ea typeface="Aptos" panose="020B0004020202020204" pitchFamily="34" charset="0"/>
+                <a:cs typeface="Aptos" panose="020B0004020202020204" pitchFamily="34" charset="0"/>
+              </a:rPr>
+              <a:t>: </a:t>
+            </a:r>
+            <a:r>
+              <a:rPr lang="he-IL" sz="3200" b="1" dirty="0">
+                <a:solidFill>
+                  <a:srgbClr val="2F5552"/>
+                </a:solidFill>
+                <a:latin typeface="Aptos" panose="020B0004020202020204" pitchFamily="34" charset="0"/>
+                <a:ea typeface="Aptos" panose="020B0004020202020204" pitchFamily="34" charset="0"/>
+                <a:cs typeface="Aptos" panose="020B0004020202020204" pitchFamily="34" charset="0"/>
               </a:rPr>
               <a:t>{SIVUG}</a:t>
             </a:r>
-            <a:endParaRPr sz="3200" b="1" dirty="0">
+            <a:endParaRPr sz="3200" b="1" dirty="0" lang="he-IL">
               <a:solidFill>
                 <a:srgbClr val="2F5552"/>
               </a:solidFill>
               <a:latin typeface="Aptos" panose="020B0004020202020204" pitchFamily="34" charset="0"/>
+              <a:ea typeface="Aptos" panose="020B0004020202020204" pitchFamily="34" charset="0"/>
+              <a:cs typeface="Aptos" panose="020B0004020202020204" pitchFamily="34" charset="0"/>
             </a:endParaRPr>
           </a:p>
         </p:txBody>
@@ -21495,9 +21524,9 @@
                 <a:solidFill>
                   <a:srgbClr val="2F5552"/>
                 </a:solidFill>
-                <a:latin typeface="Aptos" panose="020F0502020204030204" pitchFamily="34" charset="0"/>
-                <a:ea typeface="Calibri" panose="020F0502020204030204" pitchFamily="34" charset="0"/>
-                <a:cs typeface="Calibri" panose="020F0502020204030204" pitchFamily="34" charset="0"/>
+                <a:latin typeface="Aptos" panose="020B0004020202020204" pitchFamily="34" charset="0"/>
+                <a:ea typeface="Aptos" panose="020B0004020202020204" pitchFamily="34" charset="0"/>
+                <a:cs typeface="Aptos" panose="020B0004020202020204" pitchFamily="34" charset="0"/>
               </a:rPr>
               <a:t>בעלות: {OWNERSHIP_TYPE} - {OWNER_DETAILS}</a:t>
             </a:r>
@@ -21558,9 +21587,9 @@
                 <a:solidFill>
                   <a:srgbClr val="FFFFFF"/>
                 </a:solidFill>
-                <a:latin typeface="Aptos" panose="020F0502020204030204" pitchFamily="34" charset="0"/>
-                <a:ea typeface="Calibri" panose="020F0502020204030204" pitchFamily="34" charset="0"/>
-                <a:cs typeface="Calibri" panose="020F0502020204030204" pitchFamily="34" charset="0"/>
+                <a:latin typeface="Aptos" panose="020B0004020202020204" pitchFamily="34" charset="0"/>
+                <a:ea typeface="Aptos" panose="020B0004020202020204" pitchFamily="34" charset="0"/>
+                <a:cs typeface="Aptos" panose="020B0004020202020204" pitchFamily="34" charset="0"/>
               </a:rPr>
               <a:t>{QUARTER}</a:t>
             </a:r>
@@ -21633,9 +21662,9 @@
                           <a:solidFill>
                             <a:srgbClr val="2F5552"/>
                           </a:solidFill>
-                          <a:latin typeface="Aptos" panose="020F0502020204030204" pitchFamily="34" charset="0"/>
-                          <a:ea typeface="Calibri" panose="020F0502020204030204" pitchFamily="34" charset="0"/>
-                          <a:cs typeface="Calibri" panose="020F0502020204030204" pitchFamily="34" charset="0"/>
+                          <a:latin typeface="Aptos" panose="020B0004020202020204" pitchFamily="34" charset="0"/>
+                          <a:ea typeface="Aptos" panose="020B0004020202020204" pitchFamily="34" charset="0"/>
+                          <a:cs typeface="Aptos" panose="020B0004020202020204" pitchFamily="34" charset="0"/>
                         </a:rPr>
                         <a:t>אכיפה פעילה</a:t>
                       </a:r>
@@ -21694,9 +21723,9 @@
                           <a:solidFill>
                             <a:srgbClr val="2F5552"/>
                           </a:solidFill>
-                          <a:latin typeface="Aptos" panose="020F0502020204030204" pitchFamily="34" charset="0"/>
-                          <a:ea typeface="Calibri" panose="020F0502020204030204" pitchFamily="34" charset="0"/>
-                          <a:cs typeface="Calibri" panose="020F0502020204030204" pitchFamily="34" charset="0"/>
+                          <a:latin typeface="Aptos" panose="020B0004020202020204" pitchFamily="34" charset="0"/>
+                          <a:ea typeface="Aptos" panose="020B0004020202020204" pitchFamily="34" charset="0"/>
+                          <a:cs typeface="Aptos" panose="020B0004020202020204" pitchFamily="34" charset="0"/>
                         </a:rPr>
                         <a:t>פיקוח כללי</a:t>
                       </a:r>
@@ -21755,9 +21784,9 @@
                           <a:solidFill>
                             <a:srgbClr val="2F5552"/>
                           </a:solidFill>
-                          <a:latin typeface="Aptos" panose="020F0502020204030204" pitchFamily="34" charset="0"/>
-                          <a:ea typeface="Calibri" panose="020F0502020204030204" pitchFamily="34" charset="0"/>
-                          <a:cs typeface="Calibri" panose="020F0502020204030204" pitchFamily="34" charset="0"/>
+                          <a:latin typeface="Aptos" panose="020B0004020202020204" pitchFamily="34" charset="0"/>
+                          <a:ea typeface="Aptos" panose="020B0004020202020204" pitchFamily="34" charset="0"/>
+                          <a:cs typeface="Aptos" panose="020B0004020202020204" pitchFamily="34" charset="0"/>
                         </a:rPr>
                         <a:t>פיקוח הבניה</a:t>
                       </a:r>
@@ -21816,9 +21845,9 @@
                           <a:solidFill>
                             <a:srgbClr val="2F5552"/>
                           </a:solidFill>
-                          <a:latin typeface="Aptos" panose="020F0502020204030204" pitchFamily="34" charset="0"/>
-                          <a:ea typeface="Calibri" panose="020F0502020204030204" pitchFamily="34" charset="0"/>
-                          <a:cs typeface="Calibri" panose="020F0502020204030204" pitchFamily="34" charset="0"/>
+                          <a:latin typeface="Aptos" panose="020B0004020202020204" pitchFamily="34" charset="0"/>
+                          <a:ea typeface="Aptos" panose="020B0004020202020204" pitchFamily="34" charset="0"/>
+                          <a:cs typeface="Aptos" panose="020B0004020202020204" pitchFamily="34" charset="0"/>
                         </a:rPr>
                         <a:t>צו שיפוץ חזיתות</a:t>
                       </a:r>
@@ -21879,7 +21908,11 @@
                     <a:lstStyle/>
                     <a:p>
                       <a:pPr algn="ctr" rtl="1"/>
-                      <a:endParaRPr lang="he-IL" dirty="0"/>
+                      <a:endParaRPr lang="he-IL" dirty="0">
+                        <a:latin typeface="Aptos" panose="020B0004020202020204" pitchFamily="34" charset="0"/>
+                        <a:ea typeface="Aptos" panose="020B0004020202020204" pitchFamily="34" charset="0"/>
+                        <a:cs typeface="Aptos" panose="020B0004020202020204" pitchFamily="34" charset="0"/>
+                      </a:endParaRPr>
                     </a:p>
                   </a:txBody>
                   <a:tcPr marL="0" marR="0" marT="0" marB="0" anchor="ctr">
@@ -21939,20 +21972,20 @@
                     <a:p>
                       <a:pPr algn="ctr" rtl="1"/>
                       <a:r>
-                        <a:rPr lang="en-US" sz="2400" dirty="0">
+                        <a:rPr lang="he-IL" sz="2400" dirty="0">
                           <a:solidFill>
                             <a:srgbClr val="2F5552"/>
                           </a:solidFill>
-                          <a:latin typeface="Aptos" panose="020F0502020204030204" pitchFamily="34" charset="0"/>
-                          <a:ea typeface="Calibri" panose="020F0502020204030204" pitchFamily="34" charset="0"/>
-                          <a:cs typeface="Calibri" panose="020F0502020204030204" pitchFamily="34" charset="0"/>
+                          <a:latin typeface="Aptos" panose="020B0004020202020204" pitchFamily="34" charset="0"/>
+                          <a:ea typeface="Aptos" panose="020B0004020202020204" pitchFamily="34" charset="0"/>
+                          <a:cs typeface="Aptos" panose="020B0004020202020204" pitchFamily="34" charset="0"/>
                         </a:rPr>
                         <a:t>{PIKUACH_KLALI}</a:t>
                       </a:r>
                       <a:endParaRPr lang="he-IL" sz="2400" dirty="0">
-                        <a:latin typeface="Calibri" panose="020F0502020204030204" pitchFamily="34" charset="0"/>
-                        <a:ea typeface="Calibri" panose="020F0502020204030204" pitchFamily="34" charset="0"/>
-                        <a:cs typeface="Calibri" panose="020F0502020204030204" pitchFamily="34" charset="0"/>
+                        <a:latin typeface="Aptos" panose="020B0004020202020204" pitchFamily="34" charset="0"/>
+                        <a:ea typeface="Aptos" panose="020B0004020202020204" pitchFamily="34" charset="0"/>
+                        <a:cs typeface="Aptos" panose="020B0004020202020204" pitchFamily="34" charset="0"/>
                       </a:endParaRPr>
                     </a:p>
                   </a:txBody>
@@ -22005,13 +22038,13 @@
                     <a:p>
                       <a:pPr algn="ctr" rtl="1"/>
                       <a:r>
-                        <a:rPr lang="en-US" sz="2400" kern="1200" dirty="0">
+                        <a:rPr lang="he-IL" sz="2400" kern="1200" dirty="0">
                           <a:solidFill>
                             <a:srgbClr val="2F5552"/>
                           </a:solidFill>
-                          <a:latin typeface="Aptos" panose="020F0502020204030204" pitchFamily="34" charset="0"/>
-                          <a:ea typeface="Calibri" panose="020F0502020204030204" pitchFamily="34" charset="0"/>
-                          <a:cs typeface="Calibri" panose="020F0502020204030204" pitchFamily="34" charset="0"/>
+                          <a:latin typeface="Aptos" panose="020B0004020202020204" pitchFamily="34" charset="0"/>
+                          <a:ea typeface="Aptos" panose="020B0004020202020204" pitchFamily="34" charset="0"/>
+                          <a:cs typeface="Aptos" panose="020B0004020202020204" pitchFamily="34" charset="0"/>
                         </a:rPr>
                         <a:t>{PIKUACH_AL_BNIYA}</a:t>
                       </a:r>
@@ -22019,9 +22052,9 @@
                         <a:solidFill>
                           <a:schemeClr val="tx1"/>
                         </a:solidFill>
-                        <a:latin typeface="Calibri" panose="020F0502020204030204" pitchFamily="34" charset="0"/>
-                        <a:ea typeface="Calibri" panose="020F0502020204030204" pitchFamily="34" charset="0"/>
-                        <a:cs typeface="Calibri" panose="020F0502020204030204" pitchFamily="34" charset="0"/>
+                        <a:latin typeface="Aptos" panose="020B0004020202020204" pitchFamily="34" charset="0"/>
+                        <a:ea typeface="Aptos" panose="020B0004020202020204" pitchFamily="34" charset="0"/>
+                        <a:cs typeface="Aptos" panose="020B0004020202020204" pitchFamily="34" charset="0"/>
                       </a:endParaRPr>
                     </a:p>
                   </a:txBody>
@@ -22074,13 +22107,13 @@
                     <a:p>
                       <a:pPr algn="ctr" rtl="1"/>
                       <a:r>
-                        <a:rPr lang="en-US" sz="2400" kern="1200" dirty="0">
+                        <a:rPr lang="he-IL" sz="2400" kern="1200" dirty="0">
                           <a:solidFill>
                             <a:srgbClr val="2F5552"/>
                           </a:solidFill>
-                          <a:latin typeface="Aptos" panose="020F0502020204030204" pitchFamily="34" charset="0"/>
-                          <a:ea typeface="Calibri" panose="020F0502020204030204" pitchFamily="34" charset="0"/>
-                          <a:cs typeface="Calibri" panose="020F0502020204030204" pitchFamily="34" charset="0"/>
+                          <a:latin typeface="Aptos" panose="020B0004020202020204" pitchFamily="34" charset="0"/>
+                          <a:ea typeface="Aptos" panose="020B0004020202020204" pitchFamily="34" charset="0"/>
+                          <a:cs typeface="Aptos" panose="020B0004020202020204" pitchFamily="34" charset="0"/>
                         </a:rPr>
                         <a:t>{TZAV_SHIPUTZ_FRONTS}</a:t>
                       </a:r>
@@ -22088,9 +22121,9 @@
                         <a:solidFill>
                           <a:schemeClr val="tx1"/>
                         </a:solidFill>
-                        <a:latin typeface="Calibri" panose="020F0502020204030204" pitchFamily="34" charset="0"/>
-                        <a:ea typeface="Calibri" panose="020F0502020204030204" pitchFamily="34" charset="0"/>
-                        <a:cs typeface="Calibri" panose="020F0502020204030204" pitchFamily="34" charset="0"/>
+                        <a:latin typeface="Aptos" panose="020B0004020202020204" pitchFamily="34" charset="0"/>
+                        <a:ea typeface="Aptos" panose="020B0004020202020204" pitchFamily="34" charset="0"/>
+                        <a:cs typeface="Aptos" panose="020B0004020202020204" pitchFamily="34" charset="0"/>
                       </a:endParaRPr>
                     </a:p>
                   </a:txBody>
@@ -22181,11 +22214,13 @@
           <a:p>
             <a:pPr algn="ctr" rtl="1"/>
             <a:r>
-              <a:rPr sz="3200" b="1">
+              <a:rPr sz="3200" b="1" lang="he-IL">
                 <a:solidFill>
                   <a:srgbClr val="2F5552"/>
                 </a:solidFill>
-                <a:latin typeface="Aptos"/>
+                <a:latin typeface="Aptos" panose="020B0004020202020204" pitchFamily="34" charset="0"/>
+                <a:ea typeface="Aptos" panose="020B0004020202020204" pitchFamily="34" charset="0"/>
+                <a:cs typeface="Aptos" panose="020B0004020202020204" pitchFamily="34" charset="0"/>
               </a:rPr>
               <a:t>תכנון</a:t>
             </a:r>
@@ -22193,11 +22228,13 @@
           <a:p>
             <a:pPr algn="ctr"/>
             <a:r>
-              <a:rPr sz="1400" b="0">
+              <a:rPr sz="1400" b="0" lang="he-IL">
                 <a:solidFill>
                   <a:srgbClr val="2F5552"/>
                 </a:solidFill>
-                <a:latin typeface="Aptos"/>
+                <a:latin typeface="Aptos" panose="020B0004020202020204" pitchFamily="34" charset="0"/>
+                <a:ea typeface="Aptos" panose="020B0004020202020204" pitchFamily="34" charset="0"/>
+                <a:cs typeface="Aptos" panose="020B0004020202020204" pitchFamily="34" charset="0"/>
               </a:rPr>
               <a:t>{KIDUM_TICHNUN}</a:t>
             </a:r>
@@ -22239,23 +22276,35 @@
           <a:p>
             <a:pPr algn="ctr" rtl="1"/>
             <a:r>
-              <a:rPr sz="3200" b="1">
+              <a:rPr sz="3200" b="1" dirty="0" err="1" lang="he-IL">
                 <a:solidFill>
                   <a:srgbClr val="2F5552"/>
                 </a:solidFill>
-                <a:latin typeface="Aptos"/>
+                <a:latin typeface="Aptos" panose="020B0004020202020204" pitchFamily="34" charset="0"/>
+                <a:ea typeface="Aptos" panose="020B0004020202020204" pitchFamily="34" charset="0"/>
+                <a:cs typeface="Aptos" panose="020B0004020202020204" pitchFamily="34" charset="0"/>
               </a:rPr>
               <a:t>שימור</a:t>
             </a:r>
+            <a:endParaRPr sz="3200" b="1" dirty="0" lang="he-IL">
+              <a:solidFill>
+                <a:srgbClr val="2F5552"/>
+              </a:solidFill>
+              <a:latin typeface="Aptos" panose="020B0004020202020204" pitchFamily="34" charset="0"/>
+              <a:ea typeface="Aptos" panose="020B0004020202020204" pitchFamily="34" charset="0"/>
+              <a:cs typeface="Aptos" panose="020B0004020202020204" pitchFamily="34" charset="0"/>
+            </a:endParaRPr>
           </a:p>
           <a:p>
             <a:pPr algn="ctr"/>
             <a:r>
-              <a:rPr sz="1400" b="0">
+              <a:rPr sz="1400" b="0" dirty="0" lang="he-IL">
                 <a:solidFill>
                   <a:srgbClr val="2F5552"/>
                 </a:solidFill>
-                <a:latin typeface="Aptos"/>
+                <a:latin typeface="Aptos" panose="020B0004020202020204" pitchFamily="34" charset="0"/>
+                <a:ea typeface="Aptos" panose="020B0004020202020204" pitchFamily="34" charset="0"/>
+                <a:cs typeface="Aptos" panose="020B0004020202020204" pitchFamily="34" charset="0"/>
               </a:rPr>
               <a:t>{SHIMUR_YEUD}</a:t>
             </a:r>
@@ -22297,11 +22346,13 @@
           <a:p>
             <a:pPr algn="ctr" rtl="1"/>
             <a:r>
-              <a:rPr sz="3200" b="1">
+              <a:rPr sz="3200" b="1" lang="he-IL">
                 <a:solidFill>
                   <a:srgbClr val="2F5552"/>
                 </a:solidFill>
-                <a:latin typeface="Aptos"/>
+                <a:latin typeface="Aptos" panose="020B0004020202020204" pitchFamily="34" charset="0"/>
+                <a:ea typeface="Aptos" panose="020B0004020202020204" pitchFamily="34" charset="0"/>
+                <a:cs typeface="Aptos" panose="020B0004020202020204" pitchFamily="34" charset="0"/>
               </a:rPr>
               <a:t>רישוי</a:t>
             </a:r>
@@ -22309,11 +22360,13 @@
           <a:p>
             <a:pPr algn="ctr"/>
             <a:r>
-              <a:rPr sz="1400" b="0">
+              <a:rPr sz="1400" b="0" lang="he-IL">
                 <a:solidFill>
                   <a:srgbClr val="2F5552"/>
                 </a:solidFill>
-                <a:latin typeface="Aptos"/>
+                <a:latin typeface="Aptos" panose="020B0004020202020204" pitchFamily="34" charset="0"/>
+                <a:ea typeface="Aptos" panose="020B0004020202020204" pitchFamily="34" charset="0"/>
+                <a:cs typeface="Aptos" panose="020B0004020202020204" pitchFamily="34" charset="0"/>
               </a:rPr>
               <a:t>{BUILDING_PERMIT}</a:t>
             </a:r>
@@ -22373,9 +22426,9 @@
               <a:solidFill>
                 <a:schemeClr val="tx1"/>
               </a:solidFill>
-              <a:latin typeface="Calibri" panose="020F0502020204030204" pitchFamily="34" charset="0"/>
-              <a:ea typeface="Calibri" panose="020F0502020204030204" pitchFamily="34" charset="0"/>
-              <a:cs typeface="Calibri" panose="020F0502020204030204" pitchFamily="34" charset="0"/>
+              <a:latin typeface="Aptos" panose="020B0004020202020204" pitchFamily="34" charset="0"/>
+              <a:ea typeface="Aptos" panose="020B0004020202020204" pitchFamily="34" charset="0"/>
+              <a:cs typeface="Aptos" panose="020B0004020202020204" pitchFamily="34" charset="0"/>
             </a:endParaRPr>
           </a:p>
         </p:txBody>
@@ -22408,9 +22461,9 @@
                 <a:solidFill>
                   <a:srgbClr val="FFFFFF"/>
                 </a:solidFill>
-                <a:latin typeface="Aptos" panose="020F0502020204030204" pitchFamily="34" charset="0"/>
-                <a:ea typeface="Calibri" panose="020F0502020204030204" pitchFamily="34" charset="0"/>
-                <a:cs typeface="Calibri" panose="020F0502020204030204" pitchFamily="34" charset="0"/>
+                <a:latin typeface="Aptos" panose="020B0004020202020204" pitchFamily="34" charset="0"/>
+                <a:ea typeface="Aptos" panose="020B0004020202020204" pitchFamily="34" charset="0"/>
+                <a:cs typeface="Aptos" panose="020B0004020202020204" pitchFamily="34" charset="0"/>
               </a:rPr>
               <a:t>{BUILT_AREA_SQM}</a:t>
             </a:r>
@@ -22422,9 +22475,9 @@
                 <a:solidFill>
                   <a:srgbClr val="FFFFFF"/>
                 </a:solidFill>
-                <a:latin typeface="Aptos" panose="020F0502020204030204" pitchFamily="34" charset="0"/>
-                <a:ea typeface="Calibri" panose="020F0502020204030204" pitchFamily="34" charset="0"/>
-                <a:cs typeface="Calibri" panose="020F0502020204030204" pitchFamily="34" charset="0"/>
+                <a:latin typeface="Aptos" panose="020B0004020202020204" pitchFamily="34" charset="0"/>
+                <a:ea typeface="Aptos" panose="020B0004020202020204" pitchFamily="34" charset="0"/>
+                <a:cs typeface="Aptos" panose="020B0004020202020204" pitchFamily="34" charset="0"/>
               </a:rPr>
               <a:t>מ"ר בנוי</a:t>
             </a:r>
@@ -22484,9 +22537,9 @@
               <a:solidFill>
                 <a:schemeClr val="tx1"/>
               </a:solidFill>
-              <a:latin typeface="Calibri" panose="020F0502020204030204" pitchFamily="34" charset="0"/>
-              <a:ea typeface="Calibri" panose="020F0502020204030204" pitchFamily="34" charset="0"/>
-              <a:cs typeface="Calibri" panose="020F0502020204030204" pitchFamily="34" charset="0"/>
+              <a:latin typeface="Aptos" panose="020B0004020202020204" pitchFamily="34" charset="0"/>
+              <a:ea typeface="Aptos" panose="020B0004020202020204" pitchFamily="34" charset="0"/>
+              <a:cs typeface="Aptos" panose="020B0004020202020204" pitchFamily="34" charset="0"/>
             </a:endParaRPr>
           </a:p>
         </p:txBody>
@@ -22519,9 +22572,9 @@
                 <a:solidFill>
                   <a:srgbClr val="FFFFFF"/>
                 </a:solidFill>
-                <a:latin typeface="Aptos" panose="020F0502020204030204" pitchFamily="34" charset="0"/>
-                <a:ea typeface="Calibri" panose="020F0502020204030204" pitchFamily="34" charset="0"/>
-                <a:cs typeface="Calibri" panose="020F0502020204030204" pitchFamily="34" charset="0"/>
+                <a:latin typeface="Aptos" panose="020B0004020202020204" pitchFamily="34" charset="0"/>
+                <a:ea typeface="Aptos" panose="020B0004020202020204" pitchFamily="34" charset="0"/>
+                <a:cs typeface="Aptos" panose="020B0004020202020204" pitchFamily="34" charset="0"/>
               </a:rPr>
               <a:t>{DAMAGE_PERCENT}</a:t>
             </a:r>
@@ -22533,9 +22586,9 @@
                 <a:solidFill>
                   <a:srgbClr val="FFFFFF"/>
                 </a:solidFill>
-                <a:latin typeface="Aptos" panose="020F0502020204030204" pitchFamily="34" charset="0"/>
-                <a:ea typeface="Calibri" panose="020F0502020204030204" pitchFamily="34" charset="0"/>
-                <a:cs typeface="Calibri" panose="020F0502020204030204" pitchFamily="34" charset="0"/>
+                <a:latin typeface="Aptos" panose="020B0004020202020204" pitchFamily="34" charset="0"/>
+                <a:ea typeface="Aptos" panose="020B0004020202020204" pitchFamily="34" charset="0"/>
+                <a:cs typeface="Aptos" panose="020B0004020202020204" pitchFamily="34" charset="0"/>
               </a:rPr>
               <a:t>ניזוק פטור</a:t>
             </a:r>
@@ -22613,11 +22666,13 @@
           <a:p>
             <a:pPr algn="ctr" rtl="1"/>
             <a:r>
-              <a:rPr sz="2200" b="1">
+              <a:rPr sz="2200" b="1" lang="he-IL">
                 <a:solidFill>
                   <a:srgbClr val="2F5552"/>
                 </a:solidFill>
-                <a:latin typeface="Aptos"/>
+                <a:latin typeface="Aptos" panose="020B0004020202020204" pitchFamily="34" charset="0"/>
+                <a:ea typeface="Aptos" panose="020B0004020202020204" pitchFamily="34" charset="0"/>
+                <a:cs typeface="Aptos" panose="020B0004020202020204" pitchFamily="34" charset="0"/>
               </a:rPr>
               <a:t>עמדת העירייה</a:t>
             </a:r>
@@ -22625,11 +22680,13 @@
           <a:p>
             <a:pPr algn="ctr"/>
             <a:r>
-              <a:rPr sz="2000" b="1">
+              <a:rPr sz="2000" b="1" lang="he-IL">
                 <a:solidFill>
                   <a:srgbClr val="2F5552"/>
                 </a:solidFill>
-                <a:latin typeface="Aptos"/>
+                <a:latin typeface="Aptos" panose="020B0004020202020204" pitchFamily="34" charset="0"/>
+                <a:ea typeface="Aptos" panose="020B0004020202020204" pitchFamily="34" charset="0"/>
+                <a:cs typeface="Aptos" panose="020B0004020202020204" pitchFamily="34" charset="0"/>
               </a:rPr>
               <a:t>{MUNI_POSITION}</a:t>
             </a:r>
@@ -22671,11 +22728,13 @@
           <a:p>
             <a:pPr algn="ctr" rtl="1"/>
             <a:r>
-              <a:rPr sz="2200" b="1">
+              <a:rPr sz="2200" b="1" lang="he-IL">
                 <a:solidFill>
                   <a:srgbClr val="2F5552"/>
                 </a:solidFill>
-                <a:latin typeface="Aptos"/>
+                <a:latin typeface="Aptos" panose="020B0004020202020204" pitchFamily="34" charset="0"/>
+                <a:ea typeface="Aptos" panose="020B0004020202020204" pitchFamily="34" charset="0"/>
+                <a:cs typeface="Aptos" panose="020B0004020202020204" pitchFamily="34" charset="0"/>
               </a:rPr>
               <a:t>עמדת הבעלים</a:t>
             </a:r>
@@ -22683,11 +22742,13 @@
           <a:p>
             <a:pPr algn="ctr"/>
             <a:r>
-              <a:rPr sz="2000" b="1">
+              <a:rPr sz="2000" b="1" lang="he-IL">
                 <a:solidFill>
                   <a:srgbClr val="2F5552"/>
                 </a:solidFill>
-                <a:latin typeface="Aptos"/>
+                <a:latin typeface="Aptos" panose="020B0004020202020204" pitchFamily="34" charset="0"/>
+                <a:ea typeface="Aptos" panose="020B0004020202020204" pitchFamily="34" charset="0"/>
+                <a:cs typeface="Aptos" panose="020B0004020202020204" pitchFamily="34" charset="0"/>
               </a:rPr>
               <a:t>{OWNER_POSITION}</a:t>
             </a:r>

</xml_diff>